<commit_message>
Adiciona as três telas do organizador e atualiza o deck
</commit_message>
<xml_diff>
--- a/docs/slides/BilhetePass-apresentacao.pptx
+++ b/docs/slides/BilhetePass-apresentacao.pptx
@@ -3599,7 +3599,7 @@
         <p:spPr>
           <a:xfrm>
             <a:off x="7406640" y="2194560"/>
-            <a:ext cx="4206240" cy="1645920"/>
+            <a:ext cx="4206240" cy="1737360"/>
           </a:xfrm>
           <a:prstGeom prst="rect">
             <a:avLst/>
@@ -3784,7 +3784,7 @@
               </a:spcAft>
             </a:pPr>
             <a:r>
-              <a:rPr sz="1250" b="0">
+              <a:rPr sz="1200" b="0">
                 <a:solidFill>
                   <a:srgbClr val="1A1B2E"/>
                 </a:solidFill>
@@ -4046,7 +4046,7 @@
         <p:spPr>
           <a:xfrm>
             <a:off x="7406640" y="2194560"/>
-            <a:ext cx="4206240" cy="1645920"/>
+            <a:ext cx="4206240" cy="1737360"/>
           </a:xfrm>
           <a:prstGeom prst="rect">
             <a:avLst/>
@@ -4231,7 +4231,7 @@
               </a:spcAft>
             </a:pPr>
             <a:r>
-              <a:rPr sz="1250" b="0">
+              <a:rPr sz="1200" b="0">
                 <a:solidFill>
                   <a:srgbClr val="1A1B2E"/>
                 </a:solidFill>
@@ -4568,7 +4568,7 @@
         <p:spPr>
           <a:xfrm>
             <a:off x="7406640" y="2194560"/>
-            <a:ext cx="4206240" cy="1645920"/>
+            <a:ext cx="4206240" cy="1737360"/>
           </a:xfrm>
           <a:prstGeom prst="rect">
             <a:avLst/>
@@ -4753,7 +4753,7 @@
               </a:spcAft>
             </a:pPr>
             <a:r>
-              <a:rPr sz="1250" b="0">
+              <a:rPr sz="1200" b="0">
                 <a:solidFill>
                   <a:srgbClr val="1A1B2E"/>
                 </a:solidFill>
@@ -5015,7 +5015,7 @@
         <p:spPr>
           <a:xfrm>
             <a:off x="7406640" y="2194560"/>
-            <a:ext cx="4206240" cy="1645920"/>
+            <a:ext cx="4206240" cy="1737360"/>
           </a:xfrm>
           <a:prstGeom prst="rect">
             <a:avLst/>
@@ -5200,7 +5200,7 @@
               </a:spcAft>
             </a:pPr>
             <a:r>
-              <a:rPr sz="1250" b="0">
+              <a:rPr sz="1200" b="0">
                 <a:solidFill>
                   <a:srgbClr val="1A1B2E"/>
                 </a:solidFill>
@@ -5486,7 +5486,7 @@
         <p:spPr>
           <a:xfrm>
             <a:off x="7406640" y="2194560"/>
-            <a:ext cx="4206240" cy="1645920"/>
+            <a:ext cx="4206240" cy="1737360"/>
           </a:xfrm>
           <a:prstGeom prst="rect">
             <a:avLst/>
@@ -5671,7 +5671,7 @@
               </a:spcAft>
             </a:pPr>
             <a:r>
-              <a:rPr sz="1250" b="0">
+              <a:rPr sz="1200" b="0">
                 <a:solidFill>
                   <a:srgbClr val="1A1B2E"/>
                 </a:solidFill>
@@ -7688,60 +7688,64 @@
           </a:p>
         </p:txBody>
       </p:sp>
-      <p:sp>
-        <p:nvSpPr>
-          <p:cNvPr id="6" name="Rectangle 5"/>
-          <p:cNvSpPr/>
-          <p:nvPr/>
-        </p:nvSpPr>
-        <p:spPr>
-          <a:xfrm>
-            <a:off x="548640" y="1600200"/>
-            <a:ext cx="6446520" cy="4572000"/>
-          </a:xfrm>
-          <a:prstGeom prst="rect">
-            <a:avLst/>
-          </a:prstGeom>
-          <a:solidFill>
-            <a:srgbClr val="F7F8FC"/>
-          </a:solidFill>
-          <a:ln>
-            <a:noFill/>
-          </a:ln>
-          <a:effectLst/>
-        </p:spPr>
-        <p:style>
-          <a:lnRef idx="1">
-            <a:schemeClr val="accent1"/>
-          </a:lnRef>
-          <a:fillRef idx="3">
-            <a:schemeClr val="accent1"/>
-          </a:fillRef>
-          <a:effectRef idx="2">
-            <a:schemeClr val="accent1"/>
-          </a:effectRef>
-          <a:fontRef idx="minor">
-            <a:schemeClr val="lt1"/>
-          </a:fontRef>
-        </p:style>
-        <p:txBody>
-          <a:bodyPr rtlCol="0" anchor="ctr"/>
-          <a:lstStyle/>
-          <a:p>
-            <a:pPr algn="ctr"/>
-          </a:p>
-        </p:txBody>
-      </p:sp>
-      <p:sp>
-        <p:nvSpPr>
-          <p:cNvPr id="7" name="TextBox 6"/>
+      <p:pic>
+        <p:nvPicPr>
+          <p:cNvPr id="6" name="Picture 5" descr="criacao-de-evento.png"/>
+          <p:cNvPicPr>
+            <a:picLocks noChangeAspect="1"/>
+          </p:cNvPicPr>
+          <p:nvPr/>
+        </p:nvPicPr>
+        <p:blipFill>
+          <a:blip r:embed="rId2"/>
+          <a:stretch>
+            <a:fillRect/>
+          </a:stretch>
+        </p:blipFill>
+        <p:spPr>
+          <a:xfrm>
+            <a:off x="548640" y="2582164"/>
+            <a:ext cx="3108960" cy="2608072"/>
+          </a:xfrm>
+          <a:prstGeom prst="rect">
+            <a:avLst/>
+          </a:prstGeom>
+        </p:spPr>
+      </p:pic>
+      <p:pic>
+        <p:nvPicPr>
+          <p:cNvPr id="7" name="Picture 6" descr="configuracao-de-ingressos.png"/>
+          <p:cNvPicPr>
+            <a:picLocks noChangeAspect="1"/>
+          </p:cNvPicPr>
+          <p:nvPr/>
+        </p:nvPicPr>
+        <p:blipFill>
+          <a:blip r:embed="rId3"/>
+          <a:stretch>
+            <a:fillRect/>
+          </a:stretch>
+        </p:blipFill>
+        <p:spPr>
+          <a:xfrm>
+            <a:off x="3886200" y="2071560"/>
+            <a:ext cx="3108960" cy="3629279"/>
+          </a:xfrm>
+          <a:prstGeom prst="rect">
+            <a:avLst/>
+          </a:prstGeom>
+        </p:spPr>
+      </p:pic>
+      <p:sp>
+        <p:nvSpPr>
+          <p:cNvPr id="8" name="TextBox 7"/>
           <p:cNvSpPr txBox="1"/>
           <p:nvPr/>
         </p:nvSpPr>
         <p:spPr>
           <a:xfrm>
-            <a:off x="1005840" y="3566160"/>
-            <a:ext cx="5532120" cy="731520"/>
+            <a:off x="7406640" y="1737360"/>
+            <a:ext cx="4206240" cy="274320"/>
           </a:xfrm>
           <a:prstGeom prst="rect">
             <a:avLst/>
@@ -7754,49 +7758,33 @@
           </a:bodyPr>
           <a:lstStyle/>
           <a:p>
-            <a:pPr algn="ctr">
-              <a:spcAft>
-                <a:spcPts val="600"/>
-              </a:spcAft>
-            </a:pPr>
-            <a:r>
-              <a:rPr sz="1900" b="1">
-                <a:solidFill>
-                  <a:srgbClr val="9E520A"/>
-                </a:solidFill>
-                <a:latin typeface="Inter"/>
-              </a:rPr>
-              <a:t>Sem protótipo</a:t>
-            </a:r>
-          </a:p>
-          <a:p>
-            <a:pPr algn="ctr">
-              <a:spcAft>
-                <a:spcPts val="600"/>
-              </a:spcAft>
-            </a:pPr>
-            <a:r>
-              <a:rPr sz="1900" b="1">
-                <a:solidFill>
-                  <a:srgbClr val="9E520A"/>
-                </a:solidFill>
-                <a:latin typeface="Inter"/>
-              </a:rPr>
-              <a:t>Release 2 — está mapeada</a:t>
-            </a:r>
-          </a:p>
-        </p:txBody>
-      </p:sp>
-      <p:sp>
-        <p:nvSpPr>
-          <p:cNvPr id="8" name="TextBox 7"/>
+            <a:pPr algn="l">
+              <a:spcAft>
+                <a:spcPts val="0"/>
+              </a:spcAft>
+            </a:pPr>
+            <a:r>
+              <a:rPr sz="1200" b="1">
+                <a:solidFill>
+                  <a:srgbClr val="5A5C73"/>
+                </a:solidFill>
+                <a:latin typeface="Inter"/>
+              </a:rPr>
+              <a:t>O QUE MOSTRAR NA TELA</a:t>
+            </a:r>
+          </a:p>
+        </p:txBody>
+      </p:sp>
+      <p:sp>
+        <p:nvSpPr>
+          <p:cNvPr id="9" name="TextBox 8"/>
           <p:cNvSpPr txBox="1"/>
           <p:nvPr/>
         </p:nvSpPr>
         <p:spPr>
           <a:xfrm>
-            <a:off x="7406640" y="1737360"/>
-            <a:ext cx="4206240" cy="274320"/>
+            <a:off x="7406640" y="2194560"/>
+            <a:ext cx="4206240" cy="1737360"/>
           </a:xfrm>
           <a:prstGeom prst="rect">
             <a:avLst/>
@@ -7815,52 +7803,13 @@
               </a:spcAft>
             </a:pPr>
             <a:r>
-              <a:rPr sz="1200" b="1">
-                <a:solidFill>
-                  <a:srgbClr val="5A5C73"/>
-                </a:solidFill>
-                <a:latin typeface="Inter"/>
-              </a:rPr>
-              <a:t>O QUE MOSTRAR NA TELA</a:t>
-            </a:r>
-          </a:p>
-        </p:txBody>
-      </p:sp>
-      <p:sp>
-        <p:nvSpPr>
-          <p:cNvPr id="9" name="TextBox 8"/>
-          <p:cNvSpPr txBox="1"/>
-          <p:nvPr/>
-        </p:nvSpPr>
-        <p:spPr>
-          <a:xfrm>
-            <a:off x="7406640" y="2194560"/>
-            <a:ext cx="4206240" cy="1645920"/>
-          </a:xfrm>
-          <a:prstGeom prst="rect">
-            <a:avLst/>
-          </a:prstGeom>
-          <a:noFill/>
-        </p:spPr>
-        <p:txBody>
-          <a:bodyPr wrap="square" lIns="0" rIns="0" tIns="0" bIns="0">
-            <a:spAutoFit/>
-          </a:bodyPr>
-          <a:lstStyle/>
-          <a:p>
-            <a:pPr algn="l">
-              <a:spcAft>
-                <a:spcPts val="0"/>
-              </a:spcAft>
-            </a:pPr>
-            <a:r>
               <a:rPr sz="1400" b="0">
                 <a:solidFill>
                   <a:srgbClr val="1A1B2E"/>
                 </a:solidFill>
                 <a:latin typeface="Inter"/>
               </a:rPr>
-              <a:t>Os três lotes com situações diferentes — Encerrado, Vigente, Agendado — e o erro “não pode ser menor que os 248 ingressos já vendidos”.</a:t>
+              <a:t>No Resumo: “Capacidade dos lotes (1.950) excede a do local (1.800)” e o botão Publicar desabilitado. Na configuração: os três lotes Encerrado, Vigente e Agendado, e o erro dos 248 já vendidos.</a:t>
             </a:r>
           </a:p>
         </p:txBody>
@@ -8020,13 +7969,13 @@
               </a:spcAft>
             </a:pPr>
             <a:r>
-              <a:rPr sz="1250" b="0">
+              <a:rPr sz="1200" b="0">
                 <a:solidFill>
                   <a:srgbClr val="1A1B2E"/>
                 </a:solidFill>
                 <a:latin typeface="Inter"/>
               </a:rPr>
-              <a:t>Criar um lote exige VALIDAR que sua vigência não se sobrepõe à dos outros lotes do mesmo tipo, e CONSULTAR a quantidade já vendida antes de permitir reduzir a capacidade.</a:t>
+              <a:t>Publicar exige CALCULAR a soma das capacidades de todos os lotes e VALIDAR contra a capacidade do local; criar um lote exige VALIDAR que sua vigência não se sobrepõe às outras e CONSULTAR quantos já foram vendidos.</a:t>
             </a:r>
           </a:p>
         </p:txBody>
@@ -8210,50 +8159,30 @@
           </a:p>
         </p:txBody>
       </p:sp>
-      <p:sp>
-        <p:nvSpPr>
-          <p:cNvPr id="6" name="Rectangle 5"/>
-          <p:cNvSpPr/>
-          <p:nvPr/>
-        </p:nvSpPr>
-        <p:spPr>
-          <a:xfrm>
-            <a:off x="548640" y="1600200"/>
-            <a:ext cx="6446520" cy="4572000"/>
-          </a:xfrm>
-          <a:prstGeom prst="rect">
-            <a:avLst/>
-          </a:prstGeom>
-          <a:solidFill>
-            <a:srgbClr val="F7F8FC"/>
-          </a:solidFill>
-          <a:ln>
-            <a:noFill/>
-          </a:ln>
-          <a:effectLst/>
-        </p:spPr>
-        <p:style>
-          <a:lnRef idx="1">
-            <a:schemeClr val="accent1"/>
-          </a:lnRef>
-          <a:fillRef idx="3">
-            <a:schemeClr val="accent1"/>
-          </a:fillRef>
-          <a:effectRef idx="2">
-            <a:schemeClr val="accent1"/>
-          </a:effectRef>
-          <a:fontRef idx="minor">
-            <a:schemeClr val="lt1"/>
-          </a:fontRef>
-        </p:style>
-        <p:txBody>
-          <a:bodyPr rtlCol="0" anchor="ctr"/>
-          <a:lstStyle/>
-          <a:p>
-            <a:pPr algn="ctr"/>
-          </a:p>
-        </p:txBody>
-      </p:sp>
+      <p:pic>
+        <p:nvPicPr>
+          <p:cNvPr id="6" name="Picture 5" descr="gerenciar-cupons.png"/>
+          <p:cNvPicPr>
+            <a:picLocks noChangeAspect="1"/>
+          </p:cNvPicPr>
+          <p:nvPr/>
+        </p:nvPicPr>
+        <p:blipFill>
+          <a:blip r:embed="rId2"/>
+          <a:stretch>
+            <a:fillRect/>
+          </a:stretch>
+        </p:blipFill>
+        <p:spPr>
+          <a:xfrm>
+            <a:off x="998656" y="1600200"/>
+            <a:ext cx="5546486" cy="4572000"/>
+          </a:xfrm>
+          <a:prstGeom prst="rect">
+            <a:avLst/>
+          </a:prstGeom>
+        </p:spPr>
+      </p:pic>
       <p:sp>
         <p:nvSpPr>
           <p:cNvPr id="7" name="TextBox 6"/>
@@ -8262,8 +8191,8 @@
         </p:nvSpPr>
         <p:spPr>
           <a:xfrm>
-            <a:off x="1005840" y="3566160"/>
-            <a:ext cx="5532120" cy="731520"/>
+            <a:off x="7406640" y="1737360"/>
+            <a:ext cx="4206240" cy="274320"/>
           </a:xfrm>
           <a:prstGeom prst="rect">
             <a:avLst/>
@@ -8276,35 +8205,19 @@
           </a:bodyPr>
           <a:lstStyle/>
           <a:p>
-            <a:pPr algn="ctr">
-              <a:spcAft>
-                <a:spcPts val="600"/>
-              </a:spcAft>
-            </a:pPr>
-            <a:r>
-              <a:rPr sz="1900" b="1">
-                <a:solidFill>
-                  <a:srgbClr val="9E520A"/>
-                </a:solidFill>
-                <a:latin typeface="Inter"/>
-              </a:rPr>
-              <a:t>Sem protótipo</a:t>
-            </a:r>
-          </a:p>
-          <a:p>
-            <a:pPr algn="ctr">
-              <a:spcAft>
-                <a:spcPts val="600"/>
-              </a:spcAft>
-            </a:pPr>
-            <a:r>
-              <a:rPr sz="1900" b="1">
-                <a:solidFill>
-                  <a:srgbClr val="9E520A"/>
-                </a:solidFill>
-                <a:latin typeface="Inter"/>
-              </a:rPr>
-              <a:t>Release 2 — está mapeada</a:t>
+            <a:pPr algn="l">
+              <a:spcAft>
+                <a:spcPts val="0"/>
+              </a:spcAft>
+            </a:pPr>
+            <a:r>
+              <a:rPr sz="1200" b="1">
+                <a:solidFill>
+                  <a:srgbClr val="5A5C73"/>
+                </a:solidFill>
+                <a:latin typeface="Inter"/>
+              </a:rPr>
+              <a:t>O QUE MOSTRAR NA TELA</a:t>
             </a:r>
           </a:p>
         </p:txBody>
@@ -8317,8 +8230,8 @@
         </p:nvSpPr>
         <p:spPr>
           <a:xfrm>
-            <a:off x="7406640" y="1737360"/>
-            <a:ext cx="4206240" cy="274320"/>
+            <a:off x="7406640" y="2194560"/>
+            <a:ext cx="4206240" cy="1737360"/>
           </a:xfrm>
           <a:prstGeom prst="rect">
             <a:avLst/>
@@ -8337,45 +8250,6 @@
               </a:spcAft>
             </a:pPr>
             <a:r>
-              <a:rPr sz="1200" b="1">
-                <a:solidFill>
-                  <a:srgbClr val="5A5C73"/>
-                </a:solidFill>
-                <a:latin typeface="Inter"/>
-              </a:rPr>
-              <a:t>O QUE MOSTRAR NA TELA</a:t>
-            </a:r>
-          </a:p>
-        </p:txBody>
-      </p:sp>
-      <p:sp>
-        <p:nvSpPr>
-          <p:cNvPr id="9" name="TextBox 8"/>
-          <p:cNvSpPr txBox="1"/>
-          <p:nvPr/>
-        </p:nvSpPr>
-        <p:spPr>
-          <a:xfrm>
-            <a:off x="7406640" y="2194560"/>
-            <a:ext cx="4206240" cy="1645920"/>
-          </a:xfrm>
-          <a:prstGeom prst="rect">
-            <a:avLst/>
-          </a:prstGeom>
-          <a:noFill/>
-        </p:spPr>
-        <p:txBody>
-          <a:bodyPr wrap="square" lIns="0" rIns="0" tIns="0" bIns="0">
-            <a:spAutoFit/>
-          </a:bodyPr>
-          <a:lstStyle/>
-          <a:p>
-            <a:pPr algn="l">
-              <a:spcAft>
-                <a:spcPts val="0"/>
-              </a:spcAft>
-            </a:pPr>
-            <a:r>
               <a:rPr sz="1400" b="0">
                 <a:solidFill>
                   <a:srgbClr val="1A1B2E"/>
@@ -8389,7 +8263,7 @@
       </p:sp>
       <p:sp>
         <p:nvSpPr>
-          <p:cNvPr id="10" name="Rectangle 9"/>
+          <p:cNvPr id="9" name="Rectangle 8"/>
           <p:cNvSpPr/>
           <p:nvPr/>
         </p:nvSpPr>
@@ -8433,7 +8307,7 @@
       </p:sp>
       <p:sp>
         <p:nvSpPr>
-          <p:cNvPr id="11" name="Rectangle 10"/>
+          <p:cNvPr id="10" name="Rectangle 9"/>
           <p:cNvSpPr/>
           <p:nvPr/>
         </p:nvSpPr>
@@ -8477,14 +8351,53 @@
       </p:sp>
       <p:sp>
         <p:nvSpPr>
+          <p:cNvPr id="11" name="TextBox 10"/>
+          <p:cNvSpPr txBox="1"/>
+          <p:nvPr/>
+        </p:nvSpPr>
+        <p:spPr>
+          <a:xfrm>
+            <a:off x="7680960" y="4389120"/>
+            <a:ext cx="3749039" cy="274320"/>
+          </a:xfrm>
+          <a:prstGeom prst="rect">
+            <a:avLst/>
+          </a:prstGeom>
+          <a:noFill/>
+        </p:spPr>
+        <p:txBody>
+          <a:bodyPr wrap="square" lIns="0" rIns="0" tIns="0" bIns="0">
+            <a:spAutoFit/>
+          </a:bodyPr>
+          <a:lstStyle/>
+          <a:p>
+            <a:pPr algn="l">
+              <a:spcAft>
+                <a:spcPts val="0"/>
+              </a:spcAft>
+            </a:pPr>
+            <a:r>
+              <a:rPr sz="1100" b="1">
+                <a:solidFill>
+                  <a:srgbClr val="0B6E73"/>
+                </a:solidFill>
+                <a:latin typeface="Inter"/>
+              </a:rPr>
+              <a:t>POR QUE É DE ALTA COMPLEXIDADE</a:t>
+            </a:r>
+          </a:p>
+        </p:txBody>
+      </p:sp>
+      <p:sp>
+        <p:nvSpPr>
           <p:cNvPr id="12" name="TextBox 11"/>
           <p:cNvSpPr txBox="1"/>
           <p:nvPr/>
         </p:nvSpPr>
         <p:spPr>
           <a:xfrm>
-            <a:off x="7680960" y="4389120"/>
-            <a:ext cx="3749039" cy="274320"/>
+            <a:off x="7680960" y="4800600"/>
+            <a:ext cx="3749039" cy="1280160"/>
           </a:xfrm>
           <a:prstGeom prst="rect">
             <a:avLst/>
@@ -8503,46 +8416,7 @@
               </a:spcAft>
             </a:pPr>
             <a:r>
-              <a:rPr sz="1100" b="1">
-                <a:solidFill>
-                  <a:srgbClr val="0B6E73"/>
-                </a:solidFill>
-                <a:latin typeface="Inter"/>
-              </a:rPr>
-              <a:t>POR QUE É DE ALTA COMPLEXIDADE</a:t>
-            </a:r>
-          </a:p>
-        </p:txBody>
-      </p:sp>
-      <p:sp>
-        <p:nvSpPr>
-          <p:cNvPr id="13" name="TextBox 12"/>
-          <p:cNvSpPr txBox="1"/>
-          <p:nvPr/>
-        </p:nvSpPr>
-        <p:spPr>
-          <a:xfrm>
-            <a:off x="7680960" y="4800600"/>
-            <a:ext cx="3749039" cy="1280160"/>
-          </a:xfrm>
-          <a:prstGeom prst="rect">
-            <a:avLst/>
-          </a:prstGeom>
-          <a:noFill/>
-        </p:spPr>
-        <p:txBody>
-          <a:bodyPr wrap="square" lIns="0" rIns="0" tIns="0" bIns="0">
-            <a:spAutoFit/>
-          </a:bodyPr>
-          <a:lstStyle/>
-          <a:p>
-            <a:pPr algn="l">
-              <a:spcAft>
-                <a:spcPts val="0"/>
-              </a:spcAft>
-            </a:pPr>
-            <a:r>
-              <a:rPr sz="1250" b="0">
+              <a:rPr sz="1200" b="0">
                 <a:solidFill>
                   <a:srgbClr val="1A1B2E"/>
                 </a:solidFill>
@@ -8828,7 +8702,7 @@
         <p:spPr>
           <a:xfrm>
             <a:off x="7406640" y="2194560"/>
-            <a:ext cx="4206240" cy="1645920"/>
+            <a:ext cx="4206240" cy="1737360"/>
           </a:xfrm>
           <a:prstGeom prst="rect">
             <a:avLst/>
@@ -9013,7 +8887,7 @@
               </a:spcAft>
             </a:pPr>
             <a:r>
-              <a:rPr sz="1250" b="0">
+              <a:rPr sz="1200" b="0">
                 <a:solidFill>
                   <a:srgbClr val="1A1B2E"/>
                 </a:solidFill>
@@ -9219,17 +9093,41 @@
         </p:blipFill>
         <p:spPr>
           <a:xfrm>
-            <a:off x="1188038" y="1600200"/>
-            <a:ext cx="5167723" cy="4572000"/>
+            <a:off x="548640" y="2510917"/>
+            <a:ext cx="3108960" cy="2750566"/>
           </a:xfrm>
           <a:prstGeom prst="rect">
             <a:avLst/>
           </a:prstGeom>
         </p:spPr>
       </p:pic>
-      <p:sp>
-        <p:nvSpPr>
-          <p:cNvPr id="7" name="TextBox 6"/>
+      <p:pic>
+        <p:nvPicPr>
+          <p:cNvPr id="7" name="Picture 6" descr="configuracao-de-ingressos.png"/>
+          <p:cNvPicPr>
+            <a:picLocks noChangeAspect="1"/>
+          </p:cNvPicPr>
+          <p:nvPr/>
+        </p:nvPicPr>
+        <p:blipFill>
+          <a:blip r:embed="rId3"/>
+          <a:stretch>
+            <a:fillRect/>
+          </a:stretch>
+        </p:blipFill>
+        <p:spPr>
+          <a:xfrm>
+            <a:off x="3886200" y="2071560"/>
+            <a:ext cx="3108960" cy="3629279"/>
+          </a:xfrm>
+          <a:prstGeom prst="rect">
+            <a:avLst/>
+          </a:prstGeom>
+        </p:spPr>
+      </p:pic>
+      <p:sp>
+        <p:nvSpPr>
+          <p:cNvPr id="8" name="TextBox 7"/>
           <p:cNvSpPr txBox="1"/>
           <p:nvPr/>
         </p:nvSpPr>
@@ -9268,14 +9166,14 @@
       </p:sp>
       <p:sp>
         <p:nvSpPr>
-          <p:cNvPr id="8" name="TextBox 7"/>
+          <p:cNvPr id="9" name="TextBox 8"/>
           <p:cNvSpPr txBox="1"/>
           <p:nvPr/>
         </p:nvSpPr>
         <p:spPr>
           <a:xfrm>
             <a:off x="7406640" y="2194560"/>
-            <a:ext cx="4206240" cy="1645920"/>
+            <a:ext cx="4206240" cy="1737360"/>
           </a:xfrm>
           <a:prstGeom prst="rect">
             <a:avLst/>
@@ -9307,7 +9205,7 @@
       </p:sp>
       <p:sp>
         <p:nvSpPr>
-          <p:cNvPr id="9" name="Rectangle 8"/>
+          <p:cNvPr id="10" name="Rectangle 9"/>
           <p:cNvSpPr/>
           <p:nvPr/>
         </p:nvSpPr>
@@ -9351,7 +9249,7 @@
       </p:sp>
       <p:sp>
         <p:nvSpPr>
-          <p:cNvPr id="10" name="Rectangle 9"/>
+          <p:cNvPr id="11" name="Rectangle 10"/>
           <p:cNvSpPr/>
           <p:nvPr/>
         </p:nvSpPr>
@@ -9395,7 +9293,7 @@
       </p:sp>
       <p:sp>
         <p:nvSpPr>
-          <p:cNvPr id="11" name="TextBox 10"/>
+          <p:cNvPr id="12" name="TextBox 11"/>
           <p:cNvSpPr txBox="1"/>
           <p:nvPr/>
         </p:nvSpPr>
@@ -9434,7 +9332,7 @@
       </p:sp>
       <p:sp>
         <p:nvSpPr>
-          <p:cNvPr id="12" name="TextBox 11"/>
+          <p:cNvPr id="13" name="TextBox 12"/>
           <p:cNvSpPr txBox="1"/>
           <p:nvPr/>
         </p:nvSpPr>
@@ -9460,7 +9358,7 @@
               </a:spcAft>
             </a:pPr>
             <a:r>
-              <a:rPr sz="1250" b="0">
+              <a:rPr sz="1200" b="0">
                 <a:solidFill>
                   <a:srgbClr val="1A1B2E"/>
                 </a:solidFill>
@@ -9797,7 +9695,7 @@
         <p:spPr>
           <a:xfrm>
             <a:off x="7406640" y="2194560"/>
-            <a:ext cx="4206240" cy="1645920"/>
+            <a:ext cx="4206240" cy="1737360"/>
           </a:xfrm>
           <a:prstGeom prst="rect">
             <a:avLst/>
@@ -9982,7 +9880,7 @@
               </a:spcAft>
             </a:pPr>
             <a:r>
-              <a:rPr sz="1250" b="0">
+              <a:rPr sz="1200" b="0">
                 <a:solidFill>
                   <a:srgbClr val="1A1B2E"/>
                 </a:solidFill>

</xml_diff>

<commit_message>
Inclui no deck as quatro telas que estavam de fora
</commit_message>
<xml_diff>
--- a/docs/slides/BilhetePass-apresentacao.pptx
+++ b/docs/slides/BilhetePass-apresentacao.pptx
@@ -22,6 +22,10 @@
     <p:sldId id="270" r:id="rId22"/>
     <p:sldId id="271" r:id="rId23"/>
     <p:sldId id="272" r:id="rId24"/>
+    <p:sldId id="273" r:id="rId25"/>
+    <p:sldId id="274" r:id="rId26"/>
+    <p:sldId id="275" r:id="rId27"/>
+    <p:sldId id="276" r:id="rId28"/>
   </p:sldIdLst>
   <p:sldSz cx="12191695" cy="6858000" type="screen4x3"/>
   <p:notesSz cx="6858000" cy="9144000"/>
@@ -609,7 +613,7 @@
           </a:p>
           <a:p>
             <a:r>
-              <a:t>A frase do modal, que é a regra escrita na interface: “reembolso integral de R$ 90,00, pois faltam mais de 7 dias para o evento”.</a:t>
+              <a:t>A confirmação da compra, fechando o fluxo e liberando a emissão dos ingressos.</a:t>
             </a:r>
           </a:p>
           <a:p/>
@@ -620,7 +624,7 @@
           </a:p>
           <a:p>
             <a:r>
-              <a:t>O valor é CALCULADO por faixas sobre a diferença entre a data do cancelamento e a do evento — integral acima de 7 dias, metade entre 7 e 2, nenhum abaixo — exigindo CONSULTAR dois agregados.</a:t>
+              <a:t>Com o pagamento confirmado, o sistema dispara a emissão dos ingressos e a baixa definitiva do estoque no lote — é o evento que conecta Vendas a Controle de Acesso.</a:t>
             </a:r>
           </a:p>
         </p:txBody>
@@ -695,6 +699,350 @@
           </a:p>
           <a:p>
             <a:r>
+              <a:t>A lista de ingressos com o participante nomeado em cada um.</a:t>
+            </a:r>
+          </a:p>
+          <a:p/>
+          <a:p>
+            <a:r>
+              <a:t>POR QUE E DE ALTA COMPLEXIDADE</a:t>
+            </a:r>
+          </a:p>
+          <a:p>
+            <a:r>
+              <a:t>Cada ingresso recebe um código único verificável, e a reemissão precisa INVALIDAR o código anterior sem perder o vínculo com o participante — além de VALIDAR que o ingresso ainda não teve check-in.</a:t>
+            </a:r>
+          </a:p>
+        </p:txBody>
+      </p:sp>
+      <p:sp>
+        <p:nvSpPr>
+          <p:cNvPr id="4" name="Slide Number Placeholder 3"/>
+          <p:cNvSpPr>
+            <a:spLocks noGrp="1"/>
+          </p:cNvSpPr>
+          <p:nvPr>
+            <p:ph type="sldNum" idx="5" sz="quarter"/>
+          </p:nvPr>
+        </p:nvSpPr>
+        <p:spPr/>
+      </p:sp>
+    </p:spTree>
+  </p:cSld>
+  <p:clrMapOvr>
+    <a:masterClrMapping/>
+  </p:clrMapOvr>
+</p:notes>
+</file>
+
+<file path=ppt/notesSlides/notesSlide12.xml><?xml version="1.0" encoding="utf-8"?>
+<p:notes xmlns:a="http://schemas.openxmlformats.org/drawingml/2006/main" xmlns:p="http://schemas.openxmlformats.org/presentationml/2006/main" xmlns:r="http://schemas.openxmlformats.org/officeDocument/2006/relationships">
+  <p:cSld>
+    <p:spTree>
+      <p:nvGrpSpPr>
+        <p:cNvPr id="1" name=""/>
+        <p:cNvGrpSpPr/>
+        <p:nvPr/>
+      </p:nvGrpSpPr>
+      <p:grpSpPr>
+        <a:xfrm>
+          <a:off x="0" y="0"/>
+          <a:ext cx="0" cy="0"/>
+          <a:chOff x="0" y="0"/>
+          <a:chExt cx="0" cy="0"/>
+        </a:xfrm>
+      </p:grpSpPr>
+      <p:sp>
+        <p:nvSpPr>
+          <p:cNvPr id="2" name="Slide Image Placeholder 1"/>
+          <p:cNvSpPr>
+            <a:spLocks noGrp="1"/>
+          </p:cNvSpPr>
+          <p:nvPr>
+            <p:ph type="sldImg" idx="2"/>
+          </p:nvPr>
+        </p:nvSpPr>
+        <p:spPr/>
+      </p:sp>
+      <p:sp>
+        <p:nvSpPr>
+          <p:cNvPr id="3" name="Notes Placeholder 2"/>
+          <p:cNvSpPr>
+            <a:spLocks noGrp="1"/>
+          </p:cNvSpPr>
+          <p:nvPr>
+            <p:ph type="body" idx="3" sz="quarter"/>
+          </p:nvPr>
+        </p:nvSpPr>
+        <p:spPr/>
+        <p:txBody>
+          <a:bodyPr/>
+          <a:lstStyle/>
+          <a:p>
+            <a:r>
+              <a:t>O QUE MOSTRAR NA TELA</a:t>
+            </a:r>
+          </a:p>
+          <a:p>
+            <a:r>
+              <a:t>Sem protótipo — aponte no mapa, coluna “Transferir ou cancelar”, card H16. Release 2.</a:t>
+            </a:r>
+          </a:p>
+          <a:p/>
+          <a:p>
+            <a:r>
+              <a:t>POR QUE E DE ALTA COMPLEXIDADE</a:t>
+            </a:r>
+          </a:p>
+          <a:p>
+            <a:r>
+              <a:t>A transferência INVALIDA o QR antigo e emite outro, só é permitida após VALIDAR que não houve check-in e que o destinatário não tem outro ingresso do mesmo lote, e a meia-entrada exige VALIDAR o mesmo benefício.</a:t>
+            </a:r>
+          </a:p>
+        </p:txBody>
+      </p:sp>
+      <p:sp>
+        <p:nvSpPr>
+          <p:cNvPr id="4" name="Slide Number Placeholder 3"/>
+          <p:cNvSpPr>
+            <a:spLocks noGrp="1"/>
+          </p:cNvSpPr>
+          <p:nvPr>
+            <p:ph type="sldNum" idx="5" sz="quarter"/>
+          </p:nvPr>
+        </p:nvSpPr>
+        <p:spPr/>
+      </p:sp>
+    </p:spTree>
+  </p:cSld>
+  <p:clrMapOvr>
+    <a:masterClrMapping/>
+  </p:clrMapOvr>
+</p:notes>
+</file>
+
+<file path=ppt/notesSlides/notesSlide13.xml><?xml version="1.0" encoding="utf-8"?>
+<p:notes xmlns:a="http://schemas.openxmlformats.org/drawingml/2006/main" xmlns:p="http://schemas.openxmlformats.org/presentationml/2006/main" xmlns:r="http://schemas.openxmlformats.org/officeDocument/2006/relationships">
+  <p:cSld>
+    <p:spTree>
+      <p:nvGrpSpPr>
+        <p:cNvPr id="1" name=""/>
+        <p:cNvGrpSpPr/>
+        <p:nvPr/>
+      </p:nvGrpSpPr>
+      <p:grpSpPr>
+        <a:xfrm>
+          <a:off x="0" y="0"/>
+          <a:ext cx="0" cy="0"/>
+          <a:chOff x="0" y="0"/>
+          <a:chExt cx="0" cy="0"/>
+        </a:xfrm>
+      </p:grpSpPr>
+      <p:sp>
+        <p:nvSpPr>
+          <p:cNvPr id="2" name="Slide Image Placeholder 1"/>
+          <p:cNvSpPr>
+            <a:spLocks noGrp="1"/>
+          </p:cNvSpPr>
+          <p:nvPr>
+            <p:ph type="sldImg" idx="2"/>
+          </p:nvPr>
+        </p:nvSpPr>
+        <p:spPr/>
+      </p:sp>
+      <p:sp>
+        <p:nvSpPr>
+          <p:cNvPr id="3" name="Notes Placeholder 2"/>
+          <p:cNvSpPr>
+            <a:spLocks noGrp="1"/>
+          </p:cNvSpPr>
+          <p:nvPr>
+            <p:ph type="body" idx="3" sz="quarter"/>
+          </p:nvPr>
+        </p:nvSpPr>
+        <p:spPr/>
+        <p:txBody>
+          <a:bodyPr/>
+          <a:lstStyle/>
+          <a:p>
+            <a:r>
+              <a:t>O QUE MOSTRAR NA TELA</a:t>
+            </a:r>
+          </a:p>
+          <a:p>
+            <a:r>
+              <a:t>A frase do modal, que é a regra escrita na interface: “reembolso integral de R$ 90,00, pois faltam mais de 7 dias para o evento”.</a:t>
+            </a:r>
+          </a:p>
+          <a:p/>
+          <a:p>
+            <a:r>
+              <a:t>POR QUE E DE ALTA COMPLEXIDADE</a:t>
+            </a:r>
+          </a:p>
+          <a:p>
+            <a:r>
+              <a:t>O valor é CALCULADO por faixas sobre a diferença entre a data do cancelamento e a do evento — integral acima de 7 dias, metade entre 7 e 2, nenhum abaixo — exigindo CONSULTAR dois agregados.</a:t>
+            </a:r>
+          </a:p>
+        </p:txBody>
+      </p:sp>
+      <p:sp>
+        <p:nvSpPr>
+          <p:cNvPr id="4" name="Slide Number Placeholder 3"/>
+          <p:cNvSpPr>
+            <a:spLocks noGrp="1"/>
+          </p:cNvSpPr>
+          <p:nvPr>
+            <p:ph type="sldNum" idx="5" sz="quarter"/>
+          </p:nvPr>
+        </p:nvSpPr>
+        <p:spPr/>
+      </p:sp>
+    </p:spTree>
+  </p:cSld>
+  <p:clrMapOvr>
+    <a:masterClrMapping/>
+  </p:clrMapOvr>
+</p:notes>
+</file>
+
+<file path=ppt/notesSlides/notesSlide14.xml><?xml version="1.0" encoding="utf-8"?>
+<p:notes xmlns:a="http://schemas.openxmlformats.org/drawingml/2006/main" xmlns:p="http://schemas.openxmlformats.org/presentationml/2006/main" xmlns:r="http://schemas.openxmlformats.org/officeDocument/2006/relationships">
+  <p:cSld>
+    <p:spTree>
+      <p:nvGrpSpPr>
+        <p:cNvPr id="1" name=""/>
+        <p:cNvGrpSpPr/>
+        <p:nvPr/>
+      </p:nvGrpSpPr>
+      <p:grpSpPr>
+        <a:xfrm>
+          <a:off x="0" y="0"/>
+          <a:ext cx="0" cy="0"/>
+          <a:chOff x="0" y="0"/>
+          <a:chExt cx="0" cy="0"/>
+        </a:xfrm>
+      </p:grpSpPr>
+      <p:sp>
+        <p:nvSpPr>
+          <p:cNvPr id="2" name="Slide Image Placeholder 1"/>
+          <p:cNvSpPr>
+            <a:spLocks noGrp="1"/>
+          </p:cNvSpPr>
+          <p:nvPr>
+            <p:ph type="sldImg" idx="2"/>
+          </p:nvPr>
+        </p:nvSpPr>
+        <p:spPr/>
+      </p:sp>
+      <p:sp>
+        <p:nvSpPr>
+          <p:cNvPr id="3" name="Notes Placeholder 2"/>
+          <p:cNvSpPr>
+            <a:spLocks noGrp="1"/>
+          </p:cNvSpPr>
+          <p:nvPr>
+            <p:ph type="body" idx="3" sz="quarter"/>
+          </p:nvPr>
+        </p:nvSpPr>
+        <p:spPr/>
+        <p:txBody>
+          <a:bodyPr/>
+          <a:lstStyle/>
+          <a:p>
+            <a:r>
+              <a:t>O QUE MOSTRAR NA TELA</a:t>
+            </a:r>
+          </a:p>
+          <a:p>
+            <a:r>
+              <a:t>O card verde de entrada liberada, com o participante, o ingresso e o horário do registro.</a:t>
+            </a:r>
+          </a:p>
+          <a:p/>
+          <a:p>
+            <a:r>
+              <a:t>POR QUE E DE ALTA COMPLEXIDADE</a:t>
+            </a:r>
+          </a:p>
+          <a:p>
+            <a:r>
+              <a:t>Toda leitura aprovada grava data, hora e operador responsável — o registro de auditoria, que é a regra de complexidade baixa dentro desta funcionalidade.</a:t>
+            </a:r>
+          </a:p>
+        </p:txBody>
+      </p:sp>
+      <p:sp>
+        <p:nvSpPr>
+          <p:cNvPr id="4" name="Slide Number Placeholder 3"/>
+          <p:cNvSpPr>
+            <a:spLocks noGrp="1"/>
+          </p:cNvSpPr>
+          <p:nvPr>
+            <p:ph type="sldNum" idx="5" sz="quarter"/>
+          </p:nvPr>
+        </p:nvSpPr>
+        <p:spPr/>
+      </p:sp>
+    </p:spTree>
+  </p:cSld>
+  <p:clrMapOvr>
+    <a:masterClrMapping/>
+  </p:clrMapOvr>
+</p:notes>
+</file>
+
+<file path=ppt/notesSlides/notesSlide15.xml><?xml version="1.0" encoding="utf-8"?>
+<p:notes xmlns:a="http://schemas.openxmlformats.org/drawingml/2006/main" xmlns:p="http://schemas.openxmlformats.org/presentationml/2006/main" xmlns:r="http://schemas.openxmlformats.org/officeDocument/2006/relationships">
+  <p:cSld>
+    <p:spTree>
+      <p:nvGrpSpPr>
+        <p:cNvPr id="1" name=""/>
+        <p:cNvGrpSpPr/>
+        <p:nvPr/>
+      </p:nvGrpSpPr>
+      <p:grpSpPr>
+        <a:xfrm>
+          <a:off x="0" y="0"/>
+          <a:ext cx="0" cy="0"/>
+          <a:chOff x="0" y="0"/>
+          <a:chExt cx="0" cy="0"/>
+        </a:xfrm>
+      </p:grpSpPr>
+      <p:sp>
+        <p:nvSpPr>
+          <p:cNvPr id="2" name="Slide Image Placeholder 1"/>
+          <p:cNvSpPr>
+            <a:spLocks noGrp="1"/>
+          </p:cNvSpPr>
+          <p:nvPr>
+            <p:ph type="sldImg" idx="2"/>
+          </p:nvPr>
+        </p:nvSpPr>
+        <p:spPr/>
+      </p:sp>
+      <p:sp>
+        <p:nvSpPr>
+          <p:cNvPr id="3" name="Notes Placeholder 2"/>
+          <p:cNvSpPr>
+            <a:spLocks noGrp="1"/>
+          </p:cNvSpPr>
+          <p:nvPr>
+            <p:ph type="body" idx="3" sz="quarter"/>
+          </p:nvPr>
+        </p:nvSpPr>
+        <p:spPr/>
+        <p:txBody>
+          <a:bodyPr/>
+          <a:lstStyle/>
+          <a:p>
+            <a:r>
+              <a:t>O QUE MOSTRAR NA TELA</a:t>
+            </a:r>
+          </a:p>
+          <a:p>
+            <a:r>
               <a:t>Os dois casos de recusa: “ingresso já utilizado às 17:12” e “pagamento não confirmado”.</a:t>
             </a:r>
           </a:p>
@@ -953,7 +1301,7 @@
           </a:p>
           <a:p>
             <a:r>
-              <a:t>O cupom AMIGO10 aplicando −R$ 27,00 e o Camarote como Esgotado. Na tela seguinte, o erro “este nome já foi usado em outro ingresso deste pedido”.</a:t>
+              <a:t>Os três tipos de ingresso com preço, e o Camarote Open Bar marcado como Esgotado.</a:t>
             </a:r>
           </a:p>
           <a:p/>
@@ -964,7 +1312,7 @@
           </a:p>
           <a:p>
             <a:r>
-              <a:t>O preço exige CONSULTAR o lote vigente na data, a disponibilidade exige CONSULTAR quantos já foram vendidos, e o desconto exige CALCULAR sobre um cupom VALIDADO quanto a tipo, validade, limite de usos e aplicabilidade.</a:t>
+              <a:t>É a porta de entrada da compra: o preço exibido vem do lote vigente na data, e a disponibilidade vem da contagem de quantos já foram vendidos naquele lote.</a:t>
             </a:r>
           </a:p>
         </p:txBody>
@@ -1039,7 +1387,7 @@
           </a:p>
           <a:p>
             <a:r>
-              <a:t>A cota “40% do lote — 160 de 400”. Na tela de seleção, a linha “Meia-Entrada / Solidária — R$ 90,00”.</a:t>
+              <a:t>O cupom AMIGO10 aplicando −R$ 27,00 e o Camarote como Esgotado. Na tela seguinte, o erro “este nome já foi usado em outro ingresso deste pedido”.</a:t>
             </a:r>
           </a:p>
           <a:p/>
@@ -1050,7 +1398,7 @@
           </a:p>
           <a:p>
             <a:r>
-              <a:t>A venda da meia é bloqueada por uma cota CALCULADA como percentual do lote, exige VALIDAR o comprovante conforme o benefício declarado, e a não comprovação na portaria RECALCULA o ingresso para inteira cobrando a diferença.</a:t>
+              <a:t>O preço exige CONSULTAR o lote vigente na data, a disponibilidade exige CONSULTAR quantos já foram vendidos, e o desconto exige CALCULAR sobre um cupom VALIDADO quanto a tipo, validade, limite de usos e aplicabilidade.</a:t>
             </a:r>
           </a:p>
         </p:txBody>
@@ -1125,7 +1473,7 @@
           </a:p>
           <a:p>
             <a:r>
-              <a:t>Sem protótipo — aponte no mapa, coluna “Escolher ingressos”, card H13. Release 2.</a:t>
+              <a:t>O erro em vermelho: “este nome já foi usado em outro ingresso deste pedido”.</a:t>
             </a:r>
           </a:p>
           <a:p/>
@@ -1136,7 +1484,7 @@
           </a:p>
           <a:p>
             <a:r>
-              <a:t>A reserva expira por tempo e precisa DEVOLVER o estoque ao lote automaticamente, e o limite por CPF exige CALCULAR a soma das reservas ativas com as compras já concluídas no mesmo evento.</a:t>
+              <a:t>Cada ingresso é nominal: antes de confirmar, o sistema precisa VALIDAR que o mesmo participante não foi vinculado a dois ingressos do mesmo pedido.</a:t>
             </a:r>
           </a:p>
         </p:txBody>
@@ -1211,7 +1559,7 @@
           </a:p>
           <a:p>
             <a:r>
-              <a:t>O resumo da compra com a composição do total: subtotal R$ 270,00 − desconto R$ 27,00 + taxa = R$ 243,00.</a:t>
+              <a:t>A cota “40% do lote — 160 de 400”. Na tela de seleção, a linha “Meia-Entrada / Solidária — R$ 90,00”.</a:t>
             </a:r>
           </a:p>
           <a:p/>
@@ -1222,7 +1570,7 @@
           </a:p>
           <a:p>
             <a:r>
-              <a:t>O total é CALCULADO como subtotal menos desconto mais taxa, e a confirmação só é permitida após VALIDAR que a reserva do pedido ainda não expirou — cruzando pedido, lote e pagamento.</a:t>
+              <a:t>A venda da meia é bloqueada por uma cota CALCULADA como percentual do lote, exige VALIDAR o comprovante conforme o benefício declarado, e a não comprovação na portaria RECALCULA o ingresso para inteira cobrando a diferença.</a:t>
             </a:r>
           </a:p>
         </p:txBody>
@@ -1297,7 +1645,7 @@
           </a:p>
           <a:p>
             <a:r>
-              <a:t>A lista de ingressos com o participante nomeado em cada um.</a:t>
+              <a:t>Sem protótipo — aponte no mapa, coluna “Escolher ingressos”, card H13. Release 2.</a:t>
             </a:r>
           </a:p>
           <a:p/>
@@ -1308,7 +1656,7 @@
           </a:p>
           <a:p>
             <a:r>
-              <a:t>Cada ingresso recebe um código único verificável, e a reemissão precisa INVALIDAR o código anterior sem perder o vínculo com o participante — além de VALIDAR que o ingresso ainda não teve check-in.</a:t>
+              <a:t>A reserva expira por tempo e precisa DEVOLVER o estoque ao lote automaticamente, e o limite por CPF exige CALCULAR a soma das reservas ativas com as compras já concluídas no mesmo evento.</a:t>
             </a:r>
           </a:p>
         </p:txBody>
@@ -1383,7 +1731,7 @@
           </a:p>
           <a:p>
             <a:r>
-              <a:t>Sem protótipo — aponte no mapa, coluna “Transferir ou cancelar”, card H16. Release 2.</a:t>
+              <a:t>O resumo da compra com a composição do total: subtotal R$ 270,00 − desconto R$ 27,00 + taxa = R$ 243,00.</a:t>
             </a:r>
           </a:p>
           <a:p/>
@@ -1394,7 +1742,7 @@
           </a:p>
           <a:p>
             <a:r>
-              <a:t>A transferência INVALIDA o QR antigo e emite outro, só é permitida após VALIDAR que não houve check-in e que o destinatário não tem outro ingresso do mesmo lote, e a meia-entrada exige VALIDAR o mesmo benefício.</a:t>
+              <a:t>O total é CALCULADO como subtotal menos desconto mais taxa, e a confirmação só é permitida após VALIDAR que a reserva do pedido ainda não expirou — cruzando pedido, lote e pagamento.</a:t>
             </a:r>
           </a:p>
         </p:txBody>
@@ -4717,7 +5065,7 @@
                 </a:solidFill>
                 <a:latin typeface="Inter"/>
               </a:rPr>
-              <a:t>05</a:t>
+              <a:t>03</a:t>
             </a:r>
           </a:p>
         </p:txBody>
@@ -4756,7 +5104,7 @@
                 </a:solidFill>
                 <a:latin typeface="Inter"/>
               </a:rPr>
-              <a:t>Fila de espera e reserva temporária</a:t>
+              <a:t>Venda de ingressos — identificação</a:t>
             </a:r>
           </a:p>
         </p:txBody>
@@ -4795,113 +5143,38 @@
                 </a:solidFill>
                 <a:latin typeface="Inter"/>
               </a:rPr>
-              <a:t>CF</a:t>
-            </a:r>
-          </a:p>
-        </p:txBody>
-      </p:sp>
-      <p:sp>
-        <p:nvSpPr>
-          <p:cNvPr id="6" name="Rectangle 5"/>
-          <p:cNvSpPr/>
-          <p:nvPr/>
-        </p:nvSpPr>
-        <p:spPr>
-          <a:xfrm>
-            <a:off x="3200400" y="1737360"/>
-            <a:ext cx="5760720" cy="3383280"/>
-          </a:xfrm>
-          <a:prstGeom prst="rect">
-            <a:avLst/>
-          </a:prstGeom>
-          <a:solidFill>
-            <a:srgbClr val="F7F8FC"/>
-          </a:solidFill>
-          <a:ln>
-            <a:noFill/>
-          </a:ln>
-          <a:effectLst/>
-        </p:spPr>
-        <p:style>
-          <a:lnRef idx="1">
-            <a:schemeClr val="accent1"/>
-          </a:lnRef>
-          <a:fillRef idx="3">
-            <a:schemeClr val="accent1"/>
-          </a:fillRef>
-          <a:effectRef idx="2">
-            <a:schemeClr val="accent1"/>
-          </a:effectRef>
-          <a:fontRef idx="minor">
-            <a:schemeClr val="lt1"/>
-          </a:fontRef>
-        </p:style>
-        <p:txBody>
-          <a:bodyPr rtlCol="0" anchor="ctr"/>
-          <a:lstStyle/>
-          <a:p>
-            <a:pPr algn="ctr"/>
-          </a:p>
-        </p:txBody>
-      </p:sp>
-      <p:sp>
-        <p:nvSpPr>
-          <p:cNvPr id="7" name="TextBox 6"/>
-          <p:cNvSpPr txBox="1"/>
-          <p:nvPr/>
-        </p:nvSpPr>
-        <p:spPr>
-          <a:xfrm>
-            <a:off x="3566160" y="3108960"/>
-            <a:ext cx="5029200" cy="822960"/>
-          </a:xfrm>
-          <a:prstGeom prst="rect">
-            <a:avLst/>
-          </a:prstGeom>
-          <a:noFill/>
-        </p:spPr>
-        <p:txBody>
-          <a:bodyPr wrap="square" lIns="0" rIns="0" tIns="0" bIns="0">
-            <a:spAutoFit/>
-          </a:bodyPr>
-          <a:lstStyle/>
-          <a:p>
-            <a:pPr algn="ctr">
-              <a:spcAft>
-                <a:spcPts val="600"/>
-              </a:spcAft>
-            </a:pPr>
-            <a:r>
-              <a:rPr sz="1900" b="1">
-                <a:solidFill>
-                  <a:srgbClr val="9E520A"/>
-                </a:solidFill>
-                <a:latin typeface="Inter"/>
-              </a:rPr>
-              <a:t>Sem protótipo</a:t>
-            </a:r>
-          </a:p>
-          <a:p>
-            <a:pPr algn="ctr">
-              <a:spcAft>
-                <a:spcPts val="600"/>
-              </a:spcAft>
-            </a:pPr>
-            <a:r>
-              <a:rPr sz="1900" b="1">
-                <a:solidFill>
-                  <a:srgbClr val="9E520A"/>
-                </a:solidFill>
-                <a:latin typeface="Inter"/>
-              </a:rPr>
-              <a:t>Release 2 — está mapeada</a:t>
-            </a:r>
-          </a:p>
-        </p:txBody>
-      </p:sp>
-      <p:sp>
-        <p:nvSpPr>
-          <p:cNvPr id="8" name="Rectangle 7"/>
+              <a:t>LS</a:t>
+            </a:r>
+          </a:p>
+        </p:txBody>
+      </p:sp>
+      <p:pic>
+        <p:nvPicPr>
+          <p:cNvPr id="6" name="Picture 5" descr="identificacao-de-participantes.png"/>
+          <p:cNvPicPr>
+            <a:picLocks noChangeAspect="1"/>
+          </p:cNvPicPr>
+          <p:nvPr/>
+        </p:nvPicPr>
+        <p:blipFill>
+          <a:blip r:embed="rId2"/>
+          <a:stretch>
+            <a:fillRect/>
+          </a:stretch>
+        </p:blipFill>
+        <p:spPr>
+          <a:xfrm>
+            <a:off x="2641044" y="1005840"/>
+            <a:ext cx="6879431" cy="4892040"/>
+          </a:xfrm>
+          <a:prstGeom prst="rect">
+            <a:avLst/>
+          </a:prstGeom>
+        </p:spPr>
+      </p:pic>
+      <p:sp>
+        <p:nvSpPr>
+          <p:cNvPr id="7" name="Rectangle 6"/>
           <p:cNvSpPr/>
           <p:nvPr/>
         </p:nvSpPr>
@@ -4945,7 +5218,7 @@
       </p:sp>
       <p:sp>
         <p:nvSpPr>
-          <p:cNvPr id="9" name="Rectangle 8"/>
+          <p:cNvPr id="8" name="Rectangle 7"/>
           <p:cNvSpPr/>
           <p:nvPr/>
         </p:nvSpPr>
@@ -4989,7 +5262,7 @@
       </p:sp>
       <p:sp>
         <p:nvSpPr>
-          <p:cNvPr id="10" name="TextBox 9"/>
+          <p:cNvPr id="9" name="TextBox 8"/>
           <p:cNvSpPr txBox="1"/>
           <p:nvPr/>
         </p:nvSpPr>
@@ -5021,7 +5294,7 @@
                 </a:solidFill>
                 <a:latin typeface="Inter"/>
               </a:rPr>
-              <a:t>A reserva expira devolvendo estoque, e o limite por CPF soma reservas ativas com compras concluídas.</a:t>
+              <a:t>Cada ingresso é nominal, e o sistema valida que o mesmo participante não se repete no pedido.</a:t>
             </a:r>
           </a:p>
         </p:txBody>
@@ -5122,7 +5395,7 @@
                 </a:solidFill>
                 <a:latin typeface="Inter"/>
               </a:rPr>
-              <a:t>06</a:t>
+              <a:t>04</a:t>
             </a:r>
           </a:p>
         </p:txBody>
@@ -5161,7 +5434,7 @@
                 </a:solidFill>
                 <a:latin typeface="Inter"/>
               </a:rPr>
-              <a:t>Pagamento do pedido</a:t>
+              <a:t>Meia-entrada: benefício e cota</a:t>
             </a:r>
           </a:p>
         </p:txBody>
@@ -5200,14 +5473,14 @@
                 </a:solidFill>
                 <a:latin typeface="Inter"/>
               </a:rPr>
-              <a:t>GF</a:t>
+              <a:t>EM</a:t>
             </a:r>
           </a:p>
         </p:txBody>
       </p:sp>
       <p:pic>
         <p:nvPicPr>
-          <p:cNvPr id="6" name="Picture 5" descr="checkout-pagamento.png"/>
+          <p:cNvPr id="6" name="Picture 5" descr="configuracao-de-ingressos.png"/>
           <p:cNvPicPr>
             <a:picLocks noChangeAspect="1"/>
           </p:cNvPicPr>
@@ -5221,8 +5494,8 @@
         </p:blipFill>
         <p:spPr>
           <a:xfrm>
-            <a:off x="2641044" y="1005840"/>
-            <a:ext cx="6879431" cy="4892040"/>
+            <a:off x="3985418" y="1005840"/>
+            <a:ext cx="4190682" cy="4892040"/>
           </a:xfrm>
           <a:prstGeom prst="rect">
             <a:avLst/>
@@ -5351,7 +5624,7 @@
                 </a:solidFill>
                 <a:latin typeface="Inter"/>
               </a:rPr>
-              <a:t>Calcula subtotal − desconto + taxa, e só confirma após validar que a reserva não expirou.</a:t>
+              <a:t>A cota de meia é calculada como percentual do lote; sem comprovação, o ingresso é recalculado para inteira.</a:t>
             </a:r>
           </a:p>
         </p:txBody>
@@ -5452,7 +5725,7 @@
                 </a:solidFill>
                 <a:latin typeface="Inter"/>
               </a:rPr>
-              <a:t>07</a:t>
+              <a:t>05</a:t>
             </a:r>
           </a:p>
         </p:txBody>
@@ -5491,7 +5764,7 @@
                 </a:solidFill>
                 <a:latin typeface="Inter"/>
               </a:rPr>
-              <a:t>Emissão e entrega do ingresso</a:t>
+              <a:t>Fila de espera e reserva temporária</a:t>
             </a:r>
           </a:p>
         </p:txBody>
@@ -5535,33 +5808,108 @@
           </a:p>
         </p:txBody>
       </p:sp>
-      <p:pic>
-        <p:nvPicPr>
-          <p:cNvPr id="6" name="Picture 5" descr="meus-ingressos.png"/>
-          <p:cNvPicPr>
-            <a:picLocks noChangeAspect="1"/>
-          </p:cNvPicPr>
-          <p:nvPr/>
-        </p:nvPicPr>
-        <p:blipFill>
-          <a:blip r:embed="rId2"/>
-          <a:stretch>
-            <a:fillRect/>
-          </a:stretch>
-        </p:blipFill>
-        <p:spPr>
-          <a:xfrm>
-            <a:off x="3095786" y="1005840"/>
-            <a:ext cx="5969947" cy="4892040"/>
-          </a:xfrm>
-          <a:prstGeom prst="rect">
-            <a:avLst/>
-          </a:prstGeom>
-        </p:spPr>
-      </p:pic>
-      <p:sp>
-        <p:nvSpPr>
-          <p:cNvPr id="7" name="Rectangle 6"/>
+      <p:sp>
+        <p:nvSpPr>
+          <p:cNvPr id="6" name="Rectangle 5"/>
+          <p:cNvSpPr/>
+          <p:nvPr/>
+        </p:nvSpPr>
+        <p:spPr>
+          <a:xfrm>
+            <a:off x="3200400" y="1737360"/>
+            <a:ext cx="5760720" cy="3383280"/>
+          </a:xfrm>
+          <a:prstGeom prst="rect">
+            <a:avLst/>
+          </a:prstGeom>
+          <a:solidFill>
+            <a:srgbClr val="F7F8FC"/>
+          </a:solidFill>
+          <a:ln>
+            <a:noFill/>
+          </a:ln>
+          <a:effectLst/>
+        </p:spPr>
+        <p:style>
+          <a:lnRef idx="1">
+            <a:schemeClr val="accent1"/>
+          </a:lnRef>
+          <a:fillRef idx="3">
+            <a:schemeClr val="accent1"/>
+          </a:fillRef>
+          <a:effectRef idx="2">
+            <a:schemeClr val="accent1"/>
+          </a:effectRef>
+          <a:fontRef idx="minor">
+            <a:schemeClr val="lt1"/>
+          </a:fontRef>
+        </p:style>
+        <p:txBody>
+          <a:bodyPr rtlCol="0" anchor="ctr"/>
+          <a:lstStyle/>
+          <a:p>
+            <a:pPr algn="ctr"/>
+          </a:p>
+        </p:txBody>
+      </p:sp>
+      <p:sp>
+        <p:nvSpPr>
+          <p:cNvPr id="7" name="TextBox 6"/>
+          <p:cNvSpPr txBox="1"/>
+          <p:nvPr/>
+        </p:nvSpPr>
+        <p:spPr>
+          <a:xfrm>
+            <a:off x="3566160" y="3108960"/>
+            <a:ext cx="5029200" cy="822960"/>
+          </a:xfrm>
+          <a:prstGeom prst="rect">
+            <a:avLst/>
+          </a:prstGeom>
+          <a:noFill/>
+        </p:spPr>
+        <p:txBody>
+          <a:bodyPr wrap="square" lIns="0" rIns="0" tIns="0" bIns="0">
+            <a:spAutoFit/>
+          </a:bodyPr>
+          <a:lstStyle/>
+          <a:p>
+            <a:pPr algn="ctr">
+              <a:spcAft>
+                <a:spcPts val="600"/>
+              </a:spcAft>
+            </a:pPr>
+            <a:r>
+              <a:rPr sz="1900" b="1">
+                <a:solidFill>
+                  <a:srgbClr val="9E520A"/>
+                </a:solidFill>
+                <a:latin typeface="Inter"/>
+              </a:rPr>
+              <a:t>Sem protótipo</a:t>
+            </a:r>
+          </a:p>
+          <a:p>
+            <a:pPr algn="ctr">
+              <a:spcAft>
+                <a:spcPts val="600"/>
+              </a:spcAft>
+            </a:pPr>
+            <a:r>
+              <a:rPr sz="1900" b="1">
+                <a:solidFill>
+                  <a:srgbClr val="9E520A"/>
+                </a:solidFill>
+                <a:latin typeface="Inter"/>
+              </a:rPr>
+              <a:t>Release 2 — está mapeada</a:t>
+            </a:r>
+          </a:p>
+        </p:txBody>
+      </p:sp>
+      <p:sp>
+        <p:nvSpPr>
+          <p:cNvPr id="8" name="Rectangle 7"/>
           <p:cNvSpPr/>
           <p:nvPr/>
         </p:nvSpPr>
@@ -5605,7 +5953,7 @@
       </p:sp>
       <p:sp>
         <p:nvSpPr>
-          <p:cNvPr id="8" name="Rectangle 7"/>
+          <p:cNvPr id="9" name="Rectangle 8"/>
           <p:cNvSpPr/>
           <p:nvPr/>
         </p:nvSpPr>
@@ -5649,7 +5997,7 @@
       </p:sp>
       <p:sp>
         <p:nvSpPr>
-          <p:cNvPr id="9" name="TextBox 8"/>
+          <p:cNvPr id="10" name="TextBox 9"/>
           <p:cNvSpPr txBox="1"/>
           <p:nvPr/>
         </p:nvSpPr>
@@ -5681,7 +6029,7 @@
                 </a:solidFill>
                 <a:latin typeface="Inter"/>
               </a:rPr>
-              <a:t>A reemissão invalida o código anterior preservando o vínculo, e valida que não houve check-in.</a:t>
+              <a:t>A reserva expira devolvendo estoque, e o limite por CPF soma reservas ativas com compras concluídas.</a:t>
             </a:r>
           </a:p>
         </p:txBody>
@@ -5782,7 +6130,7 @@
                 </a:solidFill>
                 <a:latin typeface="Inter"/>
               </a:rPr>
-              <a:t>08</a:t>
+              <a:t>06</a:t>
             </a:r>
           </a:p>
         </p:txBody>
@@ -5821,7 +6169,7 @@
                 </a:solidFill>
                 <a:latin typeface="Inter"/>
               </a:rPr>
-              <a:t>Transferência nominal de ingresso</a:t>
+              <a:t>Pagamento do pedido</a:t>
             </a:r>
           </a:p>
         </p:txBody>
@@ -5860,113 +6208,38 @@
                 </a:solidFill>
                 <a:latin typeface="Inter"/>
               </a:rPr>
-              <a:t>EM</a:t>
-            </a:r>
-          </a:p>
-        </p:txBody>
-      </p:sp>
-      <p:sp>
-        <p:nvSpPr>
-          <p:cNvPr id="6" name="Rectangle 5"/>
-          <p:cNvSpPr/>
-          <p:nvPr/>
-        </p:nvSpPr>
-        <p:spPr>
-          <a:xfrm>
-            <a:off x="3200400" y="1737360"/>
-            <a:ext cx="5760720" cy="3383280"/>
-          </a:xfrm>
-          <a:prstGeom prst="rect">
-            <a:avLst/>
-          </a:prstGeom>
-          <a:solidFill>
-            <a:srgbClr val="F7F8FC"/>
-          </a:solidFill>
-          <a:ln>
-            <a:noFill/>
-          </a:ln>
-          <a:effectLst/>
-        </p:spPr>
-        <p:style>
-          <a:lnRef idx="1">
-            <a:schemeClr val="accent1"/>
-          </a:lnRef>
-          <a:fillRef idx="3">
-            <a:schemeClr val="accent1"/>
-          </a:fillRef>
-          <a:effectRef idx="2">
-            <a:schemeClr val="accent1"/>
-          </a:effectRef>
-          <a:fontRef idx="minor">
-            <a:schemeClr val="lt1"/>
-          </a:fontRef>
-        </p:style>
-        <p:txBody>
-          <a:bodyPr rtlCol="0" anchor="ctr"/>
-          <a:lstStyle/>
-          <a:p>
-            <a:pPr algn="ctr"/>
-          </a:p>
-        </p:txBody>
-      </p:sp>
-      <p:sp>
-        <p:nvSpPr>
-          <p:cNvPr id="7" name="TextBox 6"/>
-          <p:cNvSpPr txBox="1"/>
-          <p:nvPr/>
-        </p:nvSpPr>
-        <p:spPr>
-          <a:xfrm>
-            <a:off x="3566160" y="3108960"/>
-            <a:ext cx="5029200" cy="822960"/>
-          </a:xfrm>
-          <a:prstGeom prst="rect">
-            <a:avLst/>
-          </a:prstGeom>
-          <a:noFill/>
-        </p:spPr>
-        <p:txBody>
-          <a:bodyPr wrap="square" lIns="0" rIns="0" tIns="0" bIns="0">
-            <a:spAutoFit/>
-          </a:bodyPr>
-          <a:lstStyle/>
-          <a:p>
-            <a:pPr algn="ctr">
-              <a:spcAft>
-                <a:spcPts val="600"/>
-              </a:spcAft>
-            </a:pPr>
-            <a:r>
-              <a:rPr sz="1900" b="1">
-                <a:solidFill>
-                  <a:srgbClr val="9E520A"/>
-                </a:solidFill>
-                <a:latin typeface="Inter"/>
-              </a:rPr>
-              <a:t>Sem protótipo</a:t>
-            </a:r>
-          </a:p>
-          <a:p>
-            <a:pPr algn="ctr">
-              <a:spcAft>
-                <a:spcPts val="600"/>
-              </a:spcAft>
-            </a:pPr>
-            <a:r>
-              <a:rPr sz="1900" b="1">
-                <a:solidFill>
-                  <a:srgbClr val="9E520A"/>
-                </a:solidFill>
-                <a:latin typeface="Inter"/>
-              </a:rPr>
-              <a:t>Release 2 — está mapeada</a:t>
-            </a:r>
-          </a:p>
-        </p:txBody>
-      </p:sp>
-      <p:sp>
-        <p:nvSpPr>
-          <p:cNvPr id="8" name="Rectangle 7"/>
+              <a:t>GF</a:t>
+            </a:r>
+          </a:p>
+        </p:txBody>
+      </p:sp>
+      <p:pic>
+        <p:nvPicPr>
+          <p:cNvPr id="6" name="Picture 5" descr="checkout-pagamento.png"/>
+          <p:cNvPicPr>
+            <a:picLocks noChangeAspect="1"/>
+          </p:cNvPicPr>
+          <p:nvPr/>
+        </p:nvPicPr>
+        <p:blipFill>
+          <a:blip r:embed="rId2"/>
+          <a:stretch>
+            <a:fillRect/>
+          </a:stretch>
+        </p:blipFill>
+        <p:spPr>
+          <a:xfrm>
+            <a:off x="2641044" y="1005840"/>
+            <a:ext cx="6879431" cy="4892040"/>
+          </a:xfrm>
+          <a:prstGeom prst="rect">
+            <a:avLst/>
+          </a:prstGeom>
+        </p:spPr>
+      </p:pic>
+      <p:sp>
+        <p:nvSpPr>
+          <p:cNvPr id="7" name="Rectangle 6"/>
           <p:cNvSpPr/>
           <p:nvPr/>
         </p:nvSpPr>
@@ -6010,7 +6283,7 @@
       </p:sp>
       <p:sp>
         <p:nvSpPr>
-          <p:cNvPr id="9" name="Rectangle 8"/>
+          <p:cNvPr id="8" name="Rectangle 7"/>
           <p:cNvSpPr/>
           <p:nvPr/>
         </p:nvSpPr>
@@ -6054,7 +6327,7 @@
       </p:sp>
       <p:sp>
         <p:nvSpPr>
-          <p:cNvPr id="10" name="TextBox 9"/>
+          <p:cNvPr id="9" name="TextBox 8"/>
           <p:cNvSpPr txBox="1"/>
           <p:nvPr/>
         </p:nvSpPr>
@@ -6086,7 +6359,7 @@
                 </a:solidFill>
                 <a:latin typeface="Inter"/>
               </a:rPr>
-              <a:t>Invalida o QR antigo, emite outro, e valida check-in, lote do destinatário e benefício equivalente.</a:t>
+              <a:t>Calcula subtotal − desconto + taxa, e só confirma após validar que a reserva não expirou.</a:t>
             </a:r>
           </a:p>
         </p:txBody>
@@ -6187,7 +6460,7 @@
                 </a:solidFill>
                 <a:latin typeface="Inter"/>
               </a:rPr>
-              <a:t>09</a:t>
+              <a:t>06</a:t>
             </a:r>
           </a:p>
         </p:txBody>
@@ -6226,7 +6499,7 @@
                 </a:solidFill>
                 <a:latin typeface="Inter"/>
               </a:rPr>
-              <a:t>Cancelamento e reembolso</a:t>
+              <a:t>Pagamento — confirmação</a:t>
             </a:r>
           </a:p>
         </p:txBody>
@@ -6272,7 +6545,7 @@
       </p:sp>
       <p:pic>
         <p:nvPicPr>
-          <p:cNvPr id="6" name="Picture 5" descr="meus-ingressos.png"/>
+          <p:cNvPr id="6" name="Picture 5" descr="confirmacao-compra.png"/>
           <p:cNvPicPr>
             <a:picLocks noChangeAspect="1"/>
           </p:cNvPicPr>
@@ -6286,8 +6559,8 @@
         </p:blipFill>
         <p:spPr>
           <a:xfrm>
-            <a:off x="3095786" y="1005840"/>
-            <a:ext cx="5969947" cy="4892040"/>
+            <a:off x="2641044" y="1005840"/>
+            <a:ext cx="6879431" cy="4892040"/>
           </a:xfrm>
           <a:prstGeom prst="rect">
             <a:avLst/>
@@ -6416,7 +6689,7 @@
                 </a:solidFill>
                 <a:latin typeface="Inter"/>
               </a:rPr>
-              <a:t>Calcula o reembolso por faixas sobre a distância até a data do evento, consultando dois agregados.</a:t>
+              <a:t>Confirmado o pagamento, o sistema emite os ingressos e dá baixa definitiva no lote.</a:t>
             </a:r>
           </a:p>
         </p:txBody>
@@ -6517,7 +6790,7 @@
                 </a:solidFill>
                 <a:latin typeface="Inter"/>
               </a:rPr>
-              <a:t>10</a:t>
+              <a:t>07</a:t>
             </a:r>
           </a:p>
         </p:txBody>
@@ -6556,7 +6829,7 @@
                 </a:solidFill>
                 <a:latin typeface="Inter"/>
               </a:rPr>
-              <a:t>Check-in de participantes</a:t>
+              <a:t>Emissão e entrega do ingresso</a:t>
             </a:r>
           </a:p>
         </p:txBody>
@@ -6595,14 +6868,14 @@
                 </a:solidFill>
                 <a:latin typeface="Inter"/>
               </a:rPr>
-              <a:t>LS</a:t>
+              <a:t>CF</a:t>
             </a:r>
           </a:p>
         </p:txBody>
       </p:sp>
       <p:pic>
         <p:nvPicPr>
-          <p:cNvPr id="6" name="Picture 5" descr="checkin-estados-erro.png"/>
+          <p:cNvPr id="6" name="Picture 5" descr="meus-ingressos.png"/>
           <p:cNvPicPr>
             <a:picLocks noChangeAspect="1"/>
           </p:cNvPicPr>
@@ -6616,8 +6889,8 @@
         </p:blipFill>
         <p:spPr>
           <a:xfrm>
-            <a:off x="2641044" y="1005840"/>
-            <a:ext cx="6879431" cy="4892040"/>
+            <a:off x="3095786" y="1005840"/>
+            <a:ext cx="5969947" cy="4892040"/>
           </a:xfrm>
           <a:prstGeom prst="rect">
             <a:avLst/>
@@ -6746,7 +7019,7 @@
                 </a:solidFill>
                 <a:latin typeface="Inter"/>
               </a:rPr>
-              <a:t>Valida ingresso, pagamento e histórico de check-in em agregados distintos, além da janela de entrada.</a:t>
+              <a:t>A reemissão invalida o código anterior preservando o vínculo, e valida que não houve check-in.</a:t>
             </a:r>
           </a:p>
         </p:txBody>
@@ -6778,7 +7051,7 @@
         <p:spPr>
           <a:xfrm>
             <a:off x="0" y="0"/>
-            <a:ext cx="12191695" cy="1234440"/>
+            <a:ext cx="12191695" cy="868680"/>
           </a:xfrm>
           <a:prstGeom prst="rect">
             <a:avLst/>
@@ -6821,8 +7094,8 @@
         </p:nvSpPr>
         <p:spPr>
           <a:xfrm>
-            <a:off x="731520" y="274320"/>
-            <a:ext cx="9144000" cy="640080"/>
+            <a:off x="640080" y="182880"/>
+            <a:ext cx="731520" cy="457200"/>
           </a:xfrm>
           <a:prstGeom prst="rect">
             <a:avLst/>
@@ -6841,51 +7114,27 @@
               </a:spcAft>
             </a:pPr>
             <a:r>
-              <a:rPr sz="2700" b="1">
-                <a:solidFill>
-                  <a:srgbClr val="FFFFFF"/>
+              <a:rPr sz="2500" b="1">
+                <a:solidFill>
+                  <a:srgbClr val="6B5CF0"/>
                 </a:solidFill>
                 <a:latin typeface="Inter"/>
               </a:rPr>
-              <a:t>Mapa da história do usuário</a:t>
-            </a:r>
-          </a:p>
-        </p:txBody>
-      </p:sp>
-      <p:pic>
-        <p:nvPicPr>
-          <p:cNvPr id="4" name="Picture 3" descr="mapa-historias.png"/>
-          <p:cNvPicPr>
-            <a:picLocks noChangeAspect="1"/>
-          </p:cNvPicPr>
-          <p:nvPr/>
-        </p:nvPicPr>
-        <p:blipFill>
-          <a:blip r:embed="rId2"/>
-          <a:stretch>
-            <a:fillRect/>
-          </a:stretch>
-        </p:blipFill>
-        <p:spPr>
-          <a:xfrm>
-            <a:off x="3463044" y="1463040"/>
-            <a:ext cx="5235431" cy="4114800"/>
-          </a:xfrm>
-          <a:prstGeom prst="rect">
-            <a:avLst/>
-          </a:prstGeom>
-        </p:spPr>
-      </p:pic>
-      <p:sp>
-        <p:nvSpPr>
-          <p:cNvPr id="5" name="TextBox 4"/>
+              <a:t>08</a:t>
+            </a:r>
+          </a:p>
+        </p:txBody>
+      </p:sp>
+      <p:sp>
+        <p:nvSpPr>
+          <p:cNvPr id="4" name="TextBox 3"/>
           <p:cNvSpPr txBox="1"/>
           <p:nvPr/>
         </p:nvSpPr>
         <p:spPr>
           <a:xfrm>
-            <a:off x="731520" y="5806440"/>
-            <a:ext cx="10789920" cy="731520"/>
+            <a:off x="1371600" y="164592"/>
+            <a:ext cx="8595360" cy="548640"/>
           </a:xfrm>
           <a:prstGeom prst="rect">
             <a:avLst/>
@@ -6904,13 +7153,278 @@
               </a:spcAft>
             </a:pPr>
             <a:r>
-              <a:rPr sz="1400" b="0">
-                <a:solidFill>
-                  <a:srgbClr val="5A5C73"/>
+              <a:rPr sz="2400" b="1">
+                <a:solidFill>
+                  <a:srgbClr val="FFFFFF"/>
                 </a:solidFill>
                 <a:latin typeface="Inter"/>
               </a:rPr>
-              <a:t>3 atividades · 11 tarefas · 33 histórias.  A linha marca o corte da Release 1: acima dela dá para publicar um evento, comprar um ingresso e entrar.</a:t>
+              <a:t>Transferência nominal de ingresso</a:t>
+            </a:r>
+          </a:p>
+        </p:txBody>
+      </p:sp>
+      <p:sp>
+        <p:nvSpPr>
+          <p:cNvPr id="5" name="TextBox 4"/>
+          <p:cNvSpPr txBox="1"/>
+          <p:nvPr/>
+        </p:nvSpPr>
+        <p:spPr>
+          <a:xfrm>
+            <a:off x="10424160" y="274320"/>
+            <a:ext cx="1188720" cy="320040"/>
+          </a:xfrm>
+          <a:prstGeom prst="rect">
+            <a:avLst/>
+          </a:prstGeom>
+          <a:noFill/>
+        </p:spPr>
+        <p:txBody>
+          <a:bodyPr wrap="square" lIns="0" rIns="0" tIns="0" bIns="0">
+            <a:spAutoFit/>
+          </a:bodyPr>
+          <a:lstStyle/>
+          <a:p>
+            <a:pPr algn="r">
+              <a:spcAft>
+                <a:spcPts val="0"/>
+              </a:spcAft>
+            </a:pPr>
+            <a:r>
+              <a:rPr sz="1500" b="1">
+                <a:solidFill>
+                  <a:srgbClr val="7B8997"/>
+                </a:solidFill>
+                <a:latin typeface="Inter"/>
+              </a:rPr>
+              <a:t>EM</a:t>
+            </a:r>
+          </a:p>
+        </p:txBody>
+      </p:sp>
+      <p:sp>
+        <p:nvSpPr>
+          <p:cNvPr id="6" name="Rectangle 5"/>
+          <p:cNvSpPr/>
+          <p:nvPr/>
+        </p:nvSpPr>
+        <p:spPr>
+          <a:xfrm>
+            <a:off x="3200400" y="1737360"/>
+            <a:ext cx="5760720" cy="3383280"/>
+          </a:xfrm>
+          <a:prstGeom prst="rect">
+            <a:avLst/>
+          </a:prstGeom>
+          <a:solidFill>
+            <a:srgbClr val="F7F8FC"/>
+          </a:solidFill>
+          <a:ln>
+            <a:noFill/>
+          </a:ln>
+          <a:effectLst/>
+        </p:spPr>
+        <p:style>
+          <a:lnRef idx="1">
+            <a:schemeClr val="accent1"/>
+          </a:lnRef>
+          <a:fillRef idx="3">
+            <a:schemeClr val="accent1"/>
+          </a:fillRef>
+          <a:effectRef idx="2">
+            <a:schemeClr val="accent1"/>
+          </a:effectRef>
+          <a:fontRef idx="minor">
+            <a:schemeClr val="lt1"/>
+          </a:fontRef>
+        </p:style>
+        <p:txBody>
+          <a:bodyPr rtlCol="0" anchor="ctr"/>
+          <a:lstStyle/>
+          <a:p>
+            <a:pPr algn="ctr"/>
+          </a:p>
+        </p:txBody>
+      </p:sp>
+      <p:sp>
+        <p:nvSpPr>
+          <p:cNvPr id="7" name="TextBox 6"/>
+          <p:cNvSpPr txBox="1"/>
+          <p:nvPr/>
+        </p:nvSpPr>
+        <p:spPr>
+          <a:xfrm>
+            <a:off x="3566160" y="3108960"/>
+            <a:ext cx="5029200" cy="822960"/>
+          </a:xfrm>
+          <a:prstGeom prst="rect">
+            <a:avLst/>
+          </a:prstGeom>
+          <a:noFill/>
+        </p:spPr>
+        <p:txBody>
+          <a:bodyPr wrap="square" lIns="0" rIns="0" tIns="0" bIns="0">
+            <a:spAutoFit/>
+          </a:bodyPr>
+          <a:lstStyle/>
+          <a:p>
+            <a:pPr algn="ctr">
+              <a:spcAft>
+                <a:spcPts val="600"/>
+              </a:spcAft>
+            </a:pPr>
+            <a:r>
+              <a:rPr sz="1900" b="1">
+                <a:solidFill>
+                  <a:srgbClr val="9E520A"/>
+                </a:solidFill>
+                <a:latin typeface="Inter"/>
+              </a:rPr>
+              <a:t>Sem protótipo</a:t>
+            </a:r>
+          </a:p>
+          <a:p>
+            <a:pPr algn="ctr">
+              <a:spcAft>
+                <a:spcPts val="600"/>
+              </a:spcAft>
+            </a:pPr>
+            <a:r>
+              <a:rPr sz="1900" b="1">
+                <a:solidFill>
+                  <a:srgbClr val="9E520A"/>
+                </a:solidFill>
+                <a:latin typeface="Inter"/>
+              </a:rPr>
+              <a:t>Release 2 — está mapeada</a:t>
+            </a:r>
+          </a:p>
+        </p:txBody>
+      </p:sp>
+      <p:sp>
+        <p:nvSpPr>
+          <p:cNvPr id="8" name="Rectangle 7"/>
+          <p:cNvSpPr/>
+          <p:nvPr/>
+        </p:nvSpPr>
+        <p:spPr>
+          <a:xfrm>
+            <a:off x="457200" y="6035040"/>
+            <a:ext cx="11247120" cy="658368"/>
+          </a:xfrm>
+          <a:prstGeom prst="rect">
+            <a:avLst/>
+          </a:prstGeom>
+          <a:solidFill>
+            <a:srgbClr val="E2EFEF"/>
+          </a:solidFill>
+          <a:ln>
+            <a:noFill/>
+          </a:ln>
+          <a:effectLst/>
+        </p:spPr>
+        <p:style>
+          <a:lnRef idx="1">
+            <a:schemeClr val="accent1"/>
+          </a:lnRef>
+          <a:fillRef idx="3">
+            <a:schemeClr val="accent1"/>
+          </a:fillRef>
+          <a:effectRef idx="2">
+            <a:schemeClr val="accent1"/>
+          </a:effectRef>
+          <a:fontRef idx="minor">
+            <a:schemeClr val="lt1"/>
+          </a:fontRef>
+        </p:style>
+        <p:txBody>
+          <a:bodyPr rtlCol="0" anchor="ctr"/>
+          <a:lstStyle/>
+          <a:p>
+            <a:pPr algn="ctr"/>
+          </a:p>
+        </p:txBody>
+      </p:sp>
+      <p:sp>
+        <p:nvSpPr>
+          <p:cNvPr id="9" name="Rectangle 8"/>
+          <p:cNvSpPr/>
+          <p:nvPr/>
+        </p:nvSpPr>
+        <p:spPr>
+          <a:xfrm>
+            <a:off x="457200" y="6035040"/>
+            <a:ext cx="54864" cy="658368"/>
+          </a:xfrm>
+          <a:prstGeom prst="rect">
+            <a:avLst/>
+          </a:prstGeom>
+          <a:solidFill>
+            <a:srgbClr val="0B6E73"/>
+          </a:solidFill>
+          <a:ln>
+            <a:noFill/>
+          </a:ln>
+          <a:effectLst/>
+        </p:spPr>
+        <p:style>
+          <a:lnRef idx="1">
+            <a:schemeClr val="accent1"/>
+          </a:lnRef>
+          <a:fillRef idx="3">
+            <a:schemeClr val="accent1"/>
+          </a:fillRef>
+          <a:effectRef idx="2">
+            <a:schemeClr val="accent1"/>
+          </a:effectRef>
+          <a:fontRef idx="minor">
+            <a:schemeClr val="lt1"/>
+          </a:fontRef>
+        </p:style>
+        <p:txBody>
+          <a:bodyPr rtlCol="0" anchor="ctr"/>
+          <a:lstStyle/>
+          <a:p>
+            <a:pPr algn="ctr"/>
+          </a:p>
+        </p:txBody>
+      </p:sp>
+      <p:sp>
+        <p:nvSpPr>
+          <p:cNvPr id="10" name="TextBox 9"/>
+          <p:cNvSpPr txBox="1"/>
+          <p:nvPr/>
+        </p:nvSpPr>
+        <p:spPr>
+          <a:xfrm>
+            <a:off x="777240" y="6144768"/>
+            <a:ext cx="10789920" cy="457200"/>
+          </a:xfrm>
+          <a:prstGeom prst="rect">
+            <a:avLst/>
+          </a:prstGeom>
+          <a:noFill/>
+        </p:spPr>
+        <p:txBody>
+          <a:bodyPr wrap="square" lIns="0" rIns="0" tIns="0" bIns="0">
+            <a:spAutoFit/>
+          </a:bodyPr>
+          <a:lstStyle/>
+          <a:p>
+            <a:pPr algn="l">
+              <a:spcAft>
+                <a:spcPts val="0"/>
+              </a:spcAft>
+            </a:pPr>
+            <a:r>
+              <a:rPr sz="1400" b="0">
+                <a:solidFill>
+                  <a:srgbClr val="1A1B2E"/>
+                </a:solidFill>
+                <a:latin typeface="Inter"/>
+              </a:rPr>
+              <a:t>Invalida o QR antigo, emite outro, e valida check-in, lote do destinatário e benefício equivalente.</a:t>
             </a:r>
           </a:p>
         </p:txBody>
@@ -6942,13 +7456,13 @@
         <p:spPr>
           <a:xfrm>
             <a:off x="0" y="0"/>
-            <a:ext cx="228600" cy="6858000"/>
+            <a:ext cx="12191695" cy="868680"/>
           </a:xfrm>
           <a:prstGeom prst="rect">
             <a:avLst/>
           </a:prstGeom>
           <a:solidFill>
-            <a:srgbClr val="6B5CF0"/>
+            <a:srgbClr val="1A1B2E"/>
           </a:solidFill>
           <a:ln>
             <a:noFill/>
@@ -6985,8 +7499,8 @@
         </p:nvSpPr>
         <p:spPr>
           <a:xfrm>
-            <a:off x="1005840" y="914400"/>
-            <a:ext cx="10058400" cy="731520"/>
+            <a:off x="640080" y="182880"/>
+            <a:ext cx="731520" cy="457200"/>
           </a:xfrm>
           <a:prstGeom prst="rect">
             <a:avLst/>
@@ -7005,13 +7519,13 @@
               </a:spcAft>
             </a:pPr>
             <a:r>
-              <a:rPr sz="3600" b="1">
-                <a:solidFill>
-                  <a:srgbClr val="1A1B2E"/>
+              <a:rPr sz="2500" b="1">
+                <a:solidFill>
+                  <a:srgbClr val="6B5CF0"/>
                 </a:solidFill>
                 <a:latin typeface="Inter"/>
               </a:rPr>
-              <a:t>Próximos passos</a:t>
+              <a:t>09</a:t>
             </a:r>
           </a:p>
         </p:txBody>
@@ -7024,95 +7538,8 @@
         </p:nvSpPr>
         <p:spPr>
           <a:xfrm>
-            <a:off x="1005840" y="2103120"/>
-            <a:ext cx="10241280" cy="3200400"/>
-          </a:xfrm>
-          <a:prstGeom prst="rect">
-            <a:avLst/>
-          </a:prstGeom>
-          <a:noFill/>
-        </p:spPr>
-        <p:txBody>
-          <a:bodyPr wrap="square" lIns="0" rIns="0" tIns="0" bIns="0">
-            <a:spAutoFit/>
-          </a:bodyPr>
-          <a:lstStyle/>
-          <a:p>
-            <a:pPr algn="l">
-              <a:spcAft>
-                <a:spcPts val="1600"/>
-              </a:spcAft>
-            </a:pPr>
-            <a:r>
-              <a:rPr sz="2000" b="0">
-                <a:solidFill>
-                  <a:srgbClr val="5A5C73"/>
-                </a:solidFill>
-                <a:latin typeface="Inter"/>
-              </a:rPr>
-              <a:t>Modelar os subdomínios e o context map no nível estratégico do DDD</a:t>
-            </a:r>
-          </a:p>
-          <a:p>
-            <a:pPr algn="l">
-              <a:spcAft>
-                <a:spcPts val="1600"/>
-              </a:spcAft>
-            </a:pPr>
-            <a:r>
-              <a:rPr sz="2000" b="0">
-                <a:solidFill>
-                  <a:srgbClr val="5A5C73"/>
-                </a:solidFill>
-                <a:latin typeface="Inter"/>
-              </a:rPr>
-              <a:t>Detalhar os agregados de cada bounded context</a:t>
-            </a:r>
-          </a:p>
-          <a:p>
-            <a:pPr algn="l">
-              <a:spcAft>
-                <a:spcPts val="1600"/>
-              </a:spcAft>
-            </a:pPr>
-            <a:r>
-              <a:rPr sz="2000" b="0">
-                <a:solidFill>
-                  <a:srgbClr val="5A5C73"/>
-                </a:solidFill>
-                <a:latin typeface="Inter"/>
-              </a:rPr>
-              <a:t>Escrever os cenários BDD a partir das regras de negócio</a:t>
-            </a:r>
-          </a:p>
-          <a:p>
-            <a:pPr algn="l">
-              <a:spcAft>
-                <a:spcPts val="1600"/>
-              </a:spcAft>
-            </a:pPr>
-            <a:r>
-              <a:rPr sz="2000" b="0">
-                <a:solidFill>
-                  <a:srgbClr val="5A5C73"/>
-                </a:solidFill>
-                <a:latin typeface="Inter"/>
-              </a:rPr>
-              <a:t>Implementar em Java com Spring Boot e JPA, em arquitetura limpa</a:t>
-            </a:r>
-          </a:p>
-        </p:txBody>
-      </p:sp>
-      <p:sp>
-        <p:nvSpPr>
-          <p:cNvPr id="5" name="TextBox 4"/>
-          <p:cNvSpPr txBox="1"/>
-          <p:nvPr/>
-        </p:nvSpPr>
-        <p:spPr>
-          <a:xfrm>
-            <a:off x="1005840" y="5669280"/>
-            <a:ext cx="10058400" cy="457200"/>
+            <a:off x="1371600" y="164592"/>
+            <a:ext cx="8595360" cy="548640"/>
           </a:xfrm>
           <a:prstGeom prst="rect">
             <a:avLst/>
@@ -7131,13 +7558,863 @@
               </a:spcAft>
             </a:pPr>
             <a:r>
-              <a:rPr sz="1500" b="1">
-                <a:solidFill>
-                  <a:srgbClr val="6B5CF0"/>
+              <a:rPr sz="2400" b="1">
+                <a:solidFill>
+                  <a:srgbClr val="FFFFFF"/>
                 </a:solidFill>
                 <a:latin typeface="Inter"/>
               </a:rPr>
-              <a:t>github.com/dudumalheiros/BilhetePass</a:t>
+              <a:t>Cancelamento e reembolso</a:t>
+            </a:r>
+          </a:p>
+        </p:txBody>
+      </p:sp>
+      <p:sp>
+        <p:nvSpPr>
+          <p:cNvPr id="5" name="TextBox 4"/>
+          <p:cNvSpPr txBox="1"/>
+          <p:nvPr/>
+        </p:nvSpPr>
+        <p:spPr>
+          <a:xfrm>
+            <a:off x="10424160" y="274320"/>
+            <a:ext cx="1188720" cy="320040"/>
+          </a:xfrm>
+          <a:prstGeom prst="rect">
+            <a:avLst/>
+          </a:prstGeom>
+          <a:noFill/>
+        </p:spPr>
+        <p:txBody>
+          <a:bodyPr wrap="square" lIns="0" rIns="0" tIns="0" bIns="0">
+            <a:spAutoFit/>
+          </a:bodyPr>
+          <a:lstStyle/>
+          <a:p>
+            <a:pPr algn="r">
+              <a:spcAft>
+                <a:spcPts val="0"/>
+              </a:spcAft>
+            </a:pPr>
+            <a:r>
+              <a:rPr sz="1500" b="1">
+                <a:solidFill>
+                  <a:srgbClr val="7B8997"/>
+                </a:solidFill>
+                <a:latin typeface="Inter"/>
+              </a:rPr>
+              <a:t>GF</a:t>
+            </a:r>
+          </a:p>
+        </p:txBody>
+      </p:sp>
+      <p:pic>
+        <p:nvPicPr>
+          <p:cNvPr id="6" name="Picture 5" descr="meus-ingressos.png"/>
+          <p:cNvPicPr>
+            <a:picLocks noChangeAspect="1"/>
+          </p:cNvPicPr>
+          <p:nvPr/>
+        </p:nvPicPr>
+        <p:blipFill>
+          <a:blip r:embed="rId2"/>
+          <a:stretch>
+            <a:fillRect/>
+          </a:stretch>
+        </p:blipFill>
+        <p:spPr>
+          <a:xfrm>
+            <a:off x="3095786" y="1005840"/>
+            <a:ext cx="5969947" cy="4892040"/>
+          </a:xfrm>
+          <a:prstGeom prst="rect">
+            <a:avLst/>
+          </a:prstGeom>
+        </p:spPr>
+      </p:pic>
+      <p:sp>
+        <p:nvSpPr>
+          <p:cNvPr id="7" name="Rectangle 6"/>
+          <p:cNvSpPr/>
+          <p:nvPr/>
+        </p:nvSpPr>
+        <p:spPr>
+          <a:xfrm>
+            <a:off x="457200" y="6035040"/>
+            <a:ext cx="11247120" cy="658368"/>
+          </a:xfrm>
+          <a:prstGeom prst="rect">
+            <a:avLst/>
+          </a:prstGeom>
+          <a:solidFill>
+            <a:srgbClr val="E2EFEF"/>
+          </a:solidFill>
+          <a:ln>
+            <a:noFill/>
+          </a:ln>
+          <a:effectLst/>
+        </p:spPr>
+        <p:style>
+          <a:lnRef idx="1">
+            <a:schemeClr val="accent1"/>
+          </a:lnRef>
+          <a:fillRef idx="3">
+            <a:schemeClr val="accent1"/>
+          </a:fillRef>
+          <a:effectRef idx="2">
+            <a:schemeClr val="accent1"/>
+          </a:effectRef>
+          <a:fontRef idx="minor">
+            <a:schemeClr val="lt1"/>
+          </a:fontRef>
+        </p:style>
+        <p:txBody>
+          <a:bodyPr rtlCol="0" anchor="ctr"/>
+          <a:lstStyle/>
+          <a:p>
+            <a:pPr algn="ctr"/>
+          </a:p>
+        </p:txBody>
+      </p:sp>
+      <p:sp>
+        <p:nvSpPr>
+          <p:cNvPr id="8" name="Rectangle 7"/>
+          <p:cNvSpPr/>
+          <p:nvPr/>
+        </p:nvSpPr>
+        <p:spPr>
+          <a:xfrm>
+            <a:off x="457200" y="6035040"/>
+            <a:ext cx="54864" cy="658368"/>
+          </a:xfrm>
+          <a:prstGeom prst="rect">
+            <a:avLst/>
+          </a:prstGeom>
+          <a:solidFill>
+            <a:srgbClr val="0B6E73"/>
+          </a:solidFill>
+          <a:ln>
+            <a:noFill/>
+          </a:ln>
+          <a:effectLst/>
+        </p:spPr>
+        <p:style>
+          <a:lnRef idx="1">
+            <a:schemeClr val="accent1"/>
+          </a:lnRef>
+          <a:fillRef idx="3">
+            <a:schemeClr val="accent1"/>
+          </a:fillRef>
+          <a:effectRef idx="2">
+            <a:schemeClr val="accent1"/>
+          </a:effectRef>
+          <a:fontRef idx="minor">
+            <a:schemeClr val="lt1"/>
+          </a:fontRef>
+        </p:style>
+        <p:txBody>
+          <a:bodyPr rtlCol="0" anchor="ctr"/>
+          <a:lstStyle/>
+          <a:p>
+            <a:pPr algn="ctr"/>
+          </a:p>
+        </p:txBody>
+      </p:sp>
+      <p:sp>
+        <p:nvSpPr>
+          <p:cNvPr id="9" name="TextBox 8"/>
+          <p:cNvSpPr txBox="1"/>
+          <p:nvPr/>
+        </p:nvSpPr>
+        <p:spPr>
+          <a:xfrm>
+            <a:off x="777240" y="6144768"/>
+            <a:ext cx="10789920" cy="457200"/>
+          </a:xfrm>
+          <a:prstGeom prst="rect">
+            <a:avLst/>
+          </a:prstGeom>
+          <a:noFill/>
+        </p:spPr>
+        <p:txBody>
+          <a:bodyPr wrap="square" lIns="0" rIns="0" tIns="0" bIns="0">
+            <a:spAutoFit/>
+          </a:bodyPr>
+          <a:lstStyle/>
+          <a:p>
+            <a:pPr algn="l">
+              <a:spcAft>
+                <a:spcPts val="0"/>
+              </a:spcAft>
+            </a:pPr>
+            <a:r>
+              <a:rPr sz="1400" b="0">
+                <a:solidFill>
+                  <a:srgbClr val="1A1B2E"/>
+                </a:solidFill>
+                <a:latin typeface="Inter"/>
+              </a:rPr>
+              <a:t>Calcula o reembolso por faixas sobre a distância até a data do evento, consultando dois agregados.</a:t>
+            </a:r>
+          </a:p>
+        </p:txBody>
+      </p:sp>
+    </p:spTree>
+  </p:cSld>
+  <p:clrMapOvr>
+    <a:masterClrMapping/>
+  </p:clrMapOvr>
+</p:sld>
+</file>
+
+<file path=ppt/slides/slide18.xml><?xml version="1.0" encoding="utf-8"?>
+<p:sld xmlns:a="http://schemas.openxmlformats.org/drawingml/2006/main" xmlns:p="http://schemas.openxmlformats.org/presentationml/2006/main" xmlns:r="http://schemas.openxmlformats.org/officeDocument/2006/relationships">
+  <p:cSld>
+    <p:spTree>
+      <p:nvGrpSpPr>
+        <p:cNvPr id="1" name=""/>
+        <p:cNvGrpSpPr/>
+        <p:nvPr/>
+      </p:nvGrpSpPr>
+      <p:grpSpPr/>
+      <p:sp>
+        <p:nvSpPr>
+          <p:cNvPr id="2" name="Rectangle 1"/>
+          <p:cNvSpPr/>
+          <p:nvPr/>
+        </p:nvSpPr>
+        <p:spPr>
+          <a:xfrm>
+            <a:off x="0" y="0"/>
+            <a:ext cx="12191695" cy="868680"/>
+          </a:xfrm>
+          <a:prstGeom prst="rect">
+            <a:avLst/>
+          </a:prstGeom>
+          <a:solidFill>
+            <a:srgbClr val="1A1B2E"/>
+          </a:solidFill>
+          <a:ln>
+            <a:noFill/>
+          </a:ln>
+          <a:effectLst/>
+        </p:spPr>
+        <p:style>
+          <a:lnRef idx="1">
+            <a:schemeClr val="accent1"/>
+          </a:lnRef>
+          <a:fillRef idx="3">
+            <a:schemeClr val="accent1"/>
+          </a:fillRef>
+          <a:effectRef idx="2">
+            <a:schemeClr val="accent1"/>
+          </a:effectRef>
+          <a:fontRef idx="minor">
+            <a:schemeClr val="lt1"/>
+          </a:fontRef>
+        </p:style>
+        <p:txBody>
+          <a:bodyPr rtlCol="0" anchor="ctr"/>
+          <a:lstStyle/>
+          <a:p>
+            <a:pPr algn="ctr"/>
+          </a:p>
+        </p:txBody>
+      </p:sp>
+      <p:sp>
+        <p:nvSpPr>
+          <p:cNvPr id="3" name="TextBox 2"/>
+          <p:cNvSpPr txBox="1"/>
+          <p:nvPr/>
+        </p:nvSpPr>
+        <p:spPr>
+          <a:xfrm>
+            <a:off x="640080" y="182880"/>
+            <a:ext cx="731520" cy="457200"/>
+          </a:xfrm>
+          <a:prstGeom prst="rect">
+            <a:avLst/>
+          </a:prstGeom>
+          <a:noFill/>
+        </p:spPr>
+        <p:txBody>
+          <a:bodyPr wrap="square" lIns="0" rIns="0" tIns="0" bIns="0">
+            <a:spAutoFit/>
+          </a:bodyPr>
+          <a:lstStyle/>
+          <a:p>
+            <a:pPr algn="l">
+              <a:spcAft>
+                <a:spcPts val="0"/>
+              </a:spcAft>
+            </a:pPr>
+            <a:r>
+              <a:rPr sz="2500" b="1">
+                <a:solidFill>
+                  <a:srgbClr val="6B5CF0"/>
+                </a:solidFill>
+                <a:latin typeface="Inter"/>
+              </a:rPr>
+              <a:t>10</a:t>
+            </a:r>
+          </a:p>
+        </p:txBody>
+      </p:sp>
+      <p:sp>
+        <p:nvSpPr>
+          <p:cNvPr id="4" name="TextBox 3"/>
+          <p:cNvSpPr txBox="1"/>
+          <p:nvPr/>
+        </p:nvSpPr>
+        <p:spPr>
+          <a:xfrm>
+            <a:off x="1371600" y="164592"/>
+            <a:ext cx="8595360" cy="548640"/>
+          </a:xfrm>
+          <a:prstGeom prst="rect">
+            <a:avLst/>
+          </a:prstGeom>
+          <a:noFill/>
+        </p:spPr>
+        <p:txBody>
+          <a:bodyPr wrap="square" lIns="0" rIns="0" tIns="0" bIns="0">
+            <a:spAutoFit/>
+          </a:bodyPr>
+          <a:lstStyle/>
+          <a:p>
+            <a:pPr algn="l">
+              <a:spcAft>
+                <a:spcPts val="0"/>
+              </a:spcAft>
+            </a:pPr>
+            <a:r>
+              <a:rPr sz="2400" b="1">
+                <a:solidFill>
+                  <a:srgbClr val="FFFFFF"/>
+                </a:solidFill>
+                <a:latin typeface="Inter"/>
+              </a:rPr>
+              <a:t>Check-in — leitura aprovada</a:t>
+            </a:r>
+          </a:p>
+        </p:txBody>
+      </p:sp>
+      <p:sp>
+        <p:nvSpPr>
+          <p:cNvPr id="5" name="TextBox 4"/>
+          <p:cNvSpPr txBox="1"/>
+          <p:nvPr/>
+        </p:nvSpPr>
+        <p:spPr>
+          <a:xfrm>
+            <a:off x="10424160" y="274320"/>
+            <a:ext cx="1188720" cy="320040"/>
+          </a:xfrm>
+          <a:prstGeom prst="rect">
+            <a:avLst/>
+          </a:prstGeom>
+          <a:noFill/>
+        </p:spPr>
+        <p:txBody>
+          <a:bodyPr wrap="square" lIns="0" rIns="0" tIns="0" bIns="0">
+            <a:spAutoFit/>
+          </a:bodyPr>
+          <a:lstStyle/>
+          <a:p>
+            <a:pPr algn="r">
+              <a:spcAft>
+                <a:spcPts val="0"/>
+              </a:spcAft>
+            </a:pPr>
+            <a:r>
+              <a:rPr sz="1500" b="1">
+                <a:solidFill>
+                  <a:srgbClr val="7B8997"/>
+                </a:solidFill>
+                <a:latin typeface="Inter"/>
+              </a:rPr>
+              <a:t>LS</a:t>
+            </a:r>
+          </a:p>
+        </p:txBody>
+      </p:sp>
+      <p:pic>
+        <p:nvPicPr>
+          <p:cNvPr id="6" name="Picture 5" descr="checkin-participantes.png"/>
+          <p:cNvPicPr>
+            <a:picLocks noChangeAspect="1"/>
+          </p:cNvPicPr>
+          <p:nvPr/>
+        </p:nvPicPr>
+        <p:blipFill>
+          <a:blip r:embed="rId2"/>
+          <a:stretch>
+            <a:fillRect/>
+          </a:stretch>
+        </p:blipFill>
+        <p:spPr>
+          <a:xfrm>
+            <a:off x="3431109" y="1005840"/>
+            <a:ext cx="5299301" cy="4892039"/>
+          </a:xfrm>
+          <a:prstGeom prst="rect">
+            <a:avLst/>
+          </a:prstGeom>
+        </p:spPr>
+      </p:pic>
+      <p:sp>
+        <p:nvSpPr>
+          <p:cNvPr id="7" name="Rectangle 6"/>
+          <p:cNvSpPr/>
+          <p:nvPr/>
+        </p:nvSpPr>
+        <p:spPr>
+          <a:xfrm>
+            <a:off x="457200" y="6035040"/>
+            <a:ext cx="11247120" cy="658368"/>
+          </a:xfrm>
+          <a:prstGeom prst="rect">
+            <a:avLst/>
+          </a:prstGeom>
+          <a:solidFill>
+            <a:srgbClr val="E2EFEF"/>
+          </a:solidFill>
+          <a:ln>
+            <a:noFill/>
+          </a:ln>
+          <a:effectLst/>
+        </p:spPr>
+        <p:style>
+          <a:lnRef idx="1">
+            <a:schemeClr val="accent1"/>
+          </a:lnRef>
+          <a:fillRef idx="3">
+            <a:schemeClr val="accent1"/>
+          </a:fillRef>
+          <a:effectRef idx="2">
+            <a:schemeClr val="accent1"/>
+          </a:effectRef>
+          <a:fontRef idx="minor">
+            <a:schemeClr val="lt1"/>
+          </a:fontRef>
+        </p:style>
+        <p:txBody>
+          <a:bodyPr rtlCol="0" anchor="ctr"/>
+          <a:lstStyle/>
+          <a:p>
+            <a:pPr algn="ctr"/>
+          </a:p>
+        </p:txBody>
+      </p:sp>
+      <p:sp>
+        <p:nvSpPr>
+          <p:cNvPr id="8" name="Rectangle 7"/>
+          <p:cNvSpPr/>
+          <p:nvPr/>
+        </p:nvSpPr>
+        <p:spPr>
+          <a:xfrm>
+            <a:off x="457200" y="6035040"/>
+            <a:ext cx="54864" cy="658368"/>
+          </a:xfrm>
+          <a:prstGeom prst="rect">
+            <a:avLst/>
+          </a:prstGeom>
+          <a:solidFill>
+            <a:srgbClr val="0B6E73"/>
+          </a:solidFill>
+          <a:ln>
+            <a:noFill/>
+          </a:ln>
+          <a:effectLst/>
+        </p:spPr>
+        <p:style>
+          <a:lnRef idx="1">
+            <a:schemeClr val="accent1"/>
+          </a:lnRef>
+          <a:fillRef idx="3">
+            <a:schemeClr val="accent1"/>
+          </a:fillRef>
+          <a:effectRef idx="2">
+            <a:schemeClr val="accent1"/>
+          </a:effectRef>
+          <a:fontRef idx="minor">
+            <a:schemeClr val="lt1"/>
+          </a:fontRef>
+        </p:style>
+        <p:txBody>
+          <a:bodyPr rtlCol="0" anchor="ctr"/>
+          <a:lstStyle/>
+          <a:p>
+            <a:pPr algn="ctr"/>
+          </a:p>
+        </p:txBody>
+      </p:sp>
+      <p:sp>
+        <p:nvSpPr>
+          <p:cNvPr id="9" name="TextBox 8"/>
+          <p:cNvSpPr txBox="1"/>
+          <p:nvPr/>
+        </p:nvSpPr>
+        <p:spPr>
+          <a:xfrm>
+            <a:off x="777240" y="6144768"/>
+            <a:ext cx="10789920" cy="457200"/>
+          </a:xfrm>
+          <a:prstGeom prst="rect">
+            <a:avLst/>
+          </a:prstGeom>
+          <a:noFill/>
+        </p:spPr>
+        <p:txBody>
+          <a:bodyPr wrap="square" lIns="0" rIns="0" tIns="0" bIns="0">
+            <a:spAutoFit/>
+          </a:bodyPr>
+          <a:lstStyle/>
+          <a:p>
+            <a:pPr algn="l">
+              <a:spcAft>
+                <a:spcPts val="0"/>
+              </a:spcAft>
+            </a:pPr>
+            <a:r>
+              <a:rPr sz="1400" b="0">
+                <a:solidFill>
+                  <a:srgbClr val="1A1B2E"/>
+                </a:solidFill>
+                <a:latin typeface="Inter"/>
+              </a:rPr>
+              <a:t>A leitura aprovada grava data, hora e operador: o registro de auditoria do check-in.</a:t>
+            </a:r>
+          </a:p>
+        </p:txBody>
+      </p:sp>
+    </p:spTree>
+  </p:cSld>
+  <p:clrMapOvr>
+    <a:masterClrMapping/>
+  </p:clrMapOvr>
+</p:sld>
+</file>
+
+<file path=ppt/slides/slide19.xml><?xml version="1.0" encoding="utf-8"?>
+<p:sld xmlns:a="http://schemas.openxmlformats.org/drawingml/2006/main" xmlns:p="http://schemas.openxmlformats.org/presentationml/2006/main" xmlns:r="http://schemas.openxmlformats.org/officeDocument/2006/relationships">
+  <p:cSld>
+    <p:spTree>
+      <p:nvGrpSpPr>
+        <p:cNvPr id="1" name=""/>
+        <p:cNvGrpSpPr/>
+        <p:nvPr/>
+      </p:nvGrpSpPr>
+      <p:grpSpPr/>
+      <p:sp>
+        <p:nvSpPr>
+          <p:cNvPr id="2" name="Rectangle 1"/>
+          <p:cNvSpPr/>
+          <p:nvPr/>
+        </p:nvSpPr>
+        <p:spPr>
+          <a:xfrm>
+            <a:off x="0" y="0"/>
+            <a:ext cx="12191695" cy="868680"/>
+          </a:xfrm>
+          <a:prstGeom prst="rect">
+            <a:avLst/>
+          </a:prstGeom>
+          <a:solidFill>
+            <a:srgbClr val="1A1B2E"/>
+          </a:solidFill>
+          <a:ln>
+            <a:noFill/>
+          </a:ln>
+          <a:effectLst/>
+        </p:spPr>
+        <p:style>
+          <a:lnRef idx="1">
+            <a:schemeClr val="accent1"/>
+          </a:lnRef>
+          <a:fillRef idx="3">
+            <a:schemeClr val="accent1"/>
+          </a:fillRef>
+          <a:effectRef idx="2">
+            <a:schemeClr val="accent1"/>
+          </a:effectRef>
+          <a:fontRef idx="minor">
+            <a:schemeClr val="lt1"/>
+          </a:fontRef>
+        </p:style>
+        <p:txBody>
+          <a:bodyPr rtlCol="0" anchor="ctr"/>
+          <a:lstStyle/>
+          <a:p>
+            <a:pPr algn="ctr"/>
+          </a:p>
+        </p:txBody>
+      </p:sp>
+      <p:sp>
+        <p:nvSpPr>
+          <p:cNvPr id="3" name="TextBox 2"/>
+          <p:cNvSpPr txBox="1"/>
+          <p:nvPr/>
+        </p:nvSpPr>
+        <p:spPr>
+          <a:xfrm>
+            <a:off x="640080" y="182880"/>
+            <a:ext cx="731520" cy="457200"/>
+          </a:xfrm>
+          <a:prstGeom prst="rect">
+            <a:avLst/>
+          </a:prstGeom>
+          <a:noFill/>
+        </p:spPr>
+        <p:txBody>
+          <a:bodyPr wrap="square" lIns="0" rIns="0" tIns="0" bIns="0">
+            <a:spAutoFit/>
+          </a:bodyPr>
+          <a:lstStyle/>
+          <a:p>
+            <a:pPr algn="l">
+              <a:spcAft>
+                <a:spcPts val="0"/>
+              </a:spcAft>
+            </a:pPr>
+            <a:r>
+              <a:rPr sz="2500" b="1">
+                <a:solidFill>
+                  <a:srgbClr val="6B5CF0"/>
+                </a:solidFill>
+                <a:latin typeface="Inter"/>
+              </a:rPr>
+              <a:t>10</a:t>
+            </a:r>
+          </a:p>
+        </p:txBody>
+      </p:sp>
+      <p:sp>
+        <p:nvSpPr>
+          <p:cNvPr id="4" name="TextBox 3"/>
+          <p:cNvSpPr txBox="1"/>
+          <p:nvPr/>
+        </p:nvSpPr>
+        <p:spPr>
+          <a:xfrm>
+            <a:off x="1371600" y="164592"/>
+            <a:ext cx="8595360" cy="548640"/>
+          </a:xfrm>
+          <a:prstGeom prst="rect">
+            <a:avLst/>
+          </a:prstGeom>
+          <a:noFill/>
+        </p:spPr>
+        <p:txBody>
+          <a:bodyPr wrap="square" lIns="0" rIns="0" tIns="0" bIns="0">
+            <a:spAutoFit/>
+          </a:bodyPr>
+          <a:lstStyle/>
+          <a:p>
+            <a:pPr algn="l">
+              <a:spcAft>
+                <a:spcPts val="0"/>
+              </a:spcAft>
+            </a:pPr>
+            <a:r>
+              <a:rPr sz="2400" b="1">
+                <a:solidFill>
+                  <a:srgbClr val="FFFFFF"/>
+                </a:solidFill>
+                <a:latin typeface="Inter"/>
+              </a:rPr>
+              <a:t>Check-in — casos de recusa</a:t>
+            </a:r>
+          </a:p>
+        </p:txBody>
+      </p:sp>
+      <p:sp>
+        <p:nvSpPr>
+          <p:cNvPr id="5" name="TextBox 4"/>
+          <p:cNvSpPr txBox="1"/>
+          <p:nvPr/>
+        </p:nvSpPr>
+        <p:spPr>
+          <a:xfrm>
+            <a:off x="10424160" y="274320"/>
+            <a:ext cx="1188720" cy="320040"/>
+          </a:xfrm>
+          <a:prstGeom prst="rect">
+            <a:avLst/>
+          </a:prstGeom>
+          <a:noFill/>
+        </p:spPr>
+        <p:txBody>
+          <a:bodyPr wrap="square" lIns="0" rIns="0" tIns="0" bIns="0">
+            <a:spAutoFit/>
+          </a:bodyPr>
+          <a:lstStyle/>
+          <a:p>
+            <a:pPr algn="r">
+              <a:spcAft>
+                <a:spcPts val="0"/>
+              </a:spcAft>
+            </a:pPr>
+            <a:r>
+              <a:rPr sz="1500" b="1">
+                <a:solidFill>
+                  <a:srgbClr val="7B8997"/>
+                </a:solidFill>
+                <a:latin typeface="Inter"/>
+              </a:rPr>
+              <a:t>LS</a:t>
+            </a:r>
+          </a:p>
+        </p:txBody>
+      </p:sp>
+      <p:pic>
+        <p:nvPicPr>
+          <p:cNvPr id="6" name="Picture 5" descr="checkin-estados-erro.png"/>
+          <p:cNvPicPr>
+            <a:picLocks noChangeAspect="1"/>
+          </p:cNvPicPr>
+          <p:nvPr/>
+        </p:nvPicPr>
+        <p:blipFill>
+          <a:blip r:embed="rId2"/>
+          <a:stretch>
+            <a:fillRect/>
+          </a:stretch>
+        </p:blipFill>
+        <p:spPr>
+          <a:xfrm>
+            <a:off x="2641044" y="1005840"/>
+            <a:ext cx="6879431" cy="4892040"/>
+          </a:xfrm>
+          <a:prstGeom prst="rect">
+            <a:avLst/>
+          </a:prstGeom>
+        </p:spPr>
+      </p:pic>
+      <p:sp>
+        <p:nvSpPr>
+          <p:cNvPr id="7" name="Rectangle 6"/>
+          <p:cNvSpPr/>
+          <p:nvPr/>
+        </p:nvSpPr>
+        <p:spPr>
+          <a:xfrm>
+            <a:off x="457200" y="6035040"/>
+            <a:ext cx="11247120" cy="658368"/>
+          </a:xfrm>
+          <a:prstGeom prst="rect">
+            <a:avLst/>
+          </a:prstGeom>
+          <a:solidFill>
+            <a:srgbClr val="E2EFEF"/>
+          </a:solidFill>
+          <a:ln>
+            <a:noFill/>
+          </a:ln>
+          <a:effectLst/>
+        </p:spPr>
+        <p:style>
+          <a:lnRef idx="1">
+            <a:schemeClr val="accent1"/>
+          </a:lnRef>
+          <a:fillRef idx="3">
+            <a:schemeClr val="accent1"/>
+          </a:fillRef>
+          <a:effectRef idx="2">
+            <a:schemeClr val="accent1"/>
+          </a:effectRef>
+          <a:fontRef idx="minor">
+            <a:schemeClr val="lt1"/>
+          </a:fontRef>
+        </p:style>
+        <p:txBody>
+          <a:bodyPr rtlCol="0" anchor="ctr"/>
+          <a:lstStyle/>
+          <a:p>
+            <a:pPr algn="ctr"/>
+          </a:p>
+        </p:txBody>
+      </p:sp>
+      <p:sp>
+        <p:nvSpPr>
+          <p:cNvPr id="8" name="Rectangle 7"/>
+          <p:cNvSpPr/>
+          <p:nvPr/>
+        </p:nvSpPr>
+        <p:spPr>
+          <a:xfrm>
+            <a:off x="457200" y="6035040"/>
+            <a:ext cx="54864" cy="658368"/>
+          </a:xfrm>
+          <a:prstGeom prst="rect">
+            <a:avLst/>
+          </a:prstGeom>
+          <a:solidFill>
+            <a:srgbClr val="0B6E73"/>
+          </a:solidFill>
+          <a:ln>
+            <a:noFill/>
+          </a:ln>
+          <a:effectLst/>
+        </p:spPr>
+        <p:style>
+          <a:lnRef idx="1">
+            <a:schemeClr val="accent1"/>
+          </a:lnRef>
+          <a:fillRef idx="3">
+            <a:schemeClr val="accent1"/>
+          </a:fillRef>
+          <a:effectRef idx="2">
+            <a:schemeClr val="accent1"/>
+          </a:effectRef>
+          <a:fontRef idx="minor">
+            <a:schemeClr val="lt1"/>
+          </a:fontRef>
+        </p:style>
+        <p:txBody>
+          <a:bodyPr rtlCol="0" anchor="ctr"/>
+          <a:lstStyle/>
+          <a:p>
+            <a:pPr algn="ctr"/>
+          </a:p>
+        </p:txBody>
+      </p:sp>
+      <p:sp>
+        <p:nvSpPr>
+          <p:cNvPr id="9" name="TextBox 8"/>
+          <p:cNvSpPr txBox="1"/>
+          <p:nvPr/>
+        </p:nvSpPr>
+        <p:spPr>
+          <a:xfrm>
+            <a:off x="777240" y="6144768"/>
+            <a:ext cx="10789920" cy="457200"/>
+          </a:xfrm>
+          <a:prstGeom prst="rect">
+            <a:avLst/>
+          </a:prstGeom>
+          <a:noFill/>
+        </p:spPr>
+        <p:txBody>
+          <a:bodyPr wrap="square" lIns="0" rIns="0" tIns="0" bIns="0">
+            <a:spAutoFit/>
+          </a:bodyPr>
+          <a:lstStyle/>
+          <a:p>
+            <a:pPr algn="l">
+              <a:spcAft>
+                <a:spcPts val="0"/>
+              </a:spcAft>
+            </a:pPr>
+            <a:r>
+              <a:rPr sz="1400" b="0">
+                <a:solidFill>
+                  <a:srgbClr val="1A1B2E"/>
+                </a:solidFill>
+                <a:latin typeface="Inter"/>
+              </a:rPr>
+              <a:t>Valida ingresso, pagamento e histórico de check-in em agregados distintos, além da janela de entrada.</a:t>
             </a:r>
           </a:p>
         </p:txBody>
@@ -7534,6 +8811,397 @@
 </p:sld>
 </file>
 
+<file path=ppt/slides/slide20.xml><?xml version="1.0" encoding="utf-8"?>
+<p:sld xmlns:a="http://schemas.openxmlformats.org/drawingml/2006/main" xmlns:p="http://schemas.openxmlformats.org/presentationml/2006/main" xmlns:r="http://schemas.openxmlformats.org/officeDocument/2006/relationships">
+  <p:cSld>
+    <p:spTree>
+      <p:nvGrpSpPr>
+        <p:cNvPr id="1" name=""/>
+        <p:cNvGrpSpPr/>
+        <p:nvPr/>
+      </p:nvGrpSpPr>
+      <p:grpSpPr/>
+      <p:sp>
+        <p:nvSpPr>
+          <p:cNvPr id="2" name="Rectangle 1"/>
+          <p:cNvSpPr/>
+          <p:nvPr/>
+        </p:nvSpPr>
+        <p:spPr>
+          <a:xfrm>
+            <a:off x="0" y="0"/>
+            <a:ext cx="12191695" cy="1234440"/>
+          </a:xfrm>
+          <a:prstGeom prst="rect">
+            <a:avLst/>
+          </a:prstGeom>
+          <a:solidFill>
+            <a:srgbClr val="1A1B2E"/>
+          </a:solidFill>
+          <a:ln>
+            <a:noFill/>
+          </a:ln>
+          <a:effectLst/>
+        </p:spPr>
+        <p:style>
+          <a:lnRef idx="1">
+            <a:schemeClr val="accent1"/>
+          </a:lnRef>
+          <a:fillRef idx="3">
+            <a:schemeClr val="accent1"/>
+          </a:fillRef>
+          <a:effectRef idx="2">
+            <a:schemeClr val="accent1"/>
+          </a:effectRef>
+          <a:fontRef idx="minor">
+            <a:schemeClr val="lt1"/>
+          </a:fontRef>
+        </p:style>
+        <p:txBody>
+          <a:bodyPr rtlCol="0" anchor="ctr"/>
+          <a:lstStyle/>
+          <a:p>
+            <a:pPr algn="ctr"/>
+          </a:p>
+        </p:txBody>
+      </p:sp>
+      <p:sp>
+        <p:nvSpPr>
+          <p:cNvPr id="3" name="TextBox 2"/>
+          <p:cNvSpPr txBox="1"/>
+          <p:nvPr/>
+        </p:nvSpPr>
+        <p:spPr>
+          <a:xfrm>
+            <a:off x="731520" y="274320"/>
+            <a:ext cx="9144000" cy="640080"/>
+          </a:xfrm>
+          <a:prstGeom prst="rect">
+            <a:avLst/>
+          </a:prstGeom>
+          <a:noFill/>
+        </p:spPr>
+        <p:txBody>
+          <a:bodyPr wrap="square" lIns="0" rIns="0" tIns="0" bIns="0">
+            <a:spAutoFit/>
+          </a:bodyPr>
+          <a:lstStyle/>
+          <a:p>
+            <a:pPr algn="l">
+              <a:spcAft>
+                <a:spcPts val="0"/>
+              </a:spcAft>
+            </a:pPr>
+            <a:r>
+              <a:rPr sz="2700" b="1">
+                <a:solidFill>
+                  <a:srgbClr val="FFFFFF"/>
+                </a:solidFill>
+                <a:latin typeface="Inter"/>
+              </a:rPr>
+              <a:t>Mapa da história do usuário</a:t>
+            </a:r>
+          </a:p>
+        </p:txBody>
+      </p:sp>
+      <p:pic>
+        <p:nvPicPr>
+          <p:cNvPr id="4" name="Picture 3" descr="mapa-historias.png"/>
+          <p:cNvPicPr>
+            <a:picLocks noChangeAspect="1"/>
+          </p:cNvPicPr>
+          <p:nvPr/>
+        </p:nvPicPr>
+        <p:blipFill>
+          <a:blip r:embed="rId2"/>
+          <a:stretch>
+            <a:fillRect/>
+          </a:stretch>
+        </p:blipFill>
+        <p:spPr>
+          <a:xfrm>
+            <a:off x="3463044" y="1463040"/>
+            <a:ext cx="5235431" cy="4114800"/>
+          </a:xfrm>
+          <a:prstGeom prst="rect">
+            <a:avLst/>
+          </a:prstGeom>
+        </p:spPr>
+      </p:pic>
+      <p:sp>
+        <p:nvSpPr>
+          <p:cNvPr id="5" name="TextBox 4"/>
+          <p:cNvSpPr txBox="1"/>
+          <p:nvPr/>
+        </p:nvSpPr>
+        <p:spPr>
+          <a:xfrm>
+            <a:off x="731520" y="5806440"/>
+            <a:ext cx="10789920" cy="731520"/>
+          </a:xfrm>
+          <a:prstGeom prst="rect">
+            <a:avLst/>
+          </a:prstGeom>
+          <a:noFill/>
+        </p:spPr>
+        <p:txBody>
+          <a:bodyPr wrap="square" lIns="0" rIns="0" tIns="0" bIns="0">
+            <a:spAutoFit/>
+          </a:bodyPr>
+          <a:lstStyle/>
+          <a:p>
+            <a:pPr algn="l">
+              <a:spcAft>
+                <a:spcPts val="0"/>
+              </a:spcAft>
+            </a:pPr>
+            <a:r>
+              <a:rPr sz="1400" b="0">
+                <a:solidFill>
+                  <a:srgbClr val="5A5C73"/>
+                </a:solidFill>
+                <a:latin typeface="Inter"/>
+              </a:rPr>
+              <a:t>3 atividades · 11 tarefas · 33 histórias.  A linha marca o corte da Release 1: acima dela dá para publicar um evento, comprar um ingresso e entrar.</a:t>
+            </a:r>
+          </a:p>
+        </p:txBody>
+      </p:sp>
+    </p:spTree>
+  </p:cSld>
+  <p:clrMapOvr>
+    <a:masterClrMapping/>
+  </p:clrMapOvr>
+</p:sld>
+</file>
+
+<file path=ppt/slides/slide21.xml><?xml version="1.0" encoding="utf-8"?>
+<p:sld xmlns:a="http://schemas.openxmlformats.org/drawingml/2006/main" xmlns:p="http://schemas.openxmlformats.org/presentationml/2006/main" xmlns:r="http://schemas.openxmlformats.org/officeDocument/2006/relationships">
+  <p:cSld>
+    <p:spTree>
+      <p:nvGrpSpPr>
+        <p:cNvPr id="1" name=""/>
+        <p:cNvGrpSpPr/>
+        <p:nvPr/>
+      </p:nvGrpSpPr>
+      <p:grpSpPr/>
+      <p:sp>
+        <p:nvSpPr>
+          <p:cNvPr id="2" name="Rectangle 1"/>
+          <p:cNvSpPr/>
+          <p:nvPr/>
+        </p:nvSpPr>
+        <p:spPr>
+          <a:xfrm>
+            <a:off x="0" y="0"/>
+            <a:ext cx="228600" cy="6858000"/>
+          </a:xfrm>
+          <a:prstGeom prst="rect">
+            <a:avLst/>
+          </a:prstGeom>
+          <a:solidFill>
+            <a:srgbClr val="6B5CF0"/>
+          </a:solidFill>
+          <a:ln>
+            <a:noFill/>
+          </a:ln>
+          <a:effectLst/>
+        </p:spPr>
+        <p:style>
+          <a:lnRef idx="1">
+            <a:schemeClr val="accent1"/>
+          </a:lnRef>
+          <a:fillRef idx="3">
+            <a:schemeClr val="accent1"/>
+          </a:fillRef>
+          <a:effectRef idx="2">
+            <a:schemeClr val="accent1"/>
+          </a:effectRef>
+          <a:fontRef idx="minor">
+            <a:schemeClr val="lt1"/>
+          </a:fontRef>
+        </p:style>
+        <p:txBody>
+          <a:bodyPr rtlCol="0" anchor="ctr"/>
+          <a:lstStyle/>
+          <a:p>
+            <a:pPr algn="ctr"/>
+          </a:p>
+        </p:txBody>
+      </p:sp>
+      <p:sp>
+        <p:nvSpPr>
+          <p:cNvPr id="3" name="TextBox 2"/>
+          <p:cNvSpPr txBox="1"/>
+          <p:nvPr/>
+        </p:nvSpPr>
+        <p:spPr>
+          <a:xfrm>
+            <a:off x="1005840" y="914400"/>
+            <a:ext cx="10058400" cy="731520"/>
+          </a:xfrm>
+          <a:prstGeom prst="rect">
+            <a:avLst/>
+          </a:prstGeom>
+          <a:noFill/>
+        </p:spPr>
+        <p:txBody>
+          <a:bodyPr wrap="square" lIns="0" rIns="0" tIns="0" bIns="0">
+            <a:spAutoFit/>
+          </a:bodyPr>
+          <a:lstStyle/>
+          <a:p>
+            <a:pPr algn="l">
+              <a:spcAft>
+                <a:spcPts val="0"/>
+              </a:spcAft>
+            </a:pPr>
+            <a:r>
+              <a:rPr sz="3600" b="1">
+                <a:solidFill>
+                  <a:srgbClr val="1A1B2E"/>
+                </a:solidFill>
+                <a:latin typeface="Inter"/>
+              </a:rPr>
+              <a:t>Próximos passos</a:t>
+            </a:r>
+          </a:p>
+        </p:txBody>
+      </p:sp>
+      <p:sp>
+        <p:nvSpPr>
+          <p:cNvPr id="4" name="TextBox 3"/>
+          <p:cNvSpPr txBox="1"/>
+          <p:nvPr/>
+        </p:nvSpPr>
+        <p:spPr>
+          <a:xfrm>
+            <a:off x="1005840" y="2103120"/>
+            <a:ext cx="10241280" cy="3200400"/>
+          </a:xfrm>
+          <a:prstGeom prst="rect">
+            <a:avLst/>
+          </a:prstGeom>
+          <a:noFill/>
+        </p:spPr>
+        <p:txBody>
+          <a:bodyPr wrap="square" lIns="0" rIns="0" tIns="0" bIns="0">
+            <a:spAutoFit/>
+          </a:bodyPr>
+          <a:lstStyle/>
+          <a:p>
+            <a:pPr algn="l">
+              <a:spcAft>
+                <a:spcPts val="1600"/>
+              </a:spcAft>
+            </a:pPr>
+            <a:r>
+              <a:rPr sz="2000" b="0">
+                <a:solidFill>
+                  <a:srgbClr val="5A5C73"/>
+                </a:solidFill>
+                <a:latin typeface="Inter"/>
+              </a:rPr>
+              <a:t>Modelar os subdomínios e o context map no nível estratégico do DDD</a:t>
+            </a:r>
+          </a:p>
+          <a:p>
+            <a:pPr algn="l">
+              <a:spcAft>
+                <a:spcPts val="1600"/>
+              </a:spcAft>
+            </a:pPr>
+            <a:r>
+              <a:rPr sz="2000" b="0">
+                <a:solidFill>
+                  <a:srgbClr val="5A5C73"/>
+                </a:solidFill>
+                <a:latin typeface="Inter"/>
+              </a:rPr>
+              <a:t>Detalhar os agregados de cada bounded context</a:t>
+            </a:r>
+          </a:p>
+          <a:p>
+            <a:pPr algn="l">
+              <a:spcAft>
+                <a:spcPts val="1600"/>
+              </a:spcAft>
+            </a:pPr>
+            <a:r>
+              <a:rPr sz="2000" b="0">
+                <a:solidFill>
+                  <a:srgbClr val="5A5C73"/>
+                </a:solidFill>
+                <a:latin typeface="Inter"/>
+              </a:rPr>
+              <a:t>Escrever os cenários BDD a partir das regras de negócio</a:t>
+            </a:r>
+          </a:p>
+          <a:p>
+            <a:pPr algn="l">
+              <a:spcAft>
+                <a:spcPts val="1600"/>
+              </a:spcAft>
+            </a:pPr>
+            <a:r>
+              <a:rPr sz="2000" b="0">
+                <a:solidFill>
+                  <a:srgbClr val="5A5C73"/>
+                </a:solidFill>
+                <a:latin typeface="Inter"/>
+              </a:rPr>
+              <a:t>Implementar em Java com Spring Boot e JPA, em arquitetura limpa</a:t>
+            </a:r>
+          </a:p>
+        </p:txBody>
+      </p:sp>
+      <p:sp>
+        <p:nvSpPr>
+          <p:cNvPr id="5" name="TextBox 4"/>
+          <p:cNvSpPr txBox="1"/>
+          <p:nvPr/>
+        </p:nvSpPr>
+        <p:spPr>
+          <a:xfrm>
+            <a:off x="1005840" y="5669280"/>
+            <a:ext cx="10058400" cy="457200"/>
+          </a:xfrm>
+          <a:prstGeom prst="rect">
+            <a:avLst/>
+          </a:prstGeom>
+          <a:noFill/>
+        </p:spPr>
+        <p:txBody>
+          <a:bodyPr wrap="square" lIns="0" rIns="0" tIns="0" bIns="0">
+            <a:spAutoFit/>
+          </a:bodyPr>
+          <a:lstStyle/>
+          <a:p>
+            <a:pPr algn="l">
+              <a:spcAft>
+                <a:spcPts val="0"/>
+              </a:spcAft>
+            </a:pPr>
+            <a:r>
+              <a:rPr sz="1500" b="1">
+                <a:solidFill>
+                  <a:srgbClr val="6B5CF0"/>
+                </a:solidFill>
+                <a:latin typeface="Inter"/>
+              </a:rPr>
+              <a:t>github.com/dudumalheiros/BilhetePass</a:t>
+            </a:r>
+          </a:p>
+        </p:txBody>
+      </p:sp>
+    </p:spTree>
+  </p:cSld>
+  <p:clrMapOvr>
+    <a:masterClrMapping/>
+  </p:clrMapOvr>
+</p:sld>
+</file>
+
 <file path=ppt/slides/slide3.xml><?xml version="1.0" encoding="utf-8"?>
 <p:sld xmlns:a="http://schemas.openxmlformats.org/drawingml/2006/main" xmlns:p="http://schemas.openxmlformats.org/presentationml/2006/main" xmlns:r="http://schemas.openxmlformats.org/officeDocument/2006/relationships">
   <p:cSld>
@@ -9703,7 +11371,7 @@
                 </a:solidFill>
                 <a:latin typeface="Inter"/>
               </a:rPr>
-              <a:t>Venda de ingressos</a:t>
+              <a:t>Venda de ingressos — a página do evento</a:t>
             </a:r>
           </a:p>
         </p:txBody>
@@ -9749,7 +11417,7 @@
       </p:sp>
       <p:pic>
         <p:nvPicPr>
-          <p:cNvPr id="6" name="Picture 5" descr="selecao-de-ingressos.png"/>
+          <p:cNvPr id="6" name="Picture 5" descr="detalhe-do-evento.png"/>
           <p:cNvPicPr>
             <a:picLocks noChangeAspect="1"/>
           </p:cNvPicPr>
@@ -9763,8 +11431,8 @@
         </p:blipFill>
         <p:spPr>
           <a:xfrm>
-            <a:off x="3316027" y="1005840"/>
-            <a:ext cx="5529464" cy="4892040"/>
+            <a:off x="4059951" y="1005840"/>
+            <a:ext cx="4041616" cy="4892040"/>
           </a:xfrm>
           <a:prstGeom prst="rect">
             <a:avLst/>
@@ -9893,7 +11561,7 @@
                 </a:solidFill>
                 <a:latin typeface="Inter"/>
               </a:rPr>
-              <a:t>Consulta o lote vigente e os já vendidos, e calcula o desconto sobre um cupom validado em quatro critérios.</a:t>
+              <a:t>O preço exibido vem do lote vigente na data; o Esgotado vem da contagem de vendidos.</a:t>
             </a:r>
           </a:p>
         </p:txBody>
@@ -9994,7 +11662,7 @@
                 </a:solidFill>
                 <a:latin typeface="Inter"/>
               </a:rPr>
-              <a:t>04</a:t>
+              <a:t>03</a:t>
             </a:r>
           </a:p>
         </p:txBody>
@@ -10033,7 +11701,7 @@
                 </a:solidFill>
                 <a:latin typeface="Inter"/>
               </a:rPr>
-              <a:t>Meia-entrada: benefício e cota</a:t>
+              <a:t>Venda de ingressos — seleção</a:t>
             </a:r>
           </a:p>
         </p:txBody>
@@ -10072,14 +11740,14 @@
                 </a:solidFill>
                 <a:latin typeface="Inter"/>
               </a:rPr>
-              <a:t>EM</a:t>
+              <a:t>LS</a:t>
             </a:r>
           </a:p>
         </p:txBody>
       </p:sp>
       <p:pic>
         <p:nvPicPr>
-          <p:cNvPr id="6" name="Picture 5" descr="configuracao-de-ingressos.png"/>
+          <p:cNvPr id="6" name="Picture 5" descr="selecao-de-ingressos.png"/>
           <p:cNvPicPr>
             <a:picLocks noChangeAspect="1"/>
           </p:cNvPicPr>
@@ -10093,8 +11761,8 @@
         </p:blipFill>
         <p:spPr>
           <a:xfrm>
-            <a:off x="3985418" y="1005840"/>
-            <a:ext cx="4190682" cy="4892040"/>
+            <a:off x="3316027" y="1005840"/>
+            <a:ext cx="5529464" cy="4892040"/>
           </a:xfrm>
           <a:prstGeom prst="rect">
             <a:avLst/>
@@ -10223,7 +11891,7 @@
                 </a:solidFill>
                 <a:latin typeface="Inter"/>
               </a:rPr>
-              <a:t>A cota de meia é calculada como percentual do lote; sem comprovação, o ingresso é recalculado para inteira.</a:t>
+              <a:t>Consulta o lote vigente e os já vendidos, e calcula o desconto sobre um cupom validado em quatro critérios.</a:t>
             </a:r>
           </a:p>
         </p:txBody>

</xml_diff>

<commit_message>
Atualiza o deck para as 15 funcionalidades da nova decomposição
</commit_message>
<xml_diff>
--- a/docs/slides/BilhetePass-apresentacao.pptx
+++ b/docs/slides/BilhetePass-apresentacao.pptx
@@ -527,7 +527,7 @@
           </a:p>
           <a:p>
             <a:r>
-              <a:t>No Resumo: “Capacidade dos lotes (1.950) excede a do local (1.800)” e o botão Publicar desabilitado.</a:t>
+              <a:t>Sem protótipo ainda.</a:t>
             </a:r>
           </a:p>
           <a:p/>
@@ -538,7 +538,7 @@
           </a:p>
           <a:p>
             <a:r>
-              <a:t>Publicar exige CALCULAR a soma das capacidades de todos os lotes do evento e VALIDAR esse total contra a capacidade do local escolhido.</a:t>
+              <a:t>Aceitar uma proposta exige VALIDAR que a data ainda está livre — duas propostas podem disputar o mesmo fim de semana — e bloquear uma data exige CONSULTAR se já existe reserva confirmada nela.</a:t>
             </a:r>
           </a:p>
         </p:txBody>
@@ -613,7 +613,7 @@
           </a:p>
           <a:p>
             <a:r>
-              <a:t>A confirmação da compra, fechando o fluxo e liberando a emissão dos ingressos.</a:t>
+              <a:t>Sem protótipo ainda.</a:t>
             </a:r>
           </a:p>
           <a:p/>
@@ -624,7 +624,7 @@
           </a:p>
           <a:p>
             <a:r>
-              <a:t>Com o pagamento confirmado, o sistema dispara a emissão dos ingressos e a baixa definitiva do estoque no lote — é o evento que conecta Vendas a Controle de Acesso.</a:t>
+              <a:t>A reserva expira por tempo e precisa DEVOLVER o estoque ao lote, e o limite por CPF exige CALCULAR a soma das reservas ativas com as compras já concluídas.</a:t>
             </a:r>
           </a:p>
         </p:txBody>
@@ -699,7 +699,7 @@
           </a:p>
           <a:p>
             <a:r>
-              <a:t>A lista de ingressos com o participante nomeado em cada um.</a:t>
+              <a:t>O modal: “reembolso integral de R$ 90,00, pois faltam mais de 7 dias para o evento”.</a:t>
             </a:r>
           </a:p>
           <a:p/>
@@ -710,7 +710,7 @@
           </a:p>
           <a:p>
             <a:r>
-              <a:t>Cada ingresso recebe um código único verificável, e a reemissão precisa INVALIDAR o código anterior sem perder o vínculo com o participante — além de VALIDAR que o ingresso ainda não teve check-in.</a:t>
+              <a:t>O reembolso é CALCULADO por faixas sobre a distância até o evento; a transferência INVALIDA o código antigo e emite outro após VALIDAR que não houve check-in e que o destinatário comprova o mesmo benefício.</a:t>
             </a:r>
           </a:p>
         </p:txBody>
@@ -785,7 +785,7 @@
           </a:p>
           <a:p>
             <a:r>
-              <a:t>Sem protótipo — aponte no mapa, coluna “Transferir ou cancelar”, card H16. Release 2.</a:t>
+              <a:t>Os dois casos de recusa: “ingresso já utilizado às 17:12” e “pagamento não confirmado”.</a:t>
             </a:r>
           </a:p>
           <a:p/>
@@ -796,7 +796,7 @@
           </a:p>
           <a:p>
             <a:r>
-              <a:t>A transferência INVALIDA o QR antigo e emite outro, só é permitida após VALIDAR que não houve check-in e que o destinatário não tem outro ingresso do mesmo lote, e a meia-entrada exige VALIDAR o mesmo benefício.</a:t>
+              <a:t>Cada leitura precisa VALIDAR três coisas em agregados distintos — o ingresso é deste evento, o pagamento está confirmado, não há check-in anterior — além de CONSULTAR a janela de entrada.</a:t>
             </a:r>
           </a:p>
         </p:txBody>
@@ -871,7 +871,7 @@
           </a:p>
           <a:p>
             <a:r>
-              <a:t>A frase do modal, que é a regra escrita na interface: “reembolso integral de R$ 90,00, pois faltam mais de 7 dias para o evento”.</a:t>
+              <a:t>Sem protótipo ainda — cabe na tela de check-in.</a:t>
             </a:r>
           </a:p>
           <a:p/>
@@ -882,7 +882,7 @@
           </a:p>
           <a:p>
             <a:r>
-              <a:t>O valor é CALCULADO por faixas sobre a diferença entre a data do cancelamento e a do evento — integral acima de 7 dias, metade entre 7 e 2, nenhum abaixo — exigindo CONSULTAR dois agregados.</a:t>
+              <a:t>Conta os check-ins registrados e bloqueia a entrada ao atingir a capacidade do espaço, mesmo com ingresso válido. É contagem e comparação: média.</a:t>
             </a:r>
           </a:p>
         </p:txBody>
@@ -957,7 +957,7 @@
           </a:p>
           <a:p>
             <a:r>
-              <a:t>O card verde de entrada liberada, com o participante, o ingresso e o horário do registro.</a:t>
+              <a:t>Sem protótipo ainda.</a:t>
             </a:r>
           </a:p>
           <a:p/>
@@ -968,7 +968,7 @@
           </a:p>
           <a:p>
             <a:r>
-              <a:t>Toda leitura aprovada grava data, hora e operador responsável — o registro de auditoria, que é a regra de complexidade baixa dentro desta funcionalidade.</a:t>
+              <a:t>Só aceita avaliação de quem tem check-in CONFIRMADO naquele evento, e dentro da janela de N dias após ele — o que cruza avaliação, ingresso e registro de check-in.</a:t>
             </a:r>
           </a:p>
         </p:txBody>
@@ -1043,7 +1043,7 @@
           </a:p>
           <a:p>
             <a:r>
-              <a:t>Os dois casos de recusa: “ingresso já utilizado às 17:12” e “pagamento não confirmado”.</a:t>
+              <a:t>Sem protótipo ainda.</a:t>
             </a:r>
           </a:p>
           <a:p/>
@@ -1054,7 +1054,7 @@
           </a:p>
           <a:p>
             <a:r>
-              <a:t>Cada leitura precisa VALIDAR três coisas em agregados distintos — ingresso pertence ao evento, pagamento confirmado, sem check-in anterior — além de CONSULTAR se o horário está dentro da janela de entrada.</a:t>
+              <a:t>O repasse é CALCULADO como total vendido menos taxa da plataforma, reembolsos e estornos, liberado apenas N dias após o evento, retido em caso de disputa, e dividido com o dono do espaço alugado.</a:t>
             </a:r>
           </a:p>
         </p:txBody>
@@ -1129,7 +1129,7 @@
           </a:p>
           <a:p>
             <a:r>
-              <a:t>Os três lotes com situações diferentes — Encerrado, Vigente, Agendado — e o erro “não pode ser menor que os 248 ingressos já vendidos”.</a:t>
+              <a:t>Sem protótipo ainda.</a:t>
             </a:r>
           </a:p>
           <a:p/>
@@ -1140,7 +1140,7 @@
           </a:p>
           <a:p>
             <a:r>
-              <a:t>Criar um lote exige VALIDAR que sua vigência não se sobrepõe à dos outros lotes do mesmo tipo, e CONSULTAR a quantidade já vendida antes de permitir reduzir a capacidade.</a:t>
+              <a:t>A proposta EXPIRA sem resposta em N dias, só é permitida após VALIDAR que o espaço comporta o público estimado, e o valor é CALCULADO como diária × dias mais taxas e caução.</a:t>
             </a:r>
           </a:p>
         </p:txBody>
@@ -1215,7 +1215,7 @@
           </a:p>
           <a:p>
             <a:r>
-              <a:t>Os quatro estados: Ativo, Limite atingido (150 de 150), Expirado, e o erro “Já existe um cupom com este código”.</a:t>
+              <a:t>No Resumo: “Capacidade dos lotes (1.950) excede a do local (1.800)”. Na configuração: os lotes Encerrado, Vigente e Agendado e o erro dos 248 vendidos. Nos cupons: Limite atingido e Expirado.</a:t>
             </a:r>
           </a:p>
           <a:p/>
@@ -1226,7 +1226,7 @@
           </a:p>
           <a:p>
             <a:r>
-              <a:t>O sistema CONSULTA se já existe cupom ativo com o mesmo código antes de salvar, e ao desativar precisa VALIDAR quais pedidos em aberto já o aplicaram — esses mantêm o desconto, os novos não.</a:t>
+              <a:t>Publicar exige CALCULAR a soma das capacidades dos lotes e VALIDAR contra a do espaço; criar um lote exige VALIDAR que as vigências não se sobrepõem; desativar um cupom exige VALIDAR quais pedidos em aberto já o aplicaram.</a:t>
             </a:r>
           </a:p>
         </p:txBody>
@@ -1301,7 +1301,7 @@
           </a:p>
           <a:p>
             <a:r>
-              <a:t>Os três tipos de ingresso com preço, e o Camarote Open Bar marcado como Esgotado.</a:t>
+              <a:t>Sem protótipo ainda — cabe na tela de configuração de ingressos.</a:t>
             </a:r>
           </a:p>
           <a:p/>
@@ -1312,7 +1312,7 @@
           </a:p>
           <a:p>
             <a:r>
-              <a:t>É a porta de entrada da compra: o preço exibido vem do lote vigente na data, e a disponibilidade vem da contagem de quantos já foram vendidos naquele lote.</a:t>
+              <a:t>A cortesia consome uma cota própria do evento, é nominal e intransferível, e não entra no cálculo de receita do repasse.</a:t>
             </a:r>
           </a:p>
         </p:txBody>
@@ -1387,7 +1387,7 @@
           </a:p>
           <a:p>
             <a:r>
-              <a:t>O cupom AMIGO10 aplicando −R$ 27,00 e o Camarote como Esgotado. Na tela seguinte, o erro “este nome já foi usado em outro ingresso deste pedido”.</a:t>
+              <a:t>Sem protótipo ainda.</a:t>
             </a:r>
           </a:p>
           <a:p/>
@@ -1398,7 +1398,7 @@
           </a:p>
           <a:p>
             <a:r>
-              <a:t>O preço exige CONSULTAR o lote vigente na data, a disponibilidade exige CONSULTAR quantos já foram vendidos, e o desconto exige CALCULAR sobre um cupom VALIDADO quanto a tipo, validade, limite de usos e aplicabilidade.</a:t>
+              <a:t>Agrega vendas, presença e receita do evento. É consulta e agregação, sem validação cruzada — por isso classificamos como média, e não alta.</a:t>
             </a:r>
           </a:p>
         </p:txBody>
@@ -1473,7 +1473,7 @@
           </a:p>
           <a:p>
             <a:r>
-              <a:t>O erro em vermelho: “este nome já foi usado em outro ingresso deste pedido”.</a:t>
+              <a:t>Sem protótipo ainda — um modal na tela de acompanhamento.</a:t>
             </a:r>
           </a:p>
           <a:p/>
@@ -1484,7 +1484,7 @@
           </a:p>
           <a:p>
             <a:r>
-              <a:t>Cada ingresso é nominal: antes de confirmar, o sistema precisa VALIDAR que o mesmo participante não foi vinculado a dois ingressos do mesmo pedido.</a:t>
+              <a:t>Reembolsa INTEGRALMENTE todos os compradores, ignorando a faixa de 7/2 dias porque a culpa não é deles; DEVOLVE a capacidade ao espaço alugado; e CALCULA a multa do organizador conforme a proximidade do evento.</a:t>
             </a:r>
           </a:p>
         </p:txBody>
@@ -1559,7 +1559,7 @@
           </a:p>
           <a:p>
             <a:r>
-              <a:t>A cota “40% do lote — 160 de 400”. Na tela de seleção, a linha “Meia-Entrada / Solidária — R$ 90,00”.</a:t>
+              <a:t>Os três tipos de ingresso com preço, e o Camarote marcado como Esgotado.</a:t>
             </a:r>
           </a:p>
           <a:p/>
@@ -1570,7 +1570,7 @@
           </a:p>
           <a:p>
             <a:r>
-              <a:t>A venda da meia é bloqueada por uma cota CALCULADA como percentual do lote, exige VALIDAR o comprovante conforme o benefício declarado, e a não comprovação na portaria RECALCULA o ingresso para inteira cobrando a diferença.</a:t>
+              <a:t>Busca por cidade e data, favoritos e alerta de lote novo. É consulta com filtros — média, não alta.</a:t>
             </a:r>
           </a:p>
         </p:txBody>
@@ -1645,7 +1645,7 @@
           </a:p>
           <a:p>
             <a:r>
-              <a:t>Sem protótipo — aponte no mapa, coluna “Escolher ingressos”, card H13. Release 2.</a:t>
+              <a:t>O AMIGO10 aplicando −R$ 27,00; o erro “este nome já foi usado em outro ingresso deste pedido”; e o total composto no resumo.</a:t>
             </a:r>
           </a:p>
           <a:p/>
@@ -1656,7 +1656,7 @@
           </a:p>
           <a:p>
             <a:r>
-              <a:t>A reserva expira por tempo e precisa DEVOLVER o estoque ao lote automaticamente, e o limite por CPF exige CALCULAR a soma das reservas ativas com as compras já concluídas no mesmo evento.</a:t>
+              <a:t>O preço exige CONSULTAR o lote vigente, a disponibilidade exige CONSULTAR os já vendidos, o desconto exige CALCULAR sobre um cupom VALIDADO em quatro critérios, e a confirmação exige VALIDAR que a reserva não expirou.</a:t>
             </a:r>
           </a:p>
         </p:txBody>
@@ -1731,7 +1731,7 @@
           </a:p>
           <a:p>
             <a:r>
-              <a:t>O resumo da compra com a composição do total: subtotal R$ 270,00 − desconto R$ 27,00 + taxa = R$ 243,00.</a:t>
+              <a:t>A coluna “Cota de meia: 40% do lote — 160 de 400”.</a:t>
             </a:r>
           </a:p>
           <a:p/>
@@ -1742,7 +1742,7 @@
           </a:p>
           <a:p>
             <a:r>
-              <a:t>O total é CALCULADO como subtotal menos desconto mais taxa, e a confirmação só é permitida após VALIDAR que a reserva do pedido ainda não expirou — cruzando pedido, lote e pagamento.</a:t>
+              <a:t>A cota é CALCULADA como percentual do lote e bloqueia a venda ao ser atingida, exige VALIDAR o comprovante conforme o benefício, e a não comprovação na portaria RECALCULA o ingresso para inteira cobrando a diferença.</a:t>
             </a:r>
           </a:p>
         </p:txBody>
@@ -5065,7 +5065,7 @@
                 </a:solidFill>
                 <a:latin typeface="Inter"/>
               </a:rPr>
-              <a:t>03</a:t>
+              <a:t>06</a:t>
             </a:r>
           </a:p>
         </p:txBody>
@@ -5104,7 +5104,7 @@
                 </a:solidFill>
                 <a:latin typeface="Inter"/>
               </a:rPr>
-              <a:t>Venda de ingressos — identificação</a:t>
+              <a:t>Cancelamento do evento</a:t>
             </a:r>
           </a:p>
         </p:txBody>
@@ -5143,38 +5143,113 @@
                 </a:solidFill>
                 <a:latin typeface="Inter"/>
               </a:rPr>
-              <a:t>LS</a:t>
-            </a:r>
-          </a:p>
-        </p:txBody>
-      </p:sp>
-      <p:pic>
-        <p:nvPicPr>
-          <p:cNvPr id="6" name="Picture 5" descr="identificacao-de-participantes.png"/>
-          <p:cNvPicPr>
-            <a:picLocks noChangeAspect="1"/>
-          </p:cNvPicPr>
-          <p:nvPr/>
-        </p:nvPicPr>
-        <p:blipFill>
-          <a:blip r:embed="rId2"/>
-          <a:stretch>
-            <a:fillRect/>
-          </a:stretch>
-        </p:blipFill>
-        <p:spPr>
-          <a:xfrm>
-            <a:off x="2641044" y="1005840"/>
-            <a:ext cx="6879431" cy="4892040"/>
-          </a:xfrm>
-          <a:prstGeom prst="rect">
-            <a:avLst/>
-          </a:prstGeom>
-        </p:spPr>
-      </p:pic>
-      <p:sp>
-        <p:nvSpPr>
-          <p:cNvPr id="7" name="Rectangle 6"/>
+              <a:t>Alta</a:t>
+            </a:r>
+          </a:p>
+        </p:txBody>
+      </p:sp>
+      <p:sp>
+        <p:nvSpPr>
+          <p:cNvPr id="6" name="Rectangle 5"/>
+          <p:cNvSpPr/>
+          <p:nvPr/>
+        </p:nvSpPr>
+        <p:spPr>
+          <a:xfrm>
+            <a:off x="3200400" y="1737360"/>
+            <a:ext cx="5760720" cy="3383280"/>
+          </a:xfrm>
+          <a:prstGeom prst="rect">
+            <a:avLst/>
+          </a:prstGeom>
+          <a:solidFill>
+            <a:srgbClr val="F7F8FC"/>
+          </a:solidFill>
+          <a:ln>
+            <a:noFill/>
+          </a:ln>
+          <a:effectLst/>
+        </p:spPr>
+        <p:style>
+          <a:lnRef idx="1">
+            <a:schemeClr val="accent1"/>
+          </a:lnRef>
+          <a:fillRef idx="3">
+            <a:schemeClr val="accent1"/>
+          </a:fillRef>
+          <a:effectRef idx="2">
+            <a:schemeClr val="accent1"/>
+          </a:effectRef>
+          <a:fontRef idx="minor">
+            <a:schemeClr val="lt1"/>
+          </a:fontRef>
+        </p:style>
+        <p:txBody>
+          <a:bodyPr rtlCol="0" anchor="ctr"/>
+          <a:lstStyle/>
+          <a:p>
+            <a:pPr algn="ctr"/>
+          </a:p>
+        </p:txBody>
+      </p:sp>
+      <p:sp>
+        <p:nvSpPr>
+          <p:cNvPr id="7" name="TextBox 6"/>
+          <p:cNvSpPr txBox="1"/>
+          <p:nvPr/>
+        </p:nvSpPr>
+        <p:spPr>
+          <a:xfrm>
+            <a:off x="3566160" y="3108960"/>
+            <a:ext cx="5029200" cy="822960"/>
+          </a:xfrm>
+          <a:prstGeom prst="rect">
+            <a:avLst/>
+          </a:prstGeom>
+          <a:noFill/>
+        </p:spPr>
+        <p:txBody>
+          <a:bodyPr wrap="square" lIns="0" rIns="0" tIns="0" bIns="0">
+            <a:spAutoFit/>
+          </a:bodyPr>
+          <a:lstStyle/>
+          <a:p>
+            <a:pPr algn="ctr">
+              <a:spcAft>
+                <a:spcPts val="600"/>
+              </a:spcAft>
+            </a:pPr>
+            <a:r>
+              <a:rPr sz="1900" b="1">
+                <a:solidFill>
+                  <a:srgbClr val="9E520A"/>
+                </a:solidFill>
+                <a:latin typeface="Inter"/>
+              </a:rPr>
+              <a:t>Sem protótipo</a:t>
+            </a:r>
+          </a:p>
+          <a:p>
+            <a:pPr algn="ctr">
+              <a:spcAft>
+                <a:spcPts val="600"/>
+              </a:spcAft>
+            </a:pPr>
+            <a:r>
+              <a:rPr sz="1900" b="1">
+                <a:solidFill>
+                  <a:srgbClr val="9E520A"/>
+                </a:solidFill>
+                <a:latin typeface="Inter"/>
+              </a:rPr>
+              <a:t>Release 2 — está mapeada</a:t>
+            </a:r>
+          </a:p>
+        </p:txBody>
+      </p:sp>
+      <p:sp>
+        <p:nvSpPr>
+          <p:cNvPr id="8" name="Rectangle 7"/>
           <p:cNvSpPr/>
           <p:nvPr/>
         </p:nvSpPr>
@@ -5218,7 +5293,7 @@
       </p:sp>
       <p:sp>
         <p:nvSpPr>
-          <p:cNvPr id="8" name="Rectangle 7"/>
+          <p:cNvPr id="9" name="Rectangle 8"/>
           <p:cNvSpPr/>
           <p:nvPr/>
         </p:nvSpPr>
@@ -5262,7 +5337,7 @@
       </p:sp>
       <p:sp>
         <p:nvSpPr>
-          <p:cNvPr id="9" name="TextBox 8"/>
+          <p:cNvPr id="10" name="TextBox 9"/>
           <p:cNvSpPr txBox="1"/>
           <p:nvPr/>
         </p:nvSpPr>
@@ -5294,7 +5369,7 @@
                 </a:solidFill>
                 <a:latin typeface="Inter"/>
               </a:rPr>
-              <a:t>Cada ingresso é nominal, e o sistema valida que o mesmo participante não se repete no pedido.</a:t>
+              <a:t>Reembolso integral a todos, devolve a capacidade ao espaço e calcula a multa do organizador.</a:t>
             </a:r>
           </a:p>
         </p:txBody>
@@ -5395,7 +5470,7 @@
                 </a:solidFill>
                 <a:latin typeface="Inter"/>
               </a:rPr>
-              <a:t>04</a:t>
+              <a:t>07</a:t>
             </a:r>
           </a:p>
         </p:txBody>
@@ -5434,7 +5509,7 @@
                 </a:solidFill>
                 <a:latin typeface="Inter"/>
               </a:rPr>
-              <a:t>Meia-entrada: benefício e cota</a:t>
+              <a:t>Descoberta de eventos</a:t>
             </a:r>
           </a:p>
         </p:txBody>
@@ -5473,14 +5548,14 @@
                 </a:solidFill>
                 <a:latin typeface="Inter"/>
               </a:rPr>
-              <a:t>EM</a:t>
+              <a:t>Média</a:t>
             </a:r>
           </a:p>
         </p:txBody>
       </p:sp>
       <p:pic>
         <p:nvPicPr>
-          <p:cNvPr id="6" name="Picture 5" descr="configuracao-de-ingressos.png"/>
+          <p:cNvPr id="6" name="Picture 5" descr="detalhe-do-evento.png"/>
           <p:cNvPicPr>
             <a:picLocks noChangeAspect="1"/>
           </p:cNvPicPr>
@@ -5494,8 +5569,8 @@
         </p:blipFill>
         <p:spPr>
           <a:xfrm>
-            <a:off x="3985418" y="1005840"/>
-            <a:ext cx="4190682" cy="4892040"/>
+            <a:off x="3968511" y="1005840"/>
+            <a:ext cx="4041616" cy="4892040"/>
           </a:xfrm>
           <a:prstGeom prst="rect">
             <a:avLst/>
@@ -5624,7 +5699,7 @@
                 </a:solidFill>
                 <a:latin typeface="Inter"/>
               </a:rPr>
-              <a:t>A cota de meia é calculada como percentual do lote; sem comprovação, o ingresso é recalculado para inteira.</a:t>
+              <a:t>Busca por cidade e data, favoritos e alerta de novo lote. Consulta com filtros: média.</a:t>
             </a:r>
           </a:p>
         </p:txBody>
@@ -5725,7 +5800,7 @@
                 </a:solidFill>
                 <a:latin typeface="Inter"/>
               </a:rPr>
-              <a:t>05</a:t>
+              <a:t>08</a:t>
             </a:r>
           </a:p>
         </p:txBody>
@@ -5764,7 +5839,7 @@
                 </a:solidFill>
                 <a:latin typeface="Inter"/>
               </a:rPr>
-              <a:t>Fila de espera e reserva temporária</a:t>
+              <a:t>Compra de ingressos</a:t>
             </a:r>
           </a:p>
         </p:txBody>
@@ -5803,113 +5878,86 @@
                 </a:solidFill>
                 <a:latin typeface="Inter"/>
               </a:rPr>
-              <a:t>CF</a:t>
-            </a:r>
-          </a:p>
-        </p:txBody>
-      </p:sp>
-      <p:sp>
-        <p:nvSpPr>
-          <p:cNvPr id="6" name="Rectangle 5"/>
-          <p:cNvSpPr/>
-          <p:nvPr/>
-        </p:nvSpPr>
-        <p:spPr>
-          <a:xfrm>
-            <a:off x="3200400" y="1737360"/>
-            <a:ext cx="5760720" cy="3383280"/>
-          </a:xfrm>
-          <a:prstGeom prst="rect">
-            <a:avLst/>
-          </a:prstGeom>
-          <a:solidFill>
-            <a:srgbClr val="F7F8FC"/>
-          </a:solidFill>
-          <a:ln>
-            <a:noFill/>
-          </a:ln>
-          <a:effectLst/>
-        </p:spPr>
-        <p:style>
-          <a:lnRef idx="1">
-            <a:schemeClr val="accent1"/>
-          </a:lnRef>
-          <a:fillRef idx="3">
-            <a:schemeClr val="accent1"/>
-          </a:fillRef>
-          <a:effectRef idx="2">
-            <a:schemeClr val="accent1"/>
-          </a:effectRef>
-          <a:fontRef idx="minor">
-            <a:schemeClr val="lt1"/>
-          </a:fontRef>
-        </p:style>
-        <p:txBody>
-          <a:bodyPr rtlCol="0" anchor="ctr"/>
-          <a:lstStyle/>
-          <a:p>
-            <a:pPr algn="ctr"/>
-          </a:p>
-        </p:txBody>
-      </p:sp>
-      <p:sp>
-        <p:nvSpPr>
-          <p:cNvPr id="7" name="TextBox 6"/>
-          <p:cNvSpPr txBox="1"/>
-          <p:nvPr/>
-        </p:nvSpPr>
-        <p:spPr>
-          <a:xfrm>
-            <a:off x="3566160" y="3108960"/>
-            <a:ext cx="5029200" cy="822960"/>
-          </a:xfrm>
-          <a:prstGeom prst="rect">
-            <a:avLst/>
-          </a:prstGeom>
-          <a:noFill/>
-        </p:spPr>
-        <p:txBody>
-          <a:bodyPr wrap="square" lIns="0" rIns="0" tIns="0" bIns="0">
-            <a:spAutoFit/>
-          </a:bodyPr>
-          <a:lstStyle/>
-          <a:p>
-            <a:pPr algn="ctr">
-              <a:spcAft>
-                <a:spcPts val="600"/>
-              </a:spcAft>
-            </a:pPr>
-            <a:r>
-              <a:rPr sz="1900" b="1">
-                <a:solidFill>
-                  <a:srgbClr val="9E520A"/>
-                </a:solidFill>
-                <a:latin typeface="Inter"/>
-              </a:rPr>
-              <a:t>Sem protótipo</a:t>
-            </a:r>
-          </a:p>
-          <a:p>
-            <a:pPr algn="ctr">
-              <a:spcAft>
-                <a:spcPts val="600"/>
-              </a:spcAft>
-            </a:pPr>
-            <a:r>
-              <a:rPr sz="1900" b="1">
-                <a:solidFill>
-                  <a:srgbClr val="9E520A"/>
-                </a:solidFill>
-                <a:latin typeface="Inter"/>
-              </a:rPr>
-              <a:t>Release 2 — está mapeada</a:t>
-            </a:r>
-          </a:p>
-        </p:txBody>
-      </p:sp>
-      <p:sp>
-        <p:nvSpPr>
-          <p:cNvPr id="8" name="Rectangle 7"/>
+              <a:t>Alta</a:t>
+            </a:r>
+          </a:p>
+        </p:txBody>
+      </p:sp>
+      <p:pic>
+        <p:nvPicPr>
+          <p:cNvPr id="6" name="Picture 5" descr="selecao-de-ingressos.png"/>
+          <p:cNvPicPr>
+            <a:picLocks noChangeAspect="1"/>
+          </p:cNvPicPr>
+          <p:nvPr/>
+        </p:nvPicPr>
+        <p:blipFill>
+          <a:blip r:embed="rId2"/>
+          <a:stretch>
+            <a:fillRect/>
+          </a:stretch>
+        </p:blipFill>
+        <p:spPr>
+          <a:xfrm>
+            <a:off x="457200" y="1874329"/>
+            <a:ext cx="3566160" cy="3155061"/>
+          </a:xfrm>
+          <a:prstGeom prst="rect">
+            <a:avLst/>
+          </a:prstGeom>
+        </p:spPr>
+      </p:pic>
+      <p:pic>
+        <p:nvPicPr>
+          <p:cNvPr id="7" name="Picture 6" descr="identificacao-de-participantes.png"/>
+          <p:cNvPicPr>
+            <a:picLocks noChangeAspect="1"/>
+          </p:cNvPicPr>
+          <p:nvPr/>
+        </p:nvPicPr>
+        <p:blipFill>
+          <a:blip r:embed="rId3"/>
+          <a:stretch>
+            <a:fillRect/>
+          </a:stretch>
+        </p:blipFill>
+        <p:spPr>
+          <a:xfrm>
+            <a:off x="4206240" y="2183892"/>
+            <a:ext cx="3566160" cy="2535936"/>
+          </a:xfrm>
+          <a:prstGeom prst="rect">
+            <a:avLst/>
+          </a:prstGeom>
+        </p:spPr>
+      </p:pic>
+      <p:pic>
+        <p:nvPicPr>
+          <p:cNvPr id="8" name="Picture 7" descr="checkout-pagamento.png"/>
+          <p:cNvPicPr>
+            <a:picLocks noChangeAspect="1"/>
+          </p:cNvPicPr>
+          <p:nvPr/>
+        </p:nvPicPr>
+        <p:blipFill>
+          <a:blip r:embed="rId4"/>
+          <a:stretch>
+            <a:fillRect/>
+          </a:stretch>
+        </p:blipFill>
+        <p:spPr>
+          <a:xfrm>
+            <a:off x="7955280" y="2183892"/>
+            <a:ext cx="3566160" cy="2535936"/>
+          </a:xfrm>
+          <a:prstGeom prst="rect">
+            <a:avLst/>
+          </a:prstGeom>
+        </p:spPr>
+      </p:pic>
+      <p:sp>
+        <p:nvSpPr>
+          <p:cNvPr id="9" name="Rectangle 8"/>
           <p:cNvSpPr/>
           <p:nvPr/>
         </p:nvSpPr>
@@ -5953,7 +6001,7 @@
       </p:sp>
       <p:sp>
         <p:nvSpPr>
-          <p:cNvPr id="9" name="Rectangle 8"/>
+          <p:cNvPr id="10" name="Rectangle 9"/>
           <p:cNvSpPr/>
           <p:nvPr/>
         </p:nvSpPr>
@@ -5997,7 +6045,7 @@
       </p:sp>
       <p:sp>
         <p:nvSpPr>
-          <p:cNvPr id="10" name="TextBox 9"/>
+          <p:cNvPr id="11" name="TextBox 10"/>
           <p:cNvSpPr txBox="1"/>
           <p:nvPr/>
         </p:nvSpPr>
@@ -6029,7 +6077,7 @@
                 </a:solidFill>
                 <a:latin typeface="Inter"/>
               </a:rPr>
-              <a:t>A reserva expira devolvendo estoque, e o limite por CPF soma reservas ativas com compras concluídas.</a:t>
+              <a:t>Consulta o lote vigente e os vendidos, calcula o cupom sobre quatro critérios e valida a reserva.</a:t>
             </a:r>
           </a:p>
         </p:txBody>
@@ -6130,7 +6178,7 @@
                 </a:solidFill>
                 <a:latin typeface="Inter"/>
               </a:rPr>
-              <a:t>06</a:t>
+              <a:t>09</a:t>
             </a:r>
           </a:p>
         </p:txBody>
@@ -6169,7 +6217,7 @@
                 </a:solidFill>
                 <a:latin typeface="Inter"/>
               </a:rPr>
-              <a:t>Pagamento do pedido</a:t>
+              <a:t>Meia-entrada: benefício e cota</a:t>
             </a:r>
           </a:p>
         </p:txBody>
@@ -6208,14 +6256,14 @@
                 </a:solidFill>
                 <a:latin typeface="Inter"/>
               </a:rPr>
-              <a:t>GF</a:t>
+              <a:t>Alta</a:t>
             </a:r>
           </a:p>
         </p:txBody>
       </p:sp>
       <p:pic>
         <p:nvPicPr>
-          <p:cNvPr id="6" name="Picture 5" descr="checkout-pagamento.png"/>
+          <p:cNvPr id="6" name="Picture 5" descr="configuracao-de-ingressos.png"/>
           <p:cNvPicPr>
             <a:picLocks noChangeAspect="1"/>
           </p:cNvPicPr>
@@ -6229,8 +6277,8 @@
         </p:blipFill>
         <p:spPr>
           <a:xfrm>
-            <a:off x="2641044" y="1005840"/>
-            <a:ext cx="6879431" cy="4892040"/>
+            <a:off x="3893978" y="1005840"/>
+            <a:ext cx="4190682" cy="4892040"/>
           </a:xfrm>
           <a:prstGeom prst="rect">
             <a:avLst/>
@@ -6359,7 +6407,7 @@
                 </a:solidFill>
                 <a:latin typeface="Inter"/>
               </a:rPr>
-              <a:t>Calcula subtotal − desconto + taxa, e só confirma após validar que a reserva não expirou.</a:t>
+              <a:t>A cota é percentual do lote; sem comprovação na portaria, o ingresso é recalculado para inteira.</a:t>
             </a:r>
           </a:p>
         </p:txBody>
@@ -6460,7 +6508,7 @@
                 </a:solidFill>
                 <a:latin typeface="Inter"/>
               </a:rPr>
-              <a:t>06</a:t>
+              <a:t>10</a:t>
             </a:r>
           </a:p>
         </p:txBody>
@@ -6499,7 +6547,7 @@
                 </a:solidFill>
                 <a:latin typeface="Inter"/>
               </a:rPr>
-              <a:t>Pagamento — confirmação</a:t>
+              <a:t>Fila de espera e reserva</a:t>
             </a:r>
           </a:p>
         </p:txBody>
@@ -6538,38 +6586,113 @@
                 </a:solidFill>
                 <a:latin typeface="Inter"/>
               </a:rPr>
-              <a:t>GF</a:t>
-            </a:r>
-          </a:p>
-        </p:txBody>
-      </p:sp>
-      <p:pic>
-        <p:nvPicPr>
-          <p:cNvPr id="6" name="Picture 5" descr="confirmacao-compra.png"/>
-          <p:cNvPicPr>
-            <a:picLocks noChangeAspect="1"/>
-          </p:cNvPicPr>
-          <p:nvPr/>
-        </p:nvPicPr>
-        <p:blipFill>
-          <a:blip r:embed="rId2"/>
-          <a:stretch>
-            <a:fillRect/>
-          </a:stretch>
-        </p:blipFill>
-        <p:spPr>
-          <a:xfrm>
-            <a:off x="2641044" y="1005840"/>
-            <a:ext cx="6879431" cy="4892040"/>
-          </a:xfrm>
-          <a:prstGeom prst="rect">
-            <a:avLst/>
-          </a:prstGeom>
-        </p:spPr>
-      </p:pic>
-      <p:sp>
-        <p:nvSpPr>
-          <p:cNvPr id="7" name="Rectangle 6"/>
+              <a:t>Alta</a:t>
+            </a:r>
+          </a:p>
+        </p:txBody>
+      </p:sp>
+      <p:sp>
+        <p:nvSpPr>
+          <p:cNvPr id="6" name="Rectangle 5"/>
+          <p:cNvSpPr/>
+          <p:nvPr/>
+        </p:nvSpPr>
+        <p:spPr>
+          <a:xfrm>
+            <a:off x="3200400" y="1737360"/>
+            <a:ext cx="5760720" cy="3383280"/>
+          </a:xfrm>
+          <a:prstGeom prst="rect">
+            <a:avLst/>
+          </a:prstGeom>
+          <a:solidFill>
+            <a:srgbClr val="F7F8FC"/>
+          </a:solidFill>
+          <a:ln>
+            <a:noFill/>
+          </a:ln>
+          <a:effectLst/>
+        </p:spPr>
+        <p:style>
+          <a:lnRef idx="1">
+            <a:schemeClr val="accent1"/>
+          </a:lnRef>
+          <a:fillRef idx="3">
+            <a:schemeClr val="accent1"/>
+          </a:fillRef>
+          <a:effectRef idx="2">
+            <a:schemeClr val="accent1"/>
+          </a:effectRef>
+          <a:fontRef idx="minor">
+            <a:schemeClr val="lt1"/>
+          </a:fontRef>
+        </p:style>
+        <p:txBody>
+          <a:bodyPr rtlCol="0" anchor="ctr"/>
+          <a:lstStyle/>
+          <a:p>
+            <a:pPr algn="ctr"/>
+          </a:p>
+        </p:txBody>
+      </p:sp>
+      <p:sp>
+        <p:nvSpPr>
+          <p:cNvPr id="7" name="TextBox 6"/>
+          <p:cNvSpPr txBox="1"/>
+          <p:nvPr/>
+        </p:nvSpPr>
+        <p:spPr>
+          <a:xfrm>
+            <a:off x="3566160" y="3108960"/>
+            <a:ext cx="5029200" cy="822960"/>
+          </a:xfrm>
+          <a:prstGeom prst="rect">
+            <a:avLst/>
+          </a:prstGeom>
+          <a:noFill/>
+        </p:spPr>
+        <p:txBody>
+          <a:bodyPr wrap="square" lIns="0" rIns="0" tIns="0" bIns="0">
+            <a:spAutoFit/>
+          </a:bodyPr>
+          <a:lstStyle/>
+          <a:p>
+            <a:pPr algn="ctr">
+              <a:spcAft>
+                <a:spcPts val="600"/>
+              </a:spcAft>
+            </a:pPr>
+            <a:r>
+              <a:rPr sz="1900" b="1">
+                <a:solidFill>
+                  <a:srgbClr val="9E520A"/>
+                </a:solidFill>
+                <a:latin typeface="Inter"/>
+              </a:rPr>
+              <a:t>Sem protótipo</a:t>
+            </a:r>
+          </a:p>
+          <a:p>
+            <a:pPr algn="ctr">
+              <a:spcAft>
+                <a:spcPts val="600"/>
+              </a:spcAft>
+            </a:pPr>
+            <a:r>
+              <a:rPr sz="1900" b="1">
+                <a:solidFill>
+                  <a:srgbClr val="9E520A"/>
+                </a:solidFill>
+                <a:latin typeface="Inter"/>
+              </a:rPr>
+              <a:t>Release 2 — está mapeada</a:t>
+            </a:r>
+          </a:p>
+        </p:txBody>
+      </p:sp>
+      <p:sp>
+        <p:nvSpPr>
+          <p:cNvPr id="8" name="Rectangle 7"/>
           <p:cNvSpPr/>
           <p:nvPr/>
         </p:nvSpPr>
@@ -6613,7 +6736,7 @@
       </p:sp>
       <p:sp>
         <p:nvSpPr>
-          <p:cNvPr id="8" name="Rectangle 7"/>
+          <p:cNvPr id="9" name="Rectangle 8"/>
           <p:cNvSpPr/>
           <p:nvPr/>
         </p:nvSpPr>
@@ -6657,7 +6780,7 @@
       </p:sp>
       <p:sp>
         <p:nvSpPr>
-          <p:cNvPr id="9" name="TextBox 8"/>
+          <p:cNvPr id="10" name="TextBox 9"/>
           <p:cNvSpPr txBox="1"/>
           <p:nvPr/>
         </p:nvSpPr>
@@ -6689,7 +6812,7 @@
                 </a:solidFill>
                 <a:latin typeface="Inter"/>
               </a:rPr>
-              <a:t>Confirmado o pagamento, o sistema emite os ingressos e dá baixa definitiva no lote.</a:t>
+              <a:t>A reserva expira devolvendo estoque; o limite por CPF soma reservas ativas e compras concluídas.</a:t>
             </a:r>
           </a:p>
         </p:txBody>
@@ -6790,7 +6913,7 @@
                 </a:solidFill>
                 <a:latin typeface="Inter"/>
               </a:rPr>
-              <a:t>07</a:t>
+              <a:t>11</a:t>
             </a:r>
           </a:p>
         </p:txBody>
@@ -6829,7 +6952,7 @@
                 </a:solidFill>
                 <a:latin typeface="Inter"/>
               </a:rPr>
-              <a:t>Emissão e entrega do ingresso</a:t>
+              <a:t>Gestão do meu ingresso</a:t>
             </a:r>
           </a:p>
         </p:txBody>
@@ -6868,7 +6991,7 @@
                 </a:solidFill>
                 <a:latin typeface="Inter"/>
               </a:rPr>
-              <a:t>CF</a:t>
+              <a:t>Alta</a:t>
             </a:r>
           </a:p>
         </p:txBody>
@@ -6889,7 +7012,7 @@
         </p:blipFill>
         <p:spPr>
           <a:xfrm>
-            <a:off x="3095786" y="1005840"/>
+            <a:off x="3004346" y="1005840"/>
             <a:ext cx="5969947" cy="4892040"/>
           </a:xfrm>
           <a:prstGeom prst="rect">
@@ -7019,7 +7142,7 @@
                 </a:solidFill>
                 <a:latin typeface="Inter"/>
               </a:rPr>
-              <a:t>A reemissão invalida o código anterior preservando o vínculo, e valida que não houve check-in.</a:t>
+              <a:t>Reembolso por faixas de data; transferência invalida o código e valida check-in e benefício.</a:t>
             </a:r>
           </a:p>
         </p:txBody>
@@ -7120,7 +7243,7 @@
                 </a:solidFill>
                 <a:latin typeface="Inter"/>
               </a:rPr>
-              <a:t>08</a:t>
+              <a:t>12</a:t>
             </a:r>
           </a:p>
         </p:txBody>
@@ -7159,7 +7282,7 @@
                 </a:solidFill>
                 <a:latin typeface="Inter"/>
               </a:rPr>
-              <a:t>Transferência nominal de ingresso</a:t>
+              <a:t>Check-in de participantes</a:t>
             </a:r>
           </a:p>
         </p:txBody>
@@ -7198,110 +7321,59 @@
                 </a:solidFill>
                 <a:latin typeface="Inter"/>
               </a:rPr>
-              <a:t>EM</a:t>
-            </a:r>
-          </a:p>
-        </p:txBody>
-      </p:sp>
-      <p:sp>
-        <p:nvSpPr>
-          <p:cNvPr id="6" name="Rectangle 5"/>
-          <p:cNvSpPr/>
-          <p:nvPr/>
-        </p:nvSpPr>
-        <p:spPr>
-          <a:xfrm>
-            <a:off x="3200400" y="1737360"/>
-            <a:ext cx="5760720" cy="3383280"/>
-          </a:xfrm>
-          <a:prstGeom prst="rect">
-            <a:avLst/>
-          </a:prstGeom>
-          <a:solidFill>
-            <a:srgbClr val="F7F8FC"/>
-          </a:solidFill>
-          <a:ln>
-            <a:noFill/>
-          </a:ln>
-          <a:effectLst/>
-        </p:spPr>
-        <p:style>
-          <a:lnRef idx="1">
-            <a:schemeClr val="accent1"/>
-          </a:lnRef>
-          <a:fillRef idx="3">
-            <a:schemeClr val="accent1"/>
-          </a:fillRef>
-          <a:effectRef idx="2">
-            <a:schemeClr val="accent1"/>
-          </a:effectRef>
-          <a:fontRef idx="minor">
-            <a:schemeClr val="lt1"/>
-          </a:fontRef>
-        </p:style>
-        <p:txBody>
-          <a:bodyPr rtlCol="0" anchor="ctr"/>
-          <a:lstStyle/>
-          <a:p>
-            <a:pPr algn="ctr"/>
-          </a:p>
-        </p:txBody>
-      </p:sp>
-      <p:sp>
-        <p:nvSpPr>
-          <p:cNvPr id="7" name="TextBox 6"/>
-          <p:cNvSpPr txBox="1"/>
-          <p:nvPr/>
-        </p:nvSpPr>
-        <p:spPr>
-          <a:xfrm>
-            <a:off x="3566160" y="3108960"/>
-            <a:ext cx="5029200" cy="822960"/>
-          </a:xfrm>
-          <a:prstGeom prst="rect">
-            <a:avLst/>
-          </a:prstGeom>
-          <a:noFill/>
-        </p:spPr>
-        <p:txBody>
-          <a:bodyPr wrap="square" lIns="0" rIns="0" tIns="0" bIns="0">
-            <a:spAutoFit/>
-          </a:bodyPr>
-          <a:lstStyle/>
-          <a:p>
-            <a:pPr algn="ctr">
-              <a:spcAft>
-                <a:spcPts val="600"/>
-              </a:spcAft>
-            </a:pPr>
-            <a:r>
-              <a:rPr sz="1900" b="1">
-                <a:solidFill>
-                  <a:srgbClr val="9E520A"/>
-                </a:solidFill>
-                <a:latin typeface="Inter"/>
-              </a:rPr>
-              <a:t>Sem protótipo</a:t>
-            </a:r>
-          </a:p>
-          <a:p>
-            <a:pPr algn="ctr">
-              <a:spcAft>
-                <a:spcPts val="600"/>
-              </a:spcAft>
-            </a:pPr>
-            <a:r>
-              <a:rPr sz="1900" b="1">
-                <a:solidFill>
-                  <a:srgbClr val="9E520A"/>
-                </a:solidFill>
-                <a:latin typeface="Inter"/>
-              </a:rPr>
-              <a:t>Release 2 — está mapeada</a:t>
-            </a:r>
-          </a:p>
-        </p:txBody>
-      </p:sp>
+              <a:t>Alta</a:t>
+            </a:r>
+          </a:p>
+        </p:txBody>
+      </p:sp>
+      <p:pic>
+        <p:nvPicPr>
+          <p:cNvPr id="6" name="Picture 5" descr="checkin-participantes.png"/>
+          <p:cNvPicPr>
+            <a:picLocks noChangeAspect="1"/>
+          </p:cNvPicPr>
+          <p:nvPr/>
+        </p:nvPicPr>
+        <p:blipFill>
+          <a:blip r:embed="rId2"/>
+          <a:stretch>
+            <a:fillRect/>
+          </a:stretch>
+        </p:blipFill>
+        <p:spPr>
+          <a:xfrm>
+            <a:off x="527889" y="1005840"/>
+            <a:ext cx="5299301" cy="4892039"/>
+          </a:xfrm>
+          <a:prstGeom prst="rect">
+            <a:avLst/>
+          </a:prstGeom>
+        </p:spPr>
+      </p:pic>
+      <p:pic>
+        <p:nvPicPr>
+          <p:cNvPr id="7" name="Picture 6" descr="checkin-estados-erro.png"/>
+          <p:cNvPicPr>
+            <a:picLocks noChangeAspect="1"/>
+          </p:cNvPicPr>
+          <p:nvPr/>
+        </p:nvPicPr>
+        <p:blipFill>
+          <a:blip r:embed="rId3"/>
+          <a:stretch>
+            <a:fillRect/>
+          </a:stretch>
+        </p:blipFill>
+        <p:spPr>
+          <a:xfrm>
+            <a:off x="6080760" y="1517396"/>
+            <a:ext cx="5440679" cy="3868927"/>
+          </a:xfrm>
+          <a:prstGeom prst="rect">
+            <a:avLst/>
+          </a:prstGeom>
+        </p:spPr>
+      </p:pic>
       <p:sp>
         <p:nvSpPr>
           <p:cNvPr id="8" name="Rectangle 7"/>
@@ -7424,7 +7496,7 @@
                 </a:solidFill>
                 <a:latin typeface="Inter"/>
               </a:rPr>
-              <a:t>Invalida o QR antigo, emite outro, e valida check-in, lote do destinatário e benefício equivalente.</a:t>
+              <a:t>Valida ingresso, pagamento e histórico em agregados distintos, mais a janela de entrada.</a:t>
             </a:r>
           </a:p>
         </p:txBody>
@@ -7525,7 +7597,7 @@
                 </a:solidFill>
                 <a:latin typeface="Inter"/>
               </a:rPr>
-              <a:t>09</a:t>
+              <a:t>13</a:t>
             </a:r>
           </a:p>
         </p:txBody>
@@ -7564,7 +7636,7 @@
                 </a:solidFill>
                 <a:latin typeface="Inter"/>
               </a:rPr>
-              <a:t>Cancelamento e reembolso</a:t>
+              <a:t>Lotação em tempo real</a:t>
             </a:r>
           </a:p>
         </p:txBody>
@@ -7603,38 +7675,113 @@
                 </a:solidFill>
                 <a:latin typeface="Inter"/>
               </a:rPr>
-              <a:t>GF</a:t>
-            </a:r>
-          </a:p>
-        </p:txBody>
-      </p:sp>
-      <p:pic>
-        <p:nvPicPr>
-          <p:cNvPr id="6" name="Picture 5" descr="meus-ingressos.png"/>
-          <p:cNvPicPr>
-            <a:picLocks noChangeAspect="1"/>
-          </p:cNvPicPr>
-          <p:nvPr/>
-        </p:nvPicPr>
-        <p:blipFill>
-          <a:blip r:embed="rId2"/>
-          <a:stretch>
-            <a:fillRect/>
-          </a:stretch>
-        </p:blipFill>
-        <p:spPr>
-          <a:xfrm>
-            <a:off x="3095786" y="1005840"/>
-            <a:ext cx="5969947" cy="4892040"/>
-          </a:xfrm>
-          <a:prstGeom prst="rect">
-            <a:avLst/>
-          </a:prstGeom>
-        </p:spPr>
-      </p:pic>
-      <p:sp>
-        <p:nvSpPr>
-          <p:cNvPr id="7" name="Rectangle 6"/>
+              <a:t>Média</a:t>
+            </a:r>
+          </a:p>
+        </p:txBody>
+      </p:sp>
+      <p:sp>
+        <p:nvSpPr>
+          <p:cNvPr id="6" name="Rectangle 5"/>
+          <p:cNvSpPr/>
+          <p:nvPr/>
+        </p:nvSpPr>
+        <p:spPr>
+          <a:xfrm>
+            <a:off x="3200400" y="1737360"/>
+            <a:ext cx="5760720" cy="3383280"/>
+          </a:xfrm>
+          <a:prstGeom prst="rect">
+            <a:avLst/>
+          </a:prstGeom>
+          <a:solidFill>
+            <a:srgbClr val="F7F8FC"/>
+          </a:solidFill>
+          <a:ln>
+            <a:noFill/>
+          </a:ln>
+          <a:effectLst/>
+        </p:spPr>
+        <p:style>
+          <a:lnRef idx="1">
+            <a:schemeClr val="accent1"/>
+          </a:lnRef>
+          <a:fillRef idx="3">
+            <a:schemeClr val="accent1"/>
+          </a:fillRef>
+          <a:effectRef idx="2">
+            <a:schemeClr val="accent1"/>
+          </a:effectRef>
+          <a:fontRef idx="minor">
+            <a:schemeClr val="lt1"/>
+          </a:fontRef>
+        </p:style>
+        <p:txBody>
+          <a:bodyPr rtlCol="0" anchor="ctr"/>
+          <a:lstStyle/>
+          <a:p>
+            <a:pPr algn="ctr"/>
+          </a:p>
+        </p:txBody>
+      </p:sp>
+      <p:sp>
+        <p:nvSpPr>
+          <p:cNvPr id="7" name="TextBox 6"/>
+          <p:cNvSpPr txBox="1"/>
+          <p:nvPr/>
+        </p:nvSpPr>
+        <p:spPr>
+          <a:xfrm>
+            <a:off x="3566160" y="3108960"/>
+            <a:ext cx="5029200" cy="822960"/>
+          </a:xfrm>
+          <a:prstGeom prst="rect">
+            <a:avLst/>
+          </a:prstGeom>
+          <a:noFill/>
+        </p:spPr>
+        <p:txBody>
+          <a:bodyPr wrap="square" lIns="0" rIns="0" tIns="0" bIns="0">
+            <a:spAutoFit/>
+          </a:bodyPr>
+          <a:lstStyle/>
+          <a:p>
+            <a:pPr algn="ctr">
+              <a:spcAft>
+                <a:spcPts val="600"/>
+              </a:spcAft>
+            </a:pPr>
+            <a:r>
+              <a:rPr sz="1900" b="1">
+                <a:solidFill>
+                  <a:srgbClr val="9E520A"/>
+                </a:solidFill>
+                <a:latin typeface="Inter"/>
+              </a:rPr>
+              <a:t>Sem protótipo</a:t>
+            </a:r>
+          </a:p>
+          <a:p>
+            <a:pPr algn="ctr">
+              <a:spcAft>
+                <a:spcPts val="600"/>
+              </a:spcAft>
+            </a:pPr>
+            <a:r>
+              <a:rPr sz="1900" b="1">
+                <a:solidFill>
+                  <a:srgbClr val="9E520A"/>
+                </a:solidFill>
+                <a:latin typeface="Inter"/>
+              </a:rPr>
+              <a:t>Release 2 — está mapeada</a:t>
+            </a:r>
+          </a:p>
+        </p:txBody>
+      </p:sp>
+      <p:sp>
+        <p:nvSpPr>
+          <p:cNvPr id="8" name="Rectangle 7"/>
           <p:cNvSpPr/>
           <p:nvPr/>
         </p:nvSpPr>
@@ -7678,7 +7825,7 @@
       </p:sp>
       <p:sp>
         <p:nvSpPr>
-          <p:cNvPr id="8" name="Rectangle 7"/>
+          <p:cNvPr id="9" name="Rectangle 8"/>
           <p:cNvSpPr/>
           <p:nvPr/>
         </p:nvSpPr>
@@ -7722,7 +7869,7 @@
       </p:sp>
       <p:sp>
         <p:nvSpPr>
-          <p:cNvPr id="9" name="TextBox 8"/>
+          <p:cNvPr id="10" name="TextBox 9"/>
           <p:cNvSpPr txBox="1"/>
           <p:nvPr/>
         </p:nvSpPr>
@@ -7754,7 +7901,7 @@
                 </a:solidFill>
                 <a:latin typeface="Inter"/>
               </a:rPr>
-              <a:t>Calcula o reembolso por faixas sobre a distância até a data do evento, consultando dois agregados.</a:t>
+              <a:t>Conta os check-ins e bloqueia ao atingir a capacidade do espaço. Contagem e comparação: média.</a:t>
             </a:r>
           </a:p>
         </p:txBody>
@@ -7855,7 +8002,7 @@
                 </a:solidFill>
                 <a:latin typeface="Inter"/>
               </a:rPr>
-              <a:t>10</a:t>
+              <a:t>14</a:t>
             </a:r>
           </a:p>
         </p:txBody>
@@ -7894,7 +8041,7 @@
                 </a:solidFill>
                 <a:latin typeface="Inter"/>
               </a:rPr>
-              <a:t>Check-in — leitura aprovada</a:t>
+              <a:t>Avaliações pós-evento</a:t>
             </a:r>
           </a:p>
         </p:txBody>
@@ -7933,38 +8080,113 @@
                 </a:solidFill>
                 <a:latin typeface="Inter"/>
               </a:rPr>
-              <a:t>LS</a:t>
-            </a:r>
-          </a:p>
-        </p:txBody>
-      </p:sp>
-      <p:pic>
-        <p:nvPicPr>
-          <p:cNvPr id="6" name="Picture 5" descr="checkin-participantes.png"/>
-          <p:cNvPicPr>
-            <a:picLocks noChangeAspect="1"/>
-          </p:cNvPicPr>
-          <p:nvPr/>
-        </p:nvPicPr>
-        <p:blipFill>
-          <a:blip r:embed="rId2"/>
-          <a:stretch>
-            <a:fillRect/>
-          </a:stretch>
-        </p:blipFill>
-        <p:spPr>
-          <a:xfrm>
-            <a:off x="3431109" y="1005840"/>
-            <a:ext cx="5299301" cy="4892039"/>
-          </a:xfrm>
-          <a:prstGeom prst="rect">
-            <a:avLst/>
-          </a:prstGeom>
-        </p:spPr>
-      </p:pic>
-      <p:sp>
-        <p:nvSpPr>
-          <p:cNvPr id="7" name="Rectangle 6"/>
+              <a:t>Alta</a:t>
+            </a:r>
+          </a:p>
+        </p:txBody>
+      </p:sp>
+      <p:sp>
+        <p:nvSpPr>
+          <p:cNvPr id="6" name="Rectangle 5"/>
+          <p:cNvSpPr/>
+          <p:nvPr/>
+        </p:nvSpPr>
+        <p:spPr>
+          <a:xfrm>
+            <a:off x="3200400" y="1737360"/>
+            <a:ext cx="5760720" cy="3383280"/>
+          </a:xfrm>
+          <a:prstGeom prst="rect">
+            <a:avLst/>
+          </a:prstGeom>
+          <a:solidFill>
+            <a:srgbClr val="F7F8FC"/>
+          </a:solidFill>
+          <a:ln>
+            <a:noFill/>
+          </a:ln>
+          <a:effectLst/>
+        </p:spPr>
+        <p:style>
+          <a:lnRef idx="1">
+            <a:schemeClr val="accent1"/>
+          </a:lnRef>
+          <a:fillRef idx="3">
+            <a:schemeClr val="accent1"/>
+          </a:fillRef>
+          <a:effectRef idx="2">
+            <a:schemeClr val="accent1"/>
+          </a:effectRef>
+          <a:fontRef idx="minor">
+            <a:schemeClr val="lt1"/>
+          </a:fontRef>
+        </p:style>
+        <p:txBody>
+          <a:bodyPr rtlCol="0" anchor="ctr"/>
+          <a:lstStyle/>
+          <a:p>
+            <a:pPr algn="ctr"/>
+          </a:p>
+        </p:txBody>
+      </p:sp>
+      <p:sp>
+        <p:nvSpPr>
+          <p:cNvPr id="7" name="TextBox 6"/>
+          <p:cNvSpPr txBox="1"/>
+          <p:nvPr/>
+        </p:nvSpPr>
+        <p:spPr>
+          <a:xfrm>
+            <a:off x="3566160" y="3108960"/>
+            <a:ext cx="5029200" cy="822960"/>
+          </a:xfrm>
+          <a:prstGeom prst="rect">
+            <a:avLst/>
+          </a:prstGeom>
+          <a:noFill/>
+        </p:spPr>
+        <p:txBody>
+          <a:bodyPr wrap="square" lIns="0" rIns="0" tIns="0" bIns="0">
+            <a:spAutoFit/>
+          </a:bodyPr>
+          <a:lstStyle/>
+          <a:p>
+            <a:pPr algn="ctr">
+              <a:spcAft>
+                <a:spcPts val="600"/>
+              </a:spcAft>
+            </a:pPr>
+            <a:r>
+              <a:rPr sz="1900" b="1">
+                <a:solidFill>
+                  <a:srgbClr val="9E520A"/>
+                </a:solidFill>
+                <a:latin typeface="Inter"/>
+              </a:rPr>
+              <a:t>Sem protótipo</a:t>
+            </a:r>
+          </a:p>
+          <a:p>
+            <a:pPr algn="ctr">
+              <a:spcAft>
+                <a:spcPts val="600"/>
+              </a:spcAft>
+            </a:pPr>
+            <a:r>
+              <a:rPr sz="1900" b="1">
+                <a:solidFill>
+                  <a:srgbClr val="9E520A"/>
+                </a:solidFill>
+                <a:latin typeface="Inter"/>
+              </a:rPr>
+              <a:t>Release 2 — está mapeada</a:t>
+            </a:r>
+          </a:p>
+        </p:txBody>
+      </p:sp>
+      <p:sp>
+        <p:nvSpPr>
+          <p:cNvPr id="8" name="Rectangle 7"/>
           <p:cNvSpPr/>
           <p:nvPr/>
         </p:nvSpPr>
@@ -8008,7 +8230,7 @@
       </p:sp>
       <p:sp>
         <p:nvSpPr>
-          <p:cNvPr id="8" name="Rectangle 7"/>
+          <p:cNvPr id="9" name="Rectangle 8"/>
           <p:cNvSpPr/>
           <p:nvPr/>
         </p:nvSpPr>
@@ -8052,7 +8274,7 @@
       </p:sp>
       <p:sp>
         <p:nvSpPr>
-          <p:cNvPr id="9" name="TextBox 8"/>
+          <p:cNvPr id="10" name="TextBox 9"/>
           <p:cNvSpPr txBox="1"/>
           <p:nvPr/>
         </p:nvSpPr>
@@ -8084,7 +8306,7 @@
                 </a:solidFill>
                 <a:latin typeface="Inter"/>
               </a:rPr>
-              <a:t>A leitura aprovada grava data, hora e operador: o registro de auditoria do check-in.</a:t>
+              <a:t>Só avalia quem tem check-in confirmado, dentro da janela após o evento.</a:t>
             </a:r>
           </a:p>
         </p:txBody>
@@ -8185,7 +8407,7 @@
                 </a:solidFill>
                 <a:latin typeface="Inter"/>
               </a:rPr>
-              <a:t>10</a:t>
+              <a:t>15</a:t>
             </a:r>
           </a:p>
         </p:txBody>
@@ -8224,7 +8446,7 @@
                 </a:solidFill>
                 <a:latin typeface="Inter"/>
               </a:rPr>
-              <a:t>Check-in — casos de recusa</a:t>
+              <a:t>Repasse financeiro</a:t>
             </a:r>
           </a:p>
         </p:txBody>
@@ -8263,38 +8485,113 @@
                 </a:solidFill>
                 <a:latin typeface="Inter"/>
               </a:rPr>
-              <a:t>LS</a:t>
-            </a:r>
-          </a:p>
-        </p:txBody>
-      </p:sp>
-      <p:pic>
-        <p:nvPicPr>
-          <p:cNvPr id="6" name="Picture 5" descr="checkin-estados-erro.png"/>
-          <p:cNvPicPr>
-            <a:picLocks noChangeAspect="1"/>
-          </p:cNvPicPr>
-          <p:nvPr/>
-        </p:nvPicPr>
-        <p:blipFill>
-          <a:blip r:embed="rId2"/>
-          <a:stretch>
-            <a:fillRect/>
-          </a:stretch>
-        </p:blipFill>
-        <p:spPr>
-          <a:xfrm>
-            <a:off x="2641044" y="1005840"/>
-            <a:ext cx="6879431" cy="4892040"/>
-          </a:xfrm>
-          <a:prstGeom prst="rect">
-            <a:avLst/>
-          </a:prstGeom>
-        </p:spPr>
-      </p:pic>
-      <p:sp>
-        <p:nvSpPr>
-          <p:cNvPr id="7" name="Rectangle 6"/>
+              <a:t>Alta</a:t>
+            </a:r>
+          </a:p>
+        </p:txBody>
+      </p:sp>
+      <p:sp>
+        <p:nvSpPr>
+          <p:cNvPr id="6" name="Rectangle 5"/>
+          <p:cNvSpPr/>
+          <p:nvPr/>
+        </p:nvSpPr>
+        <p:spPr>
+          <a:xfrm>
+            <a:off x="3200400" y="1737360"/>
+            <a:ext cx="5760720" cy="3383280"/>
+          </a:xfrm>
+          <a:prstGeom prst="rect">
+            <a:avLst/>
+          </a:prstGeom>
+          <a:solidFill>
+            <a:srgbClr val="F7F8FC"/>
+          </a:solidFill>
+          <a:ln>
+            <a:noFill/>
+          </a:ln>
+          <a:effectLst/>
+        </p:spPr>
+        <p:style>
+          <a:lnRef idx="1">
+            <a:schemeClr val="accent1"/>
+          </a:lnRef>
+          <a:fillRef idx="3">
+            <a:schemeClr val="accent1"/>
+          </a:fillRef>
+          <a:effectRef idx="2">
+            <a:schemeClr val="accent1"/>
+          </a:effectRef>
+          <a:fontRef idx="minor">
+            <a:schemeClr val="lt1"/>
+          </a:fontRef>
+        </p:style>
+        <p:txBody>
+          <a:bodyPr rtlCol="0" anchor="ctr"/>
+          <a:lstStyle/>
+          <a:p>
+            <a:pPr algn="ctr"/>
+          </a:p>
+        </p:txBody>
+      </p:sp>
+      <p:sp>
+        <p:nvSpPr>
+          <p:cNvPr id="7" name="TextBox 6"/>
+          <p:cNvSpPr txBox="1"/>
+          <p:nvPr/>
+        </p:nvSpPr>
+        <p:spPr>
+          <a:xfrm>
+            <a:off x="3566160" y="3108960"/>
+            <a:ext cx="5029200" cy="822960"/>
+          </a:xfrm>
+          <a:prstGeom prst="rect">
+            <a:avLst/>
+          </a:prstGeom>
+          <a:noFill/>
+        </p:spPr>
+        <p:txBody>
+          <a:bodyPr wrap="square" lIns="0" rIns="0" tIns="0" bIns="0">
+            <a:spAutoFit/>
+          </a:bodyPr>
+          <a:lstStyle/>
+          <a:p>
+            <a:pPr algn="ctr">
+              <a:spcAft>
+                <a:spcPts val="600"/>
+              </a:spcAft>
+            </a:pPr>
+            <a:r>
+              <a:rPr sz="1900" b="1">
+                <a:solidFill>
+                  <a:srgbClr val="9E520A"/>
+                </a:solidFill>
+                <a:latin typeface="Inter"/>
+              </a:rPr>
+              <a:t>Sem protótipo</a:t>
+            </a:r>
+          </a:p>
+          <a:p>
+            <a:pPr algn="ctr">
+              <a:spcAft>
+                <a:spcPts val="600"/>
+              </a:spcAft>
+            </a:pPr>
+            <a:r>
+              <a:rPr sz="1900" b="1">
+                <a:solidFill>
+                  <a:srgbClr val="9E520A"/>
+                </a:solidFill>
+                <a:latin typeface="Inter"/>
+              </a:rPr>
+              <a:t>Release 2 — está mapeada</a:t>
+            </a:r>
+          </a:p>
+        </p:txBody>
+      </p:sp>
+      <p:sp>
+        <p:nvSpPr>
+          <p:cNvPr id="8" name="Rectangle 7"/>
           <p:cNvSpPr/>
           <p:nvPr/>
         </p:nvSpPr>
@@ -8338,7 +8635,7 @@
       </p:sp>
       <p:sp>
         <p:nvSpPr>
-          <p:cNvPr id="8" name="Rectangle 7"/>
+          <p:cNvPr id="9" name="Rectangle 8"/>
           <p:cNvSpPr/>
           <p:nvPr/>
         </p:nvSpPr>
@@ -8382,7 +8679,7 @@
       </p:sp>
       <p:sp>
         <p:nvSpPr>
-          <p:cNvPr id="9" name="TextBox 8"/>
+          <p:cNvPr id="10" name="TextBox 9"/>
           <p:cNvSpPr txBox="1"/>
           <p:nvPr/>
         </p:nvSpPr>
@@ -8414,7 +8711,7 @@
                 </a:solidFill>
                 <a:latin typeface="Inter"/>
               </a:rPr>
-              <a:t>Valida ingresso, pagamento e histórico de check-in em agregados distintos, além da janela de entrada.</a:t>
+              <a:t>Vendido − taxa − reembolsos − estornos, liberado após o evento e dividido com o dono do espaço.</a:t>
             </a:r>
           </a:p>
         </p:txBody>
@@ -10381,7 +10678,7 @@
                 </a:solidFill>
                 <a:latin typeface="Inter"/>
               </a:rPr>
-              <a:t>Publicação do evento</a:t>
+              <a:t>Oferta de espaços</a:t>
             </a:r>
           </a:p>
         </p:txBody>
@@ -10420,38 +10717,113 @@
                 </a:solidFill>
                 <a:latin typeface="Inter"/>
               </a:rPr>
-              <a:t>VV</a:t>
-            </a:r>
-          </a:p>
-        </p:txBody>
-      </p:sp>
-      <p:pic>
-        <p:nvPicPr>
-          <p:cNvPr id="6" name="Picture 5" descr="criacao-de-evento.png"/>
-          <p:cNvPicPr>
-            <a:picLocks noChangeAspect="1"/>
-          </p:cNvPicPr>
-          <p:nvPr/>
-        </p:nvPicPr>
-        <p:blipFill>
-          <a:blip r:embed="rId2"/>
-          <a:stretch>
-            <a:fillRect/>
-          </a:stretch>
-        </p:blipFill>
-        <p:spPr>
-          <a:xfrm>
-            <a:off x="3164974" y="1005840"/>
-            <a:ext cx="5831570" cy="4892040"/>
-          </a:xfrm>
-          <a:prstGeom prst="rect">
-            <a:avLst/>
-          </a:prstGeom>
-        </p:spPr>
-      </p:pic>
-      <p:sp>
-        <p:nvSpPr>
-          <p:cNvPr id="7" name="Rectangle 6"/>
+              <a:t>Alta</a:t>
+            </a:r>
+          </a:p>
+        </p:txBody>
+      </p:sp>
+      <p:sp>
+        <p:nvSpPr>
+          <p:cNvPr id="6" name="Rectangle 5"/>
+          <p:cNvSpPr/>
+          <p:nvPr/>
+        </p:nvSpPr>
+        <p:spPr>
+          <a:xfrm>
+            <a:off x="3200400" y="1737360"/>
+            <a:ext cx="5760720" cy="3383280"/>
+          </a:xfrm>
+          <a:prstGeom prst="rect">
+            <a:avLst/>
+          </a:prstGeom>
+          <a:solidFill>
+            <a:srgbClr val="F7F8FC"/>
+          </a:solidFill>
+          <a:ln>
+            <a:noFill/>
+          </a:ln>
+          <a:effectLst/>
+        </p:spPr>
+        <p:style>
+          <a:lnRef idx="1">
+            <a:schemeClr val="accent1"/>
+          </a:lnRef>
+          <a:fillRef idx="3">
+            <a:schemeClr val="accent1"/>
+          </a:fillRef>
+          <a:effectRef idx="2">
+            <a:schemeClr val="accent1"/>
+          </a:effectRef>
+          <a:fontRef idx="minor">
+            <a:schemeClr val="lt1"/>
+          </a:fontRef>
+        </p:style>
+        <p:txBody>
+          <a:bodyPr rtlCol="0" anchor="ctr"/>
+          <a:lstStyle/>
+          <a:p>
+            <a:pPr algn="ctr"/>
+          </a:p>
+        </p:txBody>
+      </p:sp>
+      <p:sp>
+        <p:nvSpPr>
+          <p:cNvPr id="7" name="TextBox 6"/>
+          <p:cNvSpPr txBox="1"/>
+          <p:nvPr/>
+        </p:nvSpPr>
+        <p:spPr>
+          <a:xfrm>
+            <a:off x="3566160" y="3108960"/>
+            <a:ext cx="5029200" cy="822960"/>
+          </a:xfrm>
+          <a:prstGeom prst="rect">
+            <a:avLst/>
+          </a:prstGeom>
+          <a:noFill/>
+        </p:spPr>
+        <p:txBody>
+          <a:bodyPr wrap="square" lIns="0" rIns="0" tIns="0" bIns="0">
+            <a:spAutoFit/>
+          </a:bodyPr>
+          <a:lstStyle/>
+          <a:p>
+            <a:pPr algn="ctr">
+              <a:spcAft>
+                <a:spcPts val="600"/>
+              </a:spcAft>
+            </a:pPr>
+            <a:r>
+              <a:rPr sz="1900" b="1">
+                <a:solidFill>
+                  <a:srgbClr val="9E520A"/>
+                </a:solidFill>
+                <a:latin typeface="Inter"/>
+              </a:rPr>
+              <a:t>Sem protótipo</a:t>
+            </a:r>
+          </a:p>
+          <a:p>
+            <a:pPr algn="ctr">
+              <a:spcAft>
+                <a:spcPts val="600"/>
+              </a:spcAft>
+            </a:pPr>
+            <a:r>
+              <a:rPr sz="1900" b="1">
+                <a:solidFill>
+                  <a:srgbClr val="9E520A"/>
+                </a:solidFill>
+                <a:latin typeface="Inter"/>
+              </a:rPr>
+              <a:t>Release 2 — está mapeada</a:t>
+            </a:r>
+          </a:p>
+        </p:txBody>
+      </p:sp>
+      <p:sp>
+        <p:nvSpPr>
+          <p:cNvPr id="8" name="Rectangle 7"/>
           <p:cNvSpPr/>
           <p:nvPr/>
         </p:nvSpPr>
@@ -10495,7 +10867,7 @@
       </p:sp>
       <p:sp>
         <p:nvSpPr>
-          <p:cNvPr id="8" name="Rectangle 7"/>
+          <p:cNvPr id="9" name="Rectangle 8"/>
           <p:cNvSpPr/>
           <p:nvPr/>
         </p:nvSpPr>
@@ -10539,7 +10911,7 @@
       </p:sp>
       <p:sp>
         <p:nvSpPr>
-          <p:cNvPr id="9" name="TextBox 8"/>
+          <p:cNvPr id="10" name="TextBox 9"/>
           <p:cNvSpPr txBox="1"/>
           <p:nvPr/>
         </p:nvSpPr>
@@ -10571,7 +10943,7 @@
                 </a:solidFill>
                 <a:latin typeface="Inter"/>
               </a:rPr>
-              <a:t>Publicar exige somar a capacidade de todos os lotes e validar contra a capacidade do local.</a:t>
+              <a:t>Aceitar proposta valida que a data segue livre; bloquear data consulta as reservas confirmadas.</a:t>
             </a:r>
           </a:p>
         </p:txBody>
@@ -10672,7 +11044,7 @@
                 </a:solidFill>
                 <a:latin typeface="Inter"/>
               </a:rPr>
-              <a:t>01</a:t>
+              <a:t>02</a:t>
             </a:r>
           </a:p>
         </p:txBody>
@@ -10711,7 +11083,7 @@
                 </a:solidFill>
                 <a:latin typeface="Inter"/>
               </a:rPr>
-              <a:t>Configuração dos ingressos</a:t>
+              <a:t>Locação de espaço</a:t>
             </a:r>
           </a:p>
         </p:txBody>
@@ -10750,38 +11122,113 @@
                 </a:solidFill>
                 <a:latin typeface="Inter"/>
               </a:rPr>
-              <a:t>VV</a:t>
-            </a:r>
-          </a:p>
-        </p:txBody>
-      </p:sp>
-      <p:pic>
-        <p:nvPicPr>
-          <p:cNvPr id="6" name="Picture 5" descr="configuracao-de-ingressos.png"/>
-          <p:cNvPicPr>
-            <a:picLocks noChangeAspect="1"/>
-          </p:cNvPicPr>
-          <p:nvPr/>
-        </p:nvPicPr>
-        <p:blipFill>
-          <a:blip r:embed="rId2"/>
-          <a:stretch>
-            <a:fillRect/>
-          </a:stretch>
-        </p:blipFill>
-        <p:spPr>
-          <a:xfrm>
-            <a:off x="3985418" y="1005840"/>
-            <a:ext cx="4190682" cy="4892040"/>
-          </a:xfrm>
-          <a:prstGeom prst="rect">
-            <a:avLst/>
-          </a:prstGeom>
-        </p:spPr>
-      </p:pic>
-      <p:sp>
-        <p:nvSpPr>
-          <p:cNvPr id="7" name="Rectangle 6"/>
+              <a:t>Alta</a:t>
+            </a:r>
+          </a:p>
+        </p:txBody>
+      </p:sp>
+      <p:sp>
+        <p:nvSpPr>
+          <p:cNvPr id="6" name="Rectangle 5"/>
+          <p:cNvSpPr/>
+          <p:nvPr/>
+        </p:nvSpPr>
+        <p:spPr>
+          <a:xfrm>
+            <a:off x="3200400" y="1737360"/>
+            <a:ext cx="5760720" cy="3383280"/>
+          </a:xfrm>
+          <a:prstGeom prst="rect">
+            <a:avLst/>
+          </a:prstGeom>
+          <a:solidFill>
+            <a:srgbClr val="F7F8FC"/>
+          </a:solidFill>
+          <a:ln>
+            <a:noFill/>
+          </a:ln>
+          <a:effectLst/>
+        </p:spPr>
+        <p:style>
+          <a:lnRef idx="1">
+            <a:schemeClr val="accent1"/>
+          </a:lnRef>
+          <a:fillRef idx="3">
+            <a:schemeClr val="accent1"/>
+          </a:fillRef>
+          <a:effectRef idx="2">
+            <a:schemeClr val="accent1"/>
+          </a:effectRef>
+          <a:fontRef idx="minor">
+            <a:schemeClr val="lt1"/>
+          </a:fontRef>
+        </p:style>
+        <p:txBody>
+          <a:bodyPr rtlCol="0" anchor="ctr"/>
+          <a:lstStyle/>
+          <a:p>
+            <a:pPr algn="ctr"/>
+          </a:p>
+        </p:txBody>
+      </p:sp>
+      <p:sp>
+        <p:nvSpPr>
+          <p:cNvPr id="7" name="TextBox 6"/>
+          <p:cNvSpPr txBox="1"/>
+          <p:nvPr/>
+        </p:nvSpPr>
+        <p:spPr>
+          <a:xfrm>
+            <a:off x="3566160" y="3108960"/>
+            <a:ext cx="5029200" cy="822960"/>
+          </a:xfrm>
+          <a:prstGeom prst="rect">
+            <a:avLst/>
+          </a:prstGeom>
+          <a:noFill/>
+        </p:spPr>
+        <p:txBody>
+          <a:bodyPr wrap="square" lIns="0" rIns="0" tIns="0" bIns="0">
+            <a:spAutoFit/>
+          </a:bodyPr>
+          <a:lstStyle/>
+          <a:p>
+            <a:pPr algn="ctr">
+              <a:spcAft>
+                <a:spcPts val="600"/>
+              </a:spcAft>
+            </a:pPr>
+            <a:r>
+              <a:rPr sz="1900" b="1">
+                <a:solidFill>
+                  <a:srgbClr val="9E520A"/>
+                </a:solidFill>
+                <a:latin typeface="Inter"/>
+              </a:rPr>
+              <a:t>Sem protótipo</a:t>
+            </a:r>
+          </a:p>
+          <a:p>
+            <a:pPr algn="ctr">
+              <a:spcAft>
+                <a:spcPts val="600"/>
+              </a:spcAft>
+            </a:pPr>
+            <a:r>
+              <a:rPr sz="1900" b="1">
+                <a:solidFill>
+                  <a:srgbClr val="9E520A"/>
+                </a:solidFill>
+                <a:latin typeface="Inter"/>
+              </a:rPr>
+              <a:t>Release 2 — está mapeada</a:t>
+            </a:r>
+          </a:p>
+        </p:txBody>
+      </p:sp>
+      <p:sp>
+        <p:nvSpPr>
+          <p:cNvPr id="8" name="Rectangle 7"/>
           <p:cNvSpPr/>
           <p:nvPr/>
         </p:nvSpPr>
@@ -10825,7 +11272,7 @@
       </p:sp>
       <p:sp>
         <p:nvSpPr>
-          <p:cNvPr id="8" name="Rectangle 7"/>
+          <p:cNvPr id="9" name="Rectangle 8"/>
           <p:cNvSpPr/>
           <p:nvPr/>
         </p:nvSpPr>
@@ -10869,7 +11316,7 @@
       </p:sp>
       <p:sp>
         <p:nvSpPr>
-          <p:cNvPr id="9" name="TextBox 8"/>
+          <p:cNvPr id="10" name="TextBox 9"/>
           <p:cNvSpPr txBox="1"/>
           <p:nvPr/>
         </p:nvSpPr>
@@ -10901,7 +11348,7 @@
                 </a:solidFill>
                 <a:latin typeface="Inter"/>
               </a:rPr>
-              <a:t>Valida que as vigências dos lotes não se sobrepõem e consulta os já vendidos antes de reduzir a capacidade.</a:t>
+              <a:t>A proposta expira, valida a capacidade contra o público estimado e calcula diária × dias + taxas.</a:t>
             </a:r>
           </a:p>
         </p:txBody>
@@ -11002,7 +11449,7 @@
                 </a:solidFill>
                 <a:latin typeface="Inter"/>
               </a:rPr>
-              <a:t>02</a:t>
+              <a:t>03</a:t>
             </a:r>
           </a:p>
         </p:txBody>
@@ -11041,7 +11488,7 @@
                 </a:solidFill>
                 <a:latin typeface="Inter"/>
               </a:rPr>
-              <a:t>Gestão de cupons de desconto</a:t>
+              <a:t>Publicação e configuração do evento</a:t>
             </a:r>
           </a:p>
         </p:txBody>
@@ -11080,14 +11527,14 @@
                 </a:solidFill>
                 <a:latin typeface="Inter"/>
               </a:rPr>
-              <a:t>VV</a:t>
+              <a:t>Alta</a:t>
             </a:r>
           </a:p>
         </p:txBody>
       </p:sp>
       <p:pic>
         <p:nvPicPr>
-          <p:cNvPr id="6" name="Picture 5" descr="gerenciar-cupons.png"/>
+          <p:cNvPr id="6" name="Picture 5" descr="criacao-de-evento.png"/>
           <p:cNvPicPr>
             <a:picLocks noChangeAspect="1"/>
           </p:cNvPicPr>
@@ -11101,17 +11548,65 @@
         </p:blipFill>
         <p:spPr>
           <a:xfrm>
-            <a:off x="3113389" y="1005840"/>
-            <a:ext cx="5934741" cy="4892040"/>
+            <a:off x="457200" y="1956053"/>
+            <a:ext cx="3566160" cy="2991612"/>
           </a:xfrm>
           <a:prstGeom prst="rect">
             <a:avLst/>
           </a:prstGeom>
         </p:spPr>
       </p:pic>
-      <p:sp>
-        <p:nvSpPr>
-          <p:cNvPr id="7" name="Rectangle 6"/>
+      <p:pic>
+        <p:nvPicPr>
+          <p:cNvPr id="7" name="Picture 6" descr="configuracao-de-ingressos.png"/>
+          <p:cNvPicPr>
+            <a:picLocks noChangeAspect="1"/>
+          </p:cNvPicPr>
+          <p:nvPr/>
+        </p:nvPicPr>
+        <p:blipFill>
+          <a:blip r:embed="rId3"/>
+          <a:stretch>
+            <a:fillRect/>
+          </a:stretch>
+        </p:blipFill>
+        <p:spPr>
+          <a:xfrm>
+            <a:off x="4206240" y="1370361"/>
+            <a:ext cx="3566160" cy="4162996"/>
+          </a:xfrm>
+          <a:prstGeom prst="rect">
+            <a:avLst/>
+          </a:prstGeom>
+        </p:spPr>
+      </p:pic>
+      <p:pic>
+        <p:nvPicPr>
+          <p:cNvPr id="8" name="Picture 7" descr="gerenciar-cupons.png"/>
+          <p:cNvPicPr>
+            <a:picLocks noChangeAspect="1"/>
+          </p:cNvPicPr>
+          <p:nvPr/>
+        </p:nvPicPr>
+        <p:blipFill>
+          <a:blip r:embed="rId4"/>
+          <a:stretch>
+            <a:fillRect/>
+          </a:stretch>
+        </p:blipFill>
+        <p:spPr>
+          <a:xfrm>
+            <a:off x="7955280" y="1982057"/>
+            <a:ext cx="3566160" cy="2939605"/>
+          </a:xfrm>
+          <a:prstGeom prst="rect">
+            <a:avLst/>
+          </a:prstGeom>
+        </p:spPr>
+      </p:pic>
+      <p:sp>
+        <p:nvSpPr>
+          <p:cNvPr id="9" name="Rectangle 8"/>
           <p:cNvSpPr/>
           <p:nvPr/>
         </p:nvSpPr>
@@ -11155,7 +11650,7 @@
       </p:sp>
       <p:sp>
         <p:nvSpPr>
-          <p:cNvPr id="8" name="Rectangle 7"/>
+          <p:cNvPr id="10" name="Rectangle 9"/>
           <p:cNvSpPr/>
           <p:nvPr/>
         </p:nvSpPr>
@@ -11199,7 +11694,7 @@
       </p:sp>
       <p:sp>
         <p:nvSpPr>
-          <p:cNvPr id="9" name="TextBox 8"/>
+          <p:cNvPr id="11" name="TextBox 10"/>
           <p:cNvSpPr txBox="1"/>
           <p:nvPr/>
         </p:nvSpPr>
@@ -11231,7 +11726,7 @@
                 </a:solidFill>
                 <a:latin typeface="Inter"/>
               </a:rPr>
-              <a:t>Valida código único entre cupons ativos e, ao desativar, distingue os pedidos em aberto dos novos.</a:t>
+              <a:t>Soma os lotes e valida contra o espaço; valida vigências sobrepostas; preserva o cupom nos pedidos abertos.</a:t>
             </a:r>
           </a:p>
         </p:txBody>
@@ -11332,7 +11827,7 @@
                 </a:solidFill>
                 <a:latin typeface="Inter"/>
               </a:rPr>
-              <a:t>03</a:t>
+              <a:t>04</a:t>
             </a:r>
           </a:p>
         </p:txBody>
@@ -11371,7 +11866,7 @@
                 </a:solidFill>
                 <a:latin typeface="Inter"/>
               </a:rPr>
-              <a:t>Venda de ingressos — a página do evento</a:t>
+              <a:t>Cortesias e convidados</a:t>
             </a:r>
           </a:p>
         </p:txBody>
@@ -11410,38 +11905,113 @@
                 </a:solidFill>
                 <a:latin typeface="Inter"/>
               </a:rPr>
-              <a:t>LS</a:t>
-            </a:r>
-          </a:p>
-        </p:txBody>
-      </p:sp>
-      <p:pic>
-        <p:nvPicPr>
-          <p:cNvPr id="6" name="Picture 5" descr="detalhe-do-evento.png"/>
-          <p:cNvPicPr>
-            <a:picLocks noChangeAspect="1"/>
-          </p:cNvPicPr>
-          <p:nvPr/>
-        </p:nvPicPr>
-        <p:blipFill>
-          <a:blip r:embed="rId2"/>
-          <a:stretch>
-            <a:fillRect/>
-          </a:stretch>
-        </p:blipFill>
-        <p:spPr>
-          <a:xfrm>
-            <a:off x="4059951" y="1005840"/>
-            <a:ext cx="4041616" cy="4892040"/>
-          </a:xfrm>
-          <a:prstGeom prst="rect">
-            <a:avLst/>
-          </a:prstGeom>
-        </p:spPr>
-      </p:pic>
-      <p:sp>
-        <p:nvSpPr>
-          <p:cNvPr id="7" name="Rectangle 6"/>
+              <a:t>Média</a:t>
+            </a:r>
+          </a:p>
+        </p:txBody>
+      </p:sp>
+      <p:sp>
+        <p:nvSpPr>
+          <p:cNvPr id="6" name="Rectangle 5"/>
+          <p:cNvSpPr/>
+          <p:nvPr/>
+        </p:nvSpPr>
+        <p:spPr>
+          <a:xfrm>
+            <a:off x="3200400" y="1737360"/>
+            <a:ext cx="5760720" cy="3383280"/>
+          </a:xfrm>
+          <a:prstGeom prst="rect">
+            <a:avLst/>
+          </a:prstGeom>
+          <a:solidFill>
+            <a:srgbClr val="F7F8FC"/>
+          </a:solidFill>
+          <a:ln>
+            <a:noFill/>
+          </a:ln>
+          <a:effectLst/>
+        </p:spPr>
+        <p:style>
+          <a:lnRef idx="1">
+            <a:schemeClr val="accent1"/>
+          </a:lnRef>
+          <a:fillRef idx="3">
+            <a:schemeClr val="accent1"/>
+          </a:fillRef>
+          <a:effectRef idx="2">
+            <a:schemeClr val="accent1"/>
+          </a:effectRef>
+          <a:fontRef idx="minor">
+            <a:schemeClr val="lt1"/>
+          </a:fontRef>
+        </p:style>
+        <p:txBody>
+          <a:bodyPr rtlCol="0" anchor="ctr"/>
+          <a:lstStyle/>
+          <a:p>
+            <a:pPr algn="ctr"/>
+          </a:p>
+        </p:txBody>
+      </p:sp>
+      <p:sp>
+        <p:nvSpPr>
+          <p:cNvPr id="7" name="TextBox 6"/>
+          <p:cNvSpPr txBox="1"/>
+          <p:nvPr/>
+        </p:nvSpPr>
+        <p:spPr>
+          <a:xfrm>
+            <a:off x="3566160" y="3108960"/>
+            <a:ext cx="5029200" cy="822960"/>
+          </a:xfrm>
+          <a:prstGeom prst="rect">
+            <a:avLst/>
+          </a:prstGeom>
+          <a:noFill/>
+        </p:spPr>
+        <p:txBody>
+          <a:bodyPr wrap="square" lIns="0" rIns="0" tIns="0" bIns="0">
+            <a:spAutoFit/>
+          </a:bodyPr>
+          <a:lstStyle/>
+          <a:p>
+            <a:pPr algn="ctr">
+              <a:spcAft>
+                <a:spcPts val="600"/>
+              </a:spcAft>
+            </a:pPr>
+            <a:r>
+              <a:rPr sz="1900" b="1">
+                <a:solidFill>
+                  <a:srgbClr val="9E520A"/>
+                </a:solidFill>
+                <a:latin typeface="Inter"/>
+              </a:rPr>
+              <a:t>Sem protótipo</a:t>
+            </a:r>
+          </a:p>
+          <a:p>
+            <a:pPr algn="ctr">
+              <a:spcAft>
+                <a:spcPts val="600"/>
+              </a:spcAft>
+            </a:pPr>
+            <a:r>
+              <a:rPr sz="1900" b="1">
+                <a:solidFill>
+                  <a:srgbClr val="9E520A"/>
+                </a:solidFill>
+                <a:latin typeface="Inter"/>
+              </a:rPr>
+              <a:t>Release 2 — está mapeada</a:t>
+            </a:r>
+          </a:p>
+        </p:txBody>
+      </p:sp>
+      <p:sp>
+        <p:nvSpPr>
+          <p:cNvPr id="8" name="Rectangle 7"/>
           <p:cNvSpPr/>
           <p:nvPr/>
         </p:nvSpPr>
@@ -11485,7 +12055,7 @@
       </p:sp>
       <p:sp>
         <p:nvSpPr>
-          <p:cNvPr id="8" name="Rectangle 7"/>
+          <p:cNvPr id="9" name="Rectangle 8"/>
           <p:cNvSpPr/>
           <p:nvPr/>
         </p:nvSpPr>
@@ -11529,7 +12099,7 @@
       </p:sp>
       <p:sp>
         <p:nvSpPr>
-          <p:cNvPr id="9" name="TextBox 8"/>
+          <p:cNvPr id="10" name="TextBox 9"/>
           <p:cNvSpPr txBox="1"/>
           <p:nvPr/>
         </p:nvSpPr>
@@ -11561,7 +12131,7 @@
                 </a:solidFill>
                 <a:latin typeface="Inter"/>
               </a:rPr>
-              <a:t>O preço exibido vem do lote vigente na data; o Esgotado vem da contagem de vendidos.</a:t>
+              <a:t>Cota própria, nominal e intransferível, e fora do cálculo de receita.</a:t>
             </a:r>
           </a:p>
         </p:txBody>
@@ -11662,7 +12232,7 @@
                 </a:solidFill>
                 <a:latin typeface="Inter"/>
               </a:rPr>
-              <a:t>03</a:t>
+              <a:t>05</a:t>
             </a:r>
           </a:p>
         </p:txBody>
@@ -11701,7 +12271,7 @@
                 </a:solidFill>
                 <a:latin typeface="Inter"/>
               </a:rPr>
-              <a:t>Venda de ingressos — seleção</a:t>
+              <a:t>Relatórios do organizador</a:t>
             </a:r>
           </a:p>
         </p:txBody>
@@ -11740,38 +12310,113 @@
                 </a:solidFill>
                 <a:latin typeface="Inter"/>
               </a:rPr>
-              <a:t>LS</a:t>
-            </a:r>
-          </a:p>
-        </p:txBody>
-      </p:sp>
-      <p:pic>
-        <p:nvPicPr>
-          <p:cNvPr id="6" name="Picture 5" descr="selecao-de-ingressos.png"/>
-          <p:cNvPicPr>
-            <a:picLocks noChangeAspect="1"/>
-          </p:cNvPicPr>
-          <p:nvPr/>
-        </p:nvPicPr>
-        <p:blipFill>
-          <a:blip r:embed="rId2"/>
-          <a:stretch>
-            <a:fillRect/>
-          </a:stretch>
-        </p:blipFill>
-        <p:spPr>
-          <a:xfrm>
-            <a:off x="3316027" y="1005840"/>
-            <a:ext cx="5529464" cy="4892040"/>
-          </a:xfrm>
-          <a:prstGeom prst="rect">
-            <a:avLst/>
-          </a:prstGeom>
-        </p:spPr>
-      </p:pic>
-      <p:sp>
-        <p:nvSpPr>
-          <p:cNvPr id="7" name="Rectangle 6"/>
+              <a:t>Média</a:t>
+            </a:r>
+          </a:p>
+        </p:txBody>
+      </p:sp>
+      <p:sp>
+        <p:nvSpPr>
+          <p:cNvPr id="6" name="Rectangle 5"/>
+          <p:cNvSpPr/>
+          <p:nvPr/>
+        </p:nvSpPr>
+        <p:spPr>
+          <a:xfrm>
+            <a:off x="3200400" y="1737360"/>
+            <a:ext cx="5760720" cy="3383280"/>
+          </a:xfrm>
+          <a:prstGeom prst="rect">
+            <a:avLst/>
+          </a:prstGeom>
+          <a:solidFill>
+            <a:srgbClr val="F7F8FC"/>
+          </a:solidFill>
+          <a:ln>
+            <a:noFill/>
+          </a:ln>
+          <a:effectLst/>
+        </p:spPr>
+        <p:style>
+          <a:lnRef idx="1">
+            <a:schemeClr val="accent1"/>
+          </a:lnRef>
+          <a:fillRef idx="3">
+            <a:schemeClr val="accent1"/>
+          </a:fillRef>
+          <a:effectRef idx="2">
+            <a:schemeClr val="accent1"/>
+          </a:effectRef>
+          <a:fontRef idx="minor">
+            <a:schemeClr val="lt1"/>
+          </a:fontRef>
+        </p:style>
+        <p:txBody>
+          <a:bodyPr rtlCol="0" anchor="ctr"/>
+          <a:lstStyle/>
+          <a:p>
+            <a:pPr algn="ctr"/>
+          </a:p>
+        </p:txBody>
+      </p:sp>
+      <p:sp>
+        <p:nvSpPr>
+          <p:cNvPr id="7" name="TextBox 6"/>
+          <p:cNvSpPr txBox="1"/>
+          <p:nvPr/>
+        </p:nvSpPr>
+        <p:spPr>
+          <a:xfrm>
+            <a:off x="3566160" y="3108960"/>
+            <a:ext cx="5029200" cy="822960"/>
+          </a:xfrm>
+          <a:prstGeom prst="rect">
+            <a:avLst/>
+          </a:prstGeom>
+          <a:noFill/>
+        </p:spPr>
+        <p:txBody>
+          <a:bodyPr wrap="square" lIns="0" rIns="0" tIns="0" bIns="0">
+            <a:spAutoFit/>
+          </a:bodyPr>
+          <a:lstStyle/>
+          <a:p>
+            <a:pPr algn="ctr">
+              <a:spcAft>
+                <a:spcPts val="600"/>
+              </a:spcAft>
+            </a:pPr>
+            <a:r>
+              <a:rPr sz="1900" b="1">
+                <a:solidFill>
+                  <a:srgbClr val="9E520A"/>
+                </a:solidFill>
+                <a:latin typeface="Inter"/>
+              </a:rPr>
+              <a:t>Sem protótipo</a:t>
+            </a:r>
+          </a:p>
+          <a:p>
+            <a:pPr algn="ctr">
+              <a:spcAft>
+                <a:spcPts val="600"/>
+              </a:spcAft>
+            </a:pPr>
+            <a:r>
+              <a:rPr sz="1900" b="1">
+                <a:solidFill>
+                  <a:srgbClr val="9E520A"/>
+                </a:solidFill>
+                <a:latin typeface="Inter"/>
+              </a:rPr>
+              <a:t>Release 2 — está mapeada</a:t>
+            </a:r>
+          </a:p>
+        </p:txBody>
+      </p:sp>
+      <p:sp>
+        <p:nvSpPr>
+          <p:cNvPr id="8" name="Rectangle 7"/>
           <p:cNvSpPr/>
           <p:nvPr/>
         </p:nvSpPr>
@@ -11815,7 +12460,7 @@
       </p:sp>
       <p:sp>
         <p:nvSpPr>
-          <p:cNvPr id="8" name="Rectangle 7"/>
+          <p:cNvPr id="9" name="Rectangle 8"/>
           <p:cNvSpPr/>
           <p:nvPr/>
         </p:nvSpPr>
@@ -11859,7 +12504,7 @@
       </p:sp>
       <p:sp>
         <p:nvSpPr>
-          <p:cNvPr id="9" name="TextBox 8"/>
+          <p:cNvPr id="10" name="TextBox 9"/>
           <p:cNvSpPr txBox="1"/>
           <p:nvPr/>
         </p:nvSpPr>
@@ -11891,7 +12536,7 @@
                 </a:solidFill>
                 <a:latin typeface="Inter"/>
               </a:rPr>
-              <a:t>Consulta o lote vigente e os já vendidos, e calcula o desconto sobre um cupom validado em quatro critérios.</a:t>
+              <a:t>Agrega vendas, presença e receita. Consulta e agregação, sem validação cruzada: média.</a:t>
             </a:r>
           </a:p>
         </p:txBody>

</xml_diff>